<commit_message>
fix: update team name to CyberCore across all slides
</commit_message>
<xml_diff>
--- a/SIH2026_ThreatLens_AI_Official_Submission.pptx
+++ b/SIH2026_ThreatLens_AI_Official_Submission.pptx
@@ -5762,7 +5762,7 @@
                 </a:solidFill>
                 <a:latin typeface="Calibri"/>
               </a:rPr>
-              <a:t>Team Cyber Core (CVR College of Engineering)</a:t>
+              <a:t>CyberCore (CVR College of Engineering)</a:t>
             </a:r>
           </a:p>
           <a:p>
@@ -6474,7 +6474,7 @@
               </a:defRPr>
             </a:pPr>
             <a:r>
-              <a:t>Team Cyber Core</a:t>
+              <a:t>CyberCore</a:t>
             </a:r>
             <a:endParaRPr lang="en-IN" dirty="0"/>
           </a:p>
@@ -6750,7 +6750,7 @@
               </a:defRPr>
             </a:pPr>
             <a:r>
-              <a:t>Team Cyber Core</a:t>
+              <a:t>CyberCore</a:t>
             </a:r>
             <a:endParaRPr lang="en-IN" dirty="0"/>
           </a:p>
@@ -7758,7 +7758,7 @@
               </a:defRPr>
             </a:pPr>
             <a:r>
-              <a:t>Team Cyber Core</a:t>
+              <a:t>CyberCore</a:t>
             </a:r>
             <a:endParaRPr lang="en-IN" dirty="0"/>
           </a:p>
@@ -8278,7 +8278,7 @@
               </a:defRPr>
             </a:pPr>
             <a:r>
-              <a:t>Team Cyber Core</a:t>
+              <a:t>CyberCore</a:t>
             </a:r>
             <a:endParaRPr lang="en-IN" dirty="0"/>
           </a:p>
@@ -8605,7 +8605,7 @@
                 </a:solidFill>
                 <a:latin typeface="Calibri"/>
               </a:rPr>
-              <a:t>Engineered by Team Cyber Core, Department of CSE (Cyber Security), CVR College of Engineering. Built from direct frontline research into the practical pain points of SOC analysts and Indian law enforcement, prioritizing zero-trust data privacy, parsimonious execution, and actionable operational defense over theoretical complexity.</a:t>
+              <a:t>Engineered by Team CyberCore, Department of CSE (Cyber Security), CVR College of Engineering. Built from direct frontline research into the practical pain points of SOC analysts and Indian law enforcement, prioritizing zero-trust data privacy, parsimonious execution, and actionable operational defense over theoretical complexity.</a:t>
             </a:r>
           </a:p>
         </p:txBody>
@@ -8815,7 +8815,7 @@
               </a:defRPr>
             </a:pPr>
             <a:r>
-              <a:t>Team Cyber Core</a:t>
+              <a:t>CyberCore</a:t>
             </a:r>
             <a:endParaRPr lang="en-IN" dirty="0"/>
           </a:p>

</xml_diff>

<commit_message>
fix(ppt): ensure CyberCore oval badge is rendered on top-left of every slide
</commit_message>
<xml_diff>
--- a/SIH2026_ThreatLens_AI_Official_Submission.pptx
+++ b/SIH2026_ThreatLens_AI_Official_Submission.pptx
@@ -5969,6 +5969,61 @@
           </a:prstGeom>
         </p:spPr>
       </p:pic>
+      <p:sp>
+        <p:nvSpPr>
+          <p:cNvPr id="38" name="Oval Team"/>
+          <p:cNvSpPr/>
+          <p:nvPr/>
+        </p:nvSpPr>
+        <p:spPr>
+          <a:xfrm>
+            <a:off x="329184" y="256032"/>
+            <a:ext cx="1252728" cy="804672"/>
+          </a:xfrm>
+          <a:prstGeom prst="ellipse">
+            <a:avLst/>
+          </a:prstGeom>
+          <a:solidFill>
+            <a:srgbClr val="0B2545"/>
+          </a:solidFill>
+          <a:ln w="25400">
+            <a:solidFill>
+              <a:srgbClr val="EA580C"/>
+            </a:solidFill>
+          </a:ln>
+        </p:spPr>
+        <p:style>
+          <a:lnRef idx="1">
+            <a:schemeClr val="accent1"/>
+          </a:lnRef>
+          <a:fillRef idx="3">
+            <a:schemeClr val="accent1"/>
+          </a:fillRef>
+          <a:effectRef idx="2">
+            <a:schemeClr val="accent1"/>
+          </a:effectRef>
+          <a:fontRef idx="minor">
+            <a:schemeClr val="lt1"/>
+          </a:fontRef>
+        </p:style>
+        <p:txBody>
+          <a:bodyPr rtlCol="0" anchor="ctr" wrap="square"/>
+          <a:lstStyle/>
+          <a:p>
+            <a:pPr algn="ctr">
+              <a:defRPr sz="1150" b="1">
+                <a:solidFill>
+                  <a:srgbClr val="FFFFFF"/>
+                </a:solidFill>
+                <a:latin typeface="Arial"/>
+              </a:defRPr>
+            </a:pPr>
+            <a:r>
+              <a:t>CyberCore</a:t>
+            </a:r>
+          </a:p>
+        </p:txBody>
+      </p:sp>
     </p:spTree>
   </p:cSld>
   <p:clrMapOvr>
@@ -6440,12 +6495,20 @@
         </p:nvSpPr>
         <p:spPr>
           <a:xfrm>
-            <a:off x="329773" y="252246"/>
-            <a:ext cx="1251857" cy="807334"/>
+            <a:off x="329184" y="256032"/>
+            <a:ext cx="1252728" cy="804672"/>
           </a:xfrm>
           <a:prstGeom prst="ellipse">
             <a:avLst/>
           </a:prstGeom>
+          <a:solidFill>
+            <a:srgbClr val="0B2545"/>
+          </a:solidFill>
+          <a:ln w="25400">
+            <a:solidFill>
+              <a:srgbClr val="EA580C"/>
+            </a:solidFill>
+          </a:ln>
         </p:spPr>
         <p:style>
           <a:lnRef idx="2">
@@ -6466,7 +6529,7 @@
           <a:lstStyle/>
           <a:p>
             <a:pPr algn="ctr">
-              <a:defRPr sz="1100" b="1">
+              <a:defRPr sz="1150" b="1">
                 <a:solidFill>
                   <a:srgbClr val="FFFFFF"/>
                 </a:solidFill>
@@ -6716,12 +6779,20 @@
         </p:nvSpPr>
         <p:spPr>
           <a:xfrm>
-            <a:off x="329773" y="252246"/>
-            <a:ext cx="1251857" cy="807334"/>
+            <a:off x="329184" y="256032"/>
+            <a:ext cx="1252728" cy="804672"/>
           </a:xfrm>
           <a:prstGeom prst="ellipse">
             <a:avLst/>
           </a:prstGeom>
+          <a:solidFill>
+            <a:srgbClr val="0B2545"/>
+          </a:solidFill>
+          <a:ln w="25400">
+            <a:solidFill>
+              <a:srgbClr val="EA580C"/>
+            </a:solidFill>
+          </a:ln>
         </p:spPr>
         <p:style>
           <a:lnRef idx="2">
@@ -6742,7 +6813,7 @@
           <a:lstStyle/>
           <a:p>
             <a:pPr algn="ctr">
-              <a:defRPr sz="1100" b="1">
+              <a:defRPr sz="1150" b="1">
                 <a:solidFill>
                   <a:srgbClr val="FFFFFF"/>
                 </a:solidFill>
@@ -7724,12 +7795,20 @@
         </p:nvSpPr>
         <p:spPr>
           <a:xfrm>
-            <a:off x="329773" y="252246"/>
-            <a:ext cx="1251857" cy="807334"/>
+            <a:off x="329184" y="256032"/>
+            <a:ext cx="1252728" cy="804672"/>
           </a:xfrm>
           <a:prstGeom prst="ellipse">
             <a:avLst/>
           </a:prstGeom>
+          <a:solidFill>
+            <a:srgbClr val="0B2545"/>
+          </a:solidFill>
+          <a:ln w="25400">
+            <a:solidFill>
+              <a:srgbClr val="EA580C"/>
+            </a:solidFill>
+          </a:ln>
         </p:spPr>
         <p:style>
           <a:lnRef idx="2">
@@ -7750,7 +7829,7 @@
           <a:lstStyle/>
           <a:p>
             <a:pPr algn="ctr">
-              <a:defRPr sz="1100" b="1">
+              <a:defRPr sz="1150" b="1">
                 <a:solidFill>
                   <a:srgbClr val="FFFFFF"/>
                 </a:solidFill>
@@ -8244,12 +8323,20 @@
         </p:nvSpPr>
         <p:spPr>
           <a:xfrm>
-            <a:off x="329773" y="252246"/>
-            <a:ext cx="1251857" cy="807334"/>
+            <a:off x="329184" y="256032"/>
+            <a:ext cx="1252728" cy="804672"/>
           </a:xfrm>
           <a:prstGeom prst="ellipse">
             <a:avLst/>
           </a:prstGeom>
+          <a:solidFill>
+            <a:srgbClr val="0B2545"/>
+          </a:solidFill>
+          <a:ln w="25400">
+            <a:solidFill>
+              <a:srgbClr val="EA580C"/>
+            </a:solidFill>
+          </a:ln>
         </p:spPr>
         <p:style>
           <a:lnRef idx="2">
@@ -8270,7 +8357,7 @@
           <a:lstStyle/>
           <a:p>
             <a:pPr algn="ctr">
-              <a:defRPr sz="1100" b="1">
+              <a:defRPr sz="1150" b="1">
                 <a:solidFill>
                   <a:srgbClr val="FFFFFF"/>
                 </a:solidFill>
@@ -8781,12 +8868,20 @@
         </p:nvSpPr>
         <p:spPr>
           <a:xfrm>
-            <a:off x="329773" y="252246"/>
-            <a:ext cx="1251857" cy="807334"/>
+            <a:off x="329184" y="256032"/>
+            <a:ext cx="1252728" cy="804672"/>
           </a:xfrm>
           <a:prstGeom prst="ellipse">
             <a:avLst/>
           </a:prstGeom>
+          <a:solidFill>
+            <a:srgbClr val="0B2545"/>
+          </a:solidFill>
+          <a:ln w="25400">
+            <a:solidFill>
+              <a:srgbClr val="EA580C"/>
+            </a:solidFill>
+          </a:ln>
         </p:spPr>
         <p:style>
           <a:lnRef idx="2">
@@ -8807,7 +8902,7 @@
           <a:lstStyle/>
           <a:p>
             <a:pPr algn="ctr">
-              <a:defRPr sz="1100" b="1">
+              <a:defRPr sz="1150" b="1">
                 <a:solidFill>
                   <a:srgbClr val="FFFFFF"/>
                 </a:solidFill>

</xml_diff>

<commit_message>
fix(ppt): ensure high-contrast CyberCore oval badge appears on all slides across all decks
</commit_message>
<xml_diff>
--- a/SIH2026_ThreatLens_AI_Official_Submission.pptx
+++ b/SIH2026_ThreatLens_AI_Official_Submission.pptx
@@ -5540,8 +5540,8 @@
         </p:nvSpPr>
         <p:spPr>
           <a:xfrm>
-            <a:off x="1245686" y="648614"/>
-            <a:ext cx="8534400" cy="1752600"/>
+            <a:off x="1920240" y="868680"/>
+            <a:ext cx="7772400" cy="457200"/>
           </a:xfrm>
         </p:spPr>
         <p:txBody>
@@ -5549,7 +5549,7 @@
           <a:lstStyle/>
           <a:p>
             <a:pPr>
-              <a:defRPr sz="1300" b="1">
+              <a:defRPr sz="1200" b="1">
                 <a:solidFill>
                   <a:srgbClr val="EA580C"/>
                 </a:solidFill>
@@ -5581,8 +5581,8 @@
         </p:nvSpPr>
         <p:spPr>
           <a:xfrm>
-            <a:off x="331286" y="-526757"/>
-            <a:ext cx="10363200" cy="2076450"/>
+            <a:off x="1920240" y="0"/>
+            <a:ext cx="7772400" cy="914400"/>
           </a:xfrm>
         </p:spPr>
         <p:txBody>
@@ -5909,7 +5909,7 @@
                 </a:solidFill>
                 <a:latin typeface="Calibri"/>
               </a:rPr>
-              <a:t>Forwarding corporate emails to external cloud sandbox providers violates GDPR and data sovereignty frameworks.</a:t>
+              <a:t>Forwarding corporate emails to external cloud sandbox providers violates GDPR and national data sovereignty frameworks.</a:t>
             </a:r>
           </a:p>
           <a:p>
@@ -5971,24 +5971,24 @@
       </p:pic>
       <p:sp>
         <p:nvSpPr>
-          <p:cNvPr id="38" name="Oval Team"/>
+          <p:cNvPr id="38" name="Oval CyberCore Slide 1"/>
           <p:cNvSpPr/>
           <p:nvPr/>
         </p:nvSpPr>
         <p:spPr>
           <a:xfrm>
-            <a:off x="329184" y="256032"/>
-            <a:ext cx="1252728" cy="804672"/>
+            <a:off x="329184" y="182880"/>
+            <a:ext cx="1417320" cy="841248"/>
           </a:xfrm>
           <a:prstGeom prst="ellipse">
             <a:avLst/>
           </a:prstGeom>
           <a:solidFill>
-            <a:srgbClr val="0B2545"/>
+            <a:srgbClr val="EA580C"/>
           </a:solidFill>
-          <a:ln w="25400">
+          <a:ln w="31750">
             <a:solidFill>
-              <a:srgbClr val="EA580C"/>
+              <a:srgbClr val="0B2545"/>
             </a:solidFill>
           </a:ln>
         </p:spPr>
@@ -6010,15 +6010,14 @@
           <a:bodyPr rtlCol="0" anchor="ctr" wrap="square"/>
           <a:lstStyle/>
           <a:p>
-            <a:pPr algn="ctr">
-              <a:defRPr sz="1150" b="1">
+            <a:pPr algn="ctr"/>
+            <a:r>
+              <a:rPr sz="1300" b="1">
                 <a:solidFill>
                   <a:srgbClr val="FFFFFF"/>
                 </a:solidFill>
                 <a:latin typeface="Arial"/>
-              </a:defRPr>
-            </a:pPr>
-            <a:r>
+              </a:rPr>
               <a:t>CyberCore</a:t>
             </a:r>
           </a:p>
@@ -6119,8 +6118,8 @@
         </p:nvSpPr>
         <p:spPr>
           <a:xfrm>
-            <a:off x="182998" y="0"/>
-            <a:ext cx="10972800" cy="1143000"/>
+            <a:off x="1920240" y="137160"/>
+            <a:ext cx="7680960" cy="914400"/>
           </a:xfrm>
         </p:spPr>
         <p:txBody>
@@ -6128,7 +6127,7 @@
           <a:lstStyle/>
           <a:p>
             <a:pPr eaLnBrk="1" hangingPunct="1">
-              <a:defRPr b="1" sz="1700">
+              <a:defRPr b="1" sz="1600">
                 <a:solidFill>
                   <a:srgbClr val="0B2545"/>
                 </a:solidFill>
@@ -6475,71 +6474,6 @@
                 <a:schemeClr val="bg1"/>
               </a:solidFill>
             </a:endParaRPr>
-          </a:p>
-        </p:txBody>
-      </p:sp>
-      <p:sp>
-        <p:nvSpPr>
-          <p:cNvPr id="10" name="Oval 9" descr="Your startup LOGO">
-            <a:extLst>
-              <a:ext uri="{FF2B5EF4-FFF2-40B4-BE49-F238E27FC236}">
-                <a16:creationId xmlns:a16="http://schemas.microsoft.com/office/drawing/2014/main" id="{5DBCE864-823D-4A13-9607-5DA1F0ED5FB8}"/>
-              </a:ext>
-              <a:ext uri="{C183D7F6-B498-43B3-948B-1728B52AA6E4}">
-                <adec:decorative xmlns:adec="http://schemas.microsoft.com/office/drawing/2017/decorative" xmlns="" val="0"/>
-              </a:ext>
-            </a:extLst>
-          </p:cNvPr>
-          <p:cNvSpPr/>
-          <p:nvPr/>
-        </p:nvSpPr>
-        <p:spPr>
-          <a:xfrm>
-            <a:off x="329184" y="256032"/>
-            <a:ext cx="1252728" cy="804672"/>
-          </a:xfrm>
-          <a:prstGeom prst="ellipse">
-            <a:avLst/>
-          </a:prstGeom>
-          <a:solidFill>
-            <a:srgbClr val="0B2545"/>
-          </a:solidFill>
-          <a:ln w="25400">
-            <a:solidFill>
-              <a:srgbClr val="EA580C"/>
-            </a:solidFill>
-          </a:ln>
-        </p:spPr>
-        <p:style>
-          <a:lnRef idx="2">
-            <a:schemeClr val="accent4"/>
-          </a:lnRef>
-          <a:fillRef idx="1">
-            <a:schemeClr val="lt1"/>
-          </a:fillRef>
-          <a:effectRef idx="0">
-            <a:schemeClr val="accent4"/>
-          </a:effectRef>
-          <a:fontRef idx="minor">
-            <a:schemeClr val="dk1"/>
-          </a:fontRef>
-        </p:style>
-        <p:txBody>
-          <a:bodyPr rtlCol="0" anchor="ctr" wrap="square"/>
-          <a:lstStyle/>
-          <a:p>
-            <a:pPr algn="ctr">
-              <a:defRPr sz="1150" b="1">
-                <a:solidFill>
-                  <a:srgbClr val="FFFFFF"/>
-                </a:solidFill>
-                <a:latin typeface="Arial"/>
-              </a:defRPr>
-            </a:pPr>
-            <a:r>
-              <a:t>CyberCore</a:t>
-            </a:r>
-            <a:endParaRPr lang="en-IN" dirty="0"/>
           </a:p>
         </p:txBody>
       </p:sp>
@@ -6573,6 +6507,60 @@
           </a:prstGeom>
         </p:spPr>
       </p:pic>
+      <p:sp>
+        <p:nvSpPr>
+          <p:cNvPr id="15363" name="Oval CyberCore Slide 2"/>
+          <p:cNvSpPr/>
+          <p:nvPr/>
+        </p:nvSpPr>
+        <p:spPr>
+          <a:xfrm>
+            <a:off x="329184" y="182880"/>
+            <a:ext cx="1417320" cy="841248"/>
+          </a:xfrm>
+          <a:prstGeom prst="ellipse">
+            <a:avLst/>
+          </a:prstGeom>
+          <a:solidFill>
+            <a:srgbClr val="EA580C"/>
+          </a:solidFill>
+          <a:ln w="31750">
+            <a:solidFill>
+              <a:srgbClr val="0B2545"/>
+            </a:solidFill>
+          </a:ln>
+        </p:spPr>
+        <p:style>
+          <a:lnRef idx="1">
+            <a:schemeClr val="accent1"/>
+          </a:lnRef>
+          <a:fillRef idx="3">
+            <a:schemeClr val="accent1"/>
+          </a:fillRef>
+          <a:effectRef idx="2">
+            <a:schemeClr val="accent1"/>
+          </a:effectRef>
+          <a:fontRef idx="minor">
+            <a:schemeClr val="lt1"/>
+          </a:fontRef>
+        </p:style>
+        <p:txBody>
+          <a:bodyPr rtlCol="0" anchor="ctr" wrap="square"/>
+          <a:lstStyle/>
+          <a:p>
+            <a:pPr algn="ctr"/>
+            <a:r>
+              <a:rPr sz="1300" b="1">
+                <a:solidFill>
+                  <a:srgbClr val="FFFFFF"/>
+                </a:solidFill>
+                <a:latin typeface="Arial"/>
+              </a:rPr>
+              <a:t>CyberCore</a:t>
+            </a:r>
+          </a:p>
+        </p:txBody>
+      </p:sp>
     </p:spTree>
   </p:cSld>
   <p:clrMapOvr>
@@ -6672,13 +6660,18 @@
             <p:ph type="title"/>
           </p:nvPr>
         </p:nvSpPr>
-        <p:spPr/>
+        <p:spPr>
+          <a:xfrm>
+            <a:off x="1920240" y="137160"/>
+            <a:ext cx="7680960" cy="914400"/>
+          </a:xfrm>
+        </p:spPr>
         <p:txBody>
           <a:bodyPr/>
           <a:lstStyle/>
           <a:p>
             <a:pPr eaLnBrk="1" hangingPunct="1">
-              <a:defRPr b="1" sz="1700">
+              <a:defRPr b="1" sz="1600">
                 <a:solidFill>
                   <a:srgbClr val="0B2545"/>
                 </a:solidFill>
@@ -6759,71 +6752,6 @@
                 <a:schemeClr val="bg1"/>
               </a:solidFill>
             </a:endParaRPr>
-          </a:p>
-        </p:txBody>
-      </p:sp>
-      <p:sp>
-        <p:nvSpPr>
-          <p:cNvPr id="11" name="Oval 10" descr="Your startup LOGO">
-            <a:extLst>
-              <a:ext uri="{FF2B5EF4-FFF2-40B4-BE49-F238E27FC236}">
-                <a16:creationId xmlns:a16="http://schemas.microsoft.com/office/drawing/2014/main" id="{5DBCE864-823D-4A13-9607-5DA1F0ED5FB8}"/>
-              </a:ext>
-              <a:ext uri="{C183D7F6-B498-43B3-948B-1728B52AA6E4}">
-                <adec:decorative xmlns:adec="http://schemas.microsoft.com/office/drawing/2017/decorative" xmlns="" val="0"/>
-              </a:ext>
-            </a:extLst>
-          </p:cNvPr>
-          <p:cNvSpPr/>
-          <p:nvPr/>
-        </p:nvSpPr>
-        <p:spPr>
-          <a:xfrm>
-            <a:off x="329184" y="256032"/>
-            <a:ext cx="1252728" cy="804672"/>
-          </a:xfrm>
-          <a:prstGeom prst="ellipse">
-            <a:avLst/>
-          </a:prstGeom>
-          <a:solidFill>
-            <a:srgbClr val="0B2545"/>
-          </a:solidFill>
-          <a:ln w="25400">
-            <a:solidFill>
-              <a:srgbClr val="EA580C"/>
-            </a:solidFill>
-          </a:ln>
-        </p:spPr>
-        <p:style>
-          <a:lnRef idx="2">
-            <a:schemeClr val="accent4"/>
-          </a:lnRef>
-          <a:fillRef idx="1">
-            <a:schemeClr val="lt1"/>
-          </a:fillRef>
-          <a:effectRef idx="0">
-            <a:schemeClr val="accent4"/>
-          </a:effectRef>
-          <a:fontRef idx="minor">
-            <a:schemeClr val="dk1"/>
-          </a:fontRef>
-        </p:style>
-        <p:txBody>
-          <a:bodyPr rtlCol="0" anchor="ctr" wrap="square"/>
-          <a:lstStyle/>
-          <a:p>
-            <a:pPr algn="ctr">
-              <a:defRPr sz="1150" b="1">
-                <a:solidFill>
-                  <a:srgbClr val="FFFFFF"/>
-                </a:solidFill>
-                <a:latin typeface="Arial"/>
-              </a:defRPr>
-            </a:pPr>
-            <a:r>
-              <a:t>CyberCore</a:t>
-            </a:r>
-            <a:endParaRPr lang="en-IN" dirty="0"/>
           </a:p>
         </p:txBody>
       </p:sp>
@@ -6859,7 +6787,61 @@
       </p:pic>
       <p:sp>
         <p:nvSpPr>
-          <p:cNvPr id="17410" name="TextBox 17409"/>
+          <p:cNvPr id="17411" name="Oval CyberCore Slide 3"/>
+          <p:cNvSpPr/>
+          <p:nvPr/>
+        </p:nvSpPr>
+        <p:spPr>
+          <a:xfrm>
+            <a:off x="329184" y="182880"/>
+            <a:ext cx="1417320" cy="841248"/>
+          </a:xfrm>
+          <a:prstGeom prst="ellipse">
+            <a:avLst/>
+          </a:prstGeom>
+          <a:solidFill>
+            <a:srgbClr val="EA580C"/>
+          </a:solidFill>
+          <a:ln w="31750">
+            <a:solidFill>
+              <a:srgbClr val="0B2545"/>
+            </a:solidFill>
+          </a:ln>
+        </p:spPr>
+        <p:style>
+          <a:lnRef idx="1">
+            <a:schemeClr val="accent1"/>
+          </a:lnRef>
+          <a:fillRef idx="3">
+            <a:schemeClr val="accent1"/>
+          </a:fillRef>
+          <a:effectRef idx="2">
+            <a:schemeClr val="accent1"/>
+          </a:effectRef>
+          <a:fontRef idx="minor">
+            <a:schemeClr val="lt1"/>
+          </a:fontRef>
+        </p:style>
+        <p:txBody>
+          <a:bodyPr rtlCol="0" anchor="ctr" wrap="square"/>
+          <a:lstStyle/>
+          <a:p>
+            <a:pPr algn="ctr"/>
+            <a:r>
+              <a:rPr sz="1300" b="1">
+                <a:solidFill>
+                  <a:srgbClr val="FFFFFF"/>
+                </a:solidFill>
+                <a:latin typeface="Arial"/>
+              </a:rPr>
+              <a:t>CyberCore</a:t>
+            </a:r>
+          </a:p>
+        </p:txBody>
+      </p:sp>
+      <p:sp>
+        <p:nvSpPr>
+          <p:cNvPr id="17412" name="TextBox 17411"/>
           <p:cNvSpPr txBox="1"/>
           <p:nvPr/>
         </p:nvSpPr>
@@ -7060,7 +7042,7 @@
       </p:sp>
       <p:sp>
         <p:nvSpPr>
-          <p:cNvPr id="17411" name="TextBox 17410"/>
+          <p:cNvPr id="17413" name="TextBox 17412"/>
           <p:cNvSpPr txBox="1"/>
           <p:nvPr/>
         </p:nvSpPr>
@@ -7384,13 +7366,18 @@
             <p:ph type="title"/>
           </p:nvPr>
         </p:nvSpPr>
-        <p:spPr/>
+        <p:spPr>
+          <a:xfrm>
+            <a:off x="1920240" y="137160"/>
+            <a:ext cx="7680960" cy="914400"/>
+          </a:xfrm>
+        </p:spPr>
         <p:txBody>
           <a:bodyPr/>
           <a:lstStyle/>
           <a:p>
             <a:pPr eaLnBrk="1" hangingPunct="1">
-              <a:defRPr b="1" sz="1700">
+              <a:defRPr b="1" sz="1600">
                 <a:solidFill>
                   <a:srgbClr val="0B2545"/>
                 </a:solidFill>
@@ -7778,71 +7765,6 @@
           </a:p>
         </p:txBody>
       </p:sp>
-      <p:sp>
-        <p:nvSpPr>
-          <p:cNvPr id="12" name="Oval 11" descr="Your startup LOGO">
-            <a:extLst>
-              <a:ext uri="{FF2B5EF4-FFF2-40B4-BE49-F238E27FC236}">
-                <a16:creationId xmlns:a16="http://schemas.microsoft.com/office/drawing/2014/main" id="{5DBCE864-823D-4A13-9607-5DA1F0ED5FB8}"/>
-              </a:ext>
-              <a:ext uri="{C183D7F6-B498-43B3-948B-1728B52AA6E4}">
-                <adec:decorative xmlns:adec="http://schemas.microsoft.com/office/drawing/2017/decorative" xmlns="" val="0"/>
-              </a:ext>
-            </a:extLst>
-          </p:cNvPr>
-          <p:cNvSpPr/>
-          <p:nvPr/>
-        </p:nvSpPr>
-        <p:spPr>
-          <a:xfrm>
-            <a:off x="329184" y="256032"/>
-            <a:ext cx="1252728" cy="804672"/>
-          </a:xfrm>
-          <a:prstGeom prst="ellipse">
-            <a:avLst/>
-          </a:prstGeom>
-          <a:solidFill>
-            <a:srgbClr val="0B2545"/>
-          </a:solidFill>
-          <a:ln w="25400">
-            <a:solidFill>
-              <a:srgbClr val="EA580C"/>
-            </a:solidFill>
-          </a:ln>
-        </p:spPr>
-        <p:style>
-          <a:lnRef idx="2">
-            <a:schemeClr val="accent4"/>
-          </a:lnRef>
-          <a:fillRef idx="1">
-            <a:schemeClr val="lt1"/>
-          </a:fillRef>
-          <a:effectRef idx="0">
-            <a:schemeClr val="accent4"/>
-          </a:effectRef>
-          <a:fontRef idx="minor">
-            <a:schemeClr val="dk1"/>
-          </a:fontRef>
-        </p:style>
-        <p:txBody>
-          <a:bodyPr rtlCol="0" anchor="ctr" wrap="square"/>
-          <a:lstStyle/>
-          <a:p>
-            <a:pPr algn="ctr">
-              <a:defRPr sz="1150" b="1">
-                <a:solidFill>
-                  <a:srgbClr val="FFFFFF"/>
-                </a:solidFill>
-                <a:latin typeface="Arial"/>
-              </a:defRPr>
-            </a:pPr>
-            <a:r>
-              <a:t>CyberCore</a:t>
-            </a:r>
-            <a:endParaRPr lang="en-IN" dirty="0"/>
-          </a:p>
-        </p:txBody>
-      </p:sp>
       <p:pic>
         <p:nvPicPr>
           <p:cNvPr id="11" name="Picture 10"/>
@@ -7873,6 +7795,60 @@
           </a:prstGeom>
         </p:spPr>
       </p:pic>
+      <p:sp>
+        <p:nvSpPr>
+          <p:cNvPr id="17411" name="Oval CyberCore Slide 4"/>
+          <p:cNvSpPr/>
+          <p:nvPr/>
+        </p:nvSpPr>
+        <p:spPr>
+          <a:xfrm>
+            <a:off x="329184" y="182880"/>
+            <a:ext cx="1417320" cy="841248"/>
+          </a:xfrm>
+          <a:prstGeom prst="ellipse">
+            <a:avLst/>
+          </a:prstGeom>
+          <a:solidFill>
+            <a:srgbClr val="EA580C"/>
+          </a:solidFill>
+          <a:ln w="31750">
+            <a:solidFill>
+              <a:srgbClr val="0B2545"/>
+            </a:solidFill>
+          </a:ln>
+        </p:spPr>
+        <p:style>
+          <a:lnRef idx="1">
+            <a:schemeClr val="accent1"/>
+          </a:lnRef>
+          <a:fillRef idx="3">
+            <a:schemeClr val="accent1"/>
+          </a:fillRef>
+          <a:effectRef idx="2">
+            <a:schemeClr val="accent1"/>
+          </a:effectRef>
+          <a:fontRef idx="minor">
+            <a:schemeClr val="lt1"/>
+          </a:fontRef>
+        </p:style>
+        <p:txBody>
+          <a:bodyPr rtlCol="0" anchor="ctr" wrap="square"/>
+          <a:lstStyle/>
+          <a:p>
+            <a:pPr algn="ctr"/>
+            <a:r>
+              <a:rPr sz="1300" b="1">
+                <a:solidFill>
+                  <a:srgbClr val="FFFFFF"/>
+                </a:solidFill>
+                <a:latin typeface="Arial"/>
+              </a:rPr>
+              <a:t>CyberCore</a:t>
+            </a:r>
+          </a:p>
+        </p:txBody>
+      </p:sp>
     </p:spTree>
     <p:extLst>
       <p:ext uri="{BB962C8B-B14F-4D97-AF65-F5344CB8AC3E}">
@@ -7992,13 +7968,18 @@
             <p:ph type="title"/>
           </p:nvPr>
         </p:nvSpPr>
-        <p:spPr/>
+        <p:spPr>
+          <a:xfrm>
+            <a:off x="1920240" y="137160"/>
+            <a:ext cx="7680960" cy="914400"/>
+          </a:xfrm>
+        </p:spPr>
         <p:txBody>
           <a:bodyPr/>
           <a:lstStyle/>
           <a:p>
             <a:pPr eaLnBrk="1" hangingPunct="1">
-              <a:defRPr b="1" sz="1700">
+              <a:defRPr b="1" sz="1600">
                 <a:solidFill>
                   <a:srgbClr val="0B2545"/>
                 </a:solidFill>
@@ -8306,71 +8287,6 @@
           </a:p>
         </p:txBody>
       </p:sp>
-      <p:sp>
-        <p:nvSpPr>
-          <p:cNvPr id="12" name="Oval 11" descr="Your startup LOGO">
-            <a:extLst>
-              <a:ext uri="{FF2B5EF4-FFF2-40B4-BE49-F238E27FC236}">
-                <a16:creationId xmlns:a16="http://schemas.microsoft.com/office/drawing/2014/main" id="{5DBCE864-823D-4A13-9607-5DA1F0ED5FB8}"/>
-              </a:ext>
-              <a:ext uri="{C183D7F6-B498-43B3-948B-1728B52AA6E4}">
-                <adec:decorative xmlns:adec="http://schemas.microsoft.com/office/drawing/2017/decorative" xmlns="" val="0"/>
-              </a:ext>
-            </a:extLst>
-          </p:cNvPr>
-          <p:cNvSpPr/>
-          <p:nvPr/>
-        </p:nvSpPr>
-        <p:spPr>
-          <a:xfrm>
-            <a:off x="329184" y="256032"/>
-            <a:ext cx="1252728" cy="804672"/>
-          </a:xfrm>
-          <a:prstGeom prst="ellipse">
-            <a:avLst/>
-          </a:prstGeom>
-          <a:solidFill>
-            <a:srgbClr val="0B2545"/>
-          </a:solidFill>
-          <a:ln w="25400">
-            <a:solidFill>
-              <a:srgbClr val="EA580C"/>
-            </a:solidFill>
-          </a:ln>
-        </p:spPr>
-        <p:style>
-          <a:lnRef idx="2">
-            <a:schemeClr val="accent4"/>
-          </a:lnRef>
-          <a:fillRef idx="1">
-            <a:schemeClr val="lt1"/>
-          </a:fillRef>
-          <a:effectRef idx="0">
-            <a:schemeClr val="accent4"/>
-          </a:effectRef>
-          <a:fontRef idx="minor">
-            <a:schemeClr val="dk1"/>
-          </a:fontRef>
-        </p:style>
-        <p:txBody>
-          <a:bodyPr rtlCol="0" anchor="ctr" wrap="square"/>
-          <a:lstStyle/>
-          <a:p>
-            <a:pPr algn="ctr">
-              <a:defRPr sz="1150" b="1">
-                <a:solidFill>
-                  <a:srgbClr val="FFFFFF"/>
-                </a:solidFill>
-                <a:latin typeface="Arial"/>
-              </a:defRPr>
-            </a:pPr>
-            <a:r>
-              <a:t>CyberCore</a:t>
-            </a:r>
-            <a:endParaRPr lang="en-IN" dirty="0"/>
-          </a:p>
-        </p:txBody>
-      </p:sp>
       <p:pic>
         <p:nvPicPr>
           <p:cNvPr id="11" name="Picture 10"/>
@@ -8401,6 +8317,60 @@
           </a:prstGeom>
         </p:spPr>
       </p:pic>
+      <p:sp>
+        <p:nvSpPr>
+          <p:cNvPr id="17411" name="Oval CyberCore Slide 5"/>
+          <p:cNvSpPr/>
+          <p:nvPr/>
+        </p:nvSpPr>
+        <p:spPr>
+          <a:xfrm>
+            <a:off x="329184" y="182880"/>
+            <a:ext cx="1417320" cy="841248"/>
+          </a:xfrm>
+          <a:prstGeom prst="ellipse">
+            <a:avLst/>
+          </a:prstGeom>
+          <a:solidFill>
+            <a:srgbClr val="EA580C"/>
+          </a:solidFill>
+          <a:ln w="31750">
+            <a:solidFill>
+              <a:srgbClr val="0B2545"/>
+            </a:solidFill>
+          </a:ln>
+        </p:spPr>
+        <p:style>
+          <a:lnRef idx="1">
+            <a:schemeClr val="accent1"/>
+          </a:lnRef>
+          <a:fillRef idx="3">
+            <a:schemeClr val="accent1"/>
+          </a:fillRef>
+          <a:effectRef idx="2">
+            <a:schemeClr val="accent1"/>
+          </a:effectRef>
+          <a:fontRef idx="minor">
+            <a:schemeClr val="lt1"/>
+          </a:fontRef>
+        </p:style>
+        <p:txBody>
+          <a:bodyPr rtlCol="0" anchor="ctr" wrap="square"/>
+          <a:lstStyle/>
+          <a:p>
+            <a:pPr algn="ctr"/>
+            <a:r>
+              <a:rPr sz="1300" b="1">
+                <a:solidFill>
+                  <a:srgbClr val="FFFFFF"/>
+                </a:solidFill>
+                <a:latin typeface="Arial"/>
+              </a:rPr>
+              <a:t>CyberCore</a:t>
+            </a:r>
+          </a:p>
+        </p:txBody>
+      </p:sp>
     </p:spTree>
     <p:extLst>
       <p:ext uri="{BB962C8B-B14F-4D97-AF65-F5344CB8AC3E}">
@@ -8520,13 +8490,18 @@
             <p:ph type="title"/>
           </p:nvPr>
         </p:nvSpPr>
-        <p:spPr/>
+        <p:spPr>
+          <a:xfrm>
+            <a:off x="1920240" y="137160"/>
+            <a:ext cx="7680960" cy="914400"/>
+          </a:xfrm>
+        </p:spPr>
         <p:txBody>
           <a:bodyPr/>
           <a:lstStyle/>
           <a:p>
             <a:pPr eaLnBrk="1" hangingPunct="1">
-              <a:defRPr b="1" sz="1700">
+              <a:defRPr b="1" sz="1600">
                 <a:solidFill>
                   <a:srgbClr val="0B2545"/>
                 </a:solidFill>
@@ -8851,71 +8826,6 @@
           </a:p>
         </p:txBody>
       </p:sp>
-      <p:sp>
-        <p:nvSpPr>
-          <p:cNvPr id="9" name="Oval 8" descr="Your startup LOGO">
-            <a:extLst>
-              <a:ext uri="{FF2B5EF4-FFF2-40B4-BE49-F238E27FC236}">
-                <a16:creationId xmlns:a16="http://schemas.microsoft.com/office/drawing/2014/main" id="{5DBCE864-823D-4A13-9607-5DA1F0ED5FB8}"/>
-              </a:ext>
-              <a:ext uri="{C183D7F6-B498-43B3-948B-1728B52AA6E4}">
-                <adec:decorative xmlns:adec="http://schemas.microsoft.com/office/drawing/2017/decorative" xmlns="" val="0"/>
-              </a:ext>
-            </a:extLst>
-          </p:cNvPr>
-          <p:cNvSpPr/>
-          <p:nvPr/>
-        </p:nvSpPr>
-        <p:spPr>
-          <a:xfrm>
-            <a:off x="329184" y="256032"/>
-            <a:ext cx="1252728" cy="804672"/>
-          </a:xfrm>
-          <a:prstGeom prst="ellipse">
-            <a:avLst/>
-          </a:prstGeom>
-          <a:solidFill>
-            <a:srgbClr val="0B2545"/>
-          </a:solidFill>
-          <a:ln w="25400">
-            <a:solidFill>
-              <a:srgbClr val="EA580C"/>
-            </a:solidFill>
-          </a:ln>
-        </p:spPr>
-        <p:style>
-          <a:lnRef idx="2">
-            <a:schemeClr val="accent4"/>
-          </a:lnRef>
-          <a:fillRef idx="1">
-            <a:schemeClr val="lt1"/>
-          </a:fillRef>
-          <a:effectRef idx="0">
-            <a:schemeClr val="accent4"/>
-          </a:effectRef>
-          <a:fontRef idx="minor">
-            <a:schemeClr val="dk1"/>
-          </a:fontRef>
-        </p:style>
-        <p:txBody>
-          <a:bodyPr rtlCol="0" anchor="ctr" wrap="square"/>
-          <a:lstStyle/>
-          <a:p>
-            <a:pPr algn="ctr">
-              <a:defRPr sz="1150" b="1">
-                <a:solidFill>
-                  <a:srgbClr val="FFFFFF"/>
-                </a:solidFill>
-                <a:latin typeface="Arial"/>
-              </a:defRPr>
-            </a:pPr>
-            <a:r>
-              <a:t>CyberCore</a:t>
-            </a:r>
-            <a:endParaRPr lang="en-IN" dirty="0"/>
-          </a:p>
-        </p:txBody>
-      </p:sp>
       <p:pic>
         <p:nvPicPr>
           <p:cNvPr id="12" name="Picture 11"/>
@@ -8946,6 +8856,60 @@
           </a:prstGeom>
         </p:spPr>
       </p:pic>
+      <p:sp>
+        <p:nvSpPr>
+          <p:cNvPr id="17411" name="Oval CyberCore Slide 6"/>
+          <p:cNvSpPr/>
+          <p:nvPr/>
+        </p:nvSpPr>
+        <p:spPr>
+          <a:xfrm>
+            <a:off x="329184" y="182880"/>
+            <a:ext cx="1417320" cy="841248"/>
+          </a:xfrm>
+          <a:prstGeom prst="ellipse">
+            <a:avLst/>
+          </a:prstGeom>
+          <a:solidFill>
+            <a:srgbClr val="EA580C"/>
+          </a:solidFill>
+          <a:ln w="31750">
+            <a:solidFill>
+              <a:srgbClr val="0B2545"/>
+            </a:solidFill>
+          </a:ln>
+        </p:spPr>
+        <p:style>
+          <a:lnRef idx="1">
+            <a:schemeClr val="accent1"/>
+          </a:lnRef>
+          <a:fillRef idx="3">
+            <a:schemeClr val="accent1"/>
+          </a:fillRef>
+          <a:effectRef idx="2">
+            <a:schemeClr val="accent1"/>
+          </a:effectRef>
+          <a:fontRef idx="minor">
+            <a:schemeClr val="lt1"/>
+          </a:fontRef>
+        </p:style>
+        <p:txBody>
+          <a:bodyPr rtlCol="0" anchor="ctr" wrap="square"/>
+          <a:lstStyle/>
+          <a:p>
+            <a:pPr algn="ctr"/>
+            <a:r>
+              <a:rPr sz="1300" b="1">
+                <a:solidFill>
+                  <a:srgbClr val="FFFFFF"/>
+                </a:solidFill>
+                <a:latin typeface="Arial"/>
+              </a:rPr>
+              <a:t>CyberCore</a:t>
+            </a:r>
+          </a:p>
+        </p:txBody>
+      </p:sp>
     </p:spTree>
     <p:extLst>
       <p:ext uri="{BB962C8B-B14F-4D97-AF65-F5344CB8AC3E}">

</xml_diff>

<commit_message>
fix(ppt): prevent word-wrap on CyberCore oval badge across all slides
</commit_message>
<xml_diff>
--- a/SIH2026_ThreatLens_AI_Official_Submission.pptx
+++ b/SIH2026_ThreatLens_AI_Official_Submission.pptx
@@ -5540,8 +5540,8 @@
         </p:nvSpPr>
         <p:spPr>
           <a:xfrm>
-            <a:off x="1920240" y="868680"/>
-            <a:ext cx="7772400" cy="457200"/>
+            <a:off x="2148840" y="868680"/>
+            <a:ext cx="7589520" cy="457200"/>
           </a:xfrm>
         </p:spPr>
         <p:txBody>
@@ -5581,8 +5581,8 @@
         </p:nvSpPr>
         <p:spPr>
           <a:xfrm>
-            <a:off x="1920240" y="0"/>
-            <a:ext cx="7772400" cy="914400"/>
+            <a:off x="2148840" y="0"/>
+            <a:ext cx="7589520" cy="914400"/>
           </a:xfrm>
         </p:spPr>
         <p:txBody>
@@ -5978,7 +5978,7 @@
         <p:spPr>
           <a:xfrm>
             <a:off x="329184" y="182880"/>
-            <a:ext cx="1417320" cy="841248"/>
+            <a:ext cx="1691640" cy="777240"/>
           </a:xfrm>
           <a:prstGeom prst="ellipse">
             <a:avLst/>
@@ -6007,12 +6007,12 @@
           </a:fontRef>
         </p:style>
         <p:txBody>
-          <a:bodyPr rtlCol="0" anchor="ctr" wrap="square"/>
+          <a:bodyPr rtlCol="0" anchor="ctr" wrap="none" lIns="36576" rIns="36576" tIns="36576" bIns="36576"/>
           <a:lstStyle/>
           <a:p>
             <a:pPr algn="ctr"/>
             <a:r>
-              <a:rPr sz="1300" b="1">
+              <a:rPr sz="1150" b="1">
                 <a:solidFill>
                   <a:srgbClr val="FFFFFF"/>
                 </a:solidFill>
@@ -6118,8 +6118,8 @@
         </p:nvSpPr>
         <p:spPr>
           <a:xfrm>
-            <a:off x="1920240" y="137160"/>
-            <a:ext cx="7680960" cy="914400"/>
+            <a:off x="2148840" y="137160"/>
+            <a:ext cx="7498079" cy="914400"/>
           </a:xfrm>
         </p:spPr>
         <p:txBody>
@@ -6516,7 +6516,7 @@
         <p:spPr>
           <a:xfrm>
             <a:off x="329184" y="182880"/>
-            <a:ext cx="1417320" cy="841248"/>
+            <a:ext cx="1691640" cy="777240"/>
           </a:xfrm>
           <a:prstGeom prst="ellipse">
             <a:avLst/>
@@ -6545,12 +6545,12 @@
           </a:fontRef>
         </p:style>
         <p:txBody>
-          <a:bodyPr rtlCol="0" anchor="ctr" wrap="square"/>
+          <a:bodyPr rtlCol="0" anchor="ctr" wrap="none" lIns="36576" rIns="36576" tIns="36576" bIns="36576"/>
           <a:lstStyle/>
           <a:p>
             <a:pPr algn="ctr"/>
             <a:r>
-              <a:rPr sz="1300" b="1">
+              <a:rPr sz="1150" b="1">
                 <a:solidFill>
                   <a:srgbClr val="FFFFFF"/>
                 </a:solidFill>
@@ -6662,8 +6662,8 @@
         </p:nvSpPr>
         <p:spPr>
           <a:xfrm>
-            <a:off x="1920240" y="137160"/>
-            <a:ext cx="7680960" cy="914400"/>
+            <a:off x="2148840" y="137160"/>
+            <a:ext cx="7498079" cy="914400"/>
           </a:xfrm>
         </p:spPr>
         <p:txBody>
@@ -6794,7 +6794,7 @@
         <p:spPr>
           <a:xfrm>
             <a:off x="329184" y="182880"/>
-            <a:ext cx="1417320" cy="841248"/>
+            <a:ext cx="1691640" cy="777240"/>
           </a:xfrm>
           <a:prstGeom prst="ellipse">
             <a:avLst/>
@@ -6823,12 +6823,12 @@
           </a:fontRef>
         </p:style>
         <p:txBody>
-          <a:bodyPr rtlCol="0" anchor="ctr" wrap="square"/>
+          <a:bodyPr rtlCol="0" anchor="ctr" wrap="none" lIns="36576" rIns="36576" tIns="36576" bIns="36576"/>
           <a:lstStyle/>
           <a:p>
             <a:pPr algn="ctr"/>
             <a:r>
-              <a:rPr sz="1300" b="1">
+              <a:rPr sz="1150" b="1">
                 <a:solidFill>
                   <a:srgbClr val="FFFFFF"/>
                 </a:solidFill>
@@ -7368,8 +7368,8 @@
         </p:nvSpPr>
         <p:spPr>
           <a:xfrm>
-            <a:off x="1920240" y="137160"/>
-            <a:ext cx="7680960" cy="914400"/>
+            <a:off x="2148840" y="137160"/>
+            <a:ext cx="7498079" cy="914400"/>
           </a:xfrm>
         </p:spPr>
         <p:txBody>
@@ -7804,7 +7804,7 @@
         <p:spPr>
           <a:xfrm>
             <a:off x="329184" y="182880"/>
-            <a:ext cx="1417320" cy="841248"/>
+            <a:ext cx="1691640" cy="777240"/>
           </a:xfrm>
           <a:prstGeom prst="ellipse">
             <a:avLst/>
@@ -7833,12 +7833,12 @@
           </a:fontRef>
         </p:style>
         <p:txBody>
-          <a:bodyPr rtlCol="0" anchor="ctr" wrap="square"/>
+          <a:bodyPr rtlCol="0" anchor="ctr" wrap="none" lIns="36576" rIns="36576" tIns="36576" bIns="36576"/>
           <a:lstStyle/>
           <a:p>
             <a:pPr algn="ctr"/>
             <a:r>
-              <a:rPr sz="1300" b="1">
+              <a:rPr sz="1150" b="1">
                 <a:solidFill>
                   <a:srgbClr val="FFFFFF"/>
                 </a:solidFill>
@@ -7970,8 +7970,8 @@
         </p:nvSpPr>
         <p:spPr>
           <a:xfrm>
-            <a:off x="1920240" y="137160"/>
-            <a:ext cx="7680960" cy="914400"/>
+            <a:off x="2148840" y="137160"/>
+            <a:ext cx="7498079" cy="914400"/>
           </a:xfrm>
         </p:spPr>
         <p:txBody>
@@ -8326,7 +8326,7 @@
         <p:spPr>
           <a:xfrm>
             <a:off x="329184" y="182880"/>
-            <a:ext cx="1417320" cy="841248"/>
+            <a:ext cx="1691640" cy="777240"/>
           </a:xfrm>
           <a:prstGeom prst="ellipse">
             <a:avLst/>
@@ -8355,12 +8355,12 @@
           </a:fontRef>
         </p:style>
         <p:txBody>
-          <a:bodyPr rtlCol="0" anchor="ctr" wrap="square"/>
+          <a:bodyPr rtlCol="0" anchor="ctr" wrap="none" lIns="36576" rIns="36576" tIns="36576" bIns="36576"/>
           <a:lstStyle/>
           <a:p>
             <a:pPr algn="ctr"/>
             <a:r>
-              <a:rPr sz="1300" b="1">
+              <a:rPr sz="1150" b="1">
                 <a:solidFill>
                   <a:srgbClr val="FFFFFF"/>
                 </a:solidFill>
@@ -8492,8 +8492,8 @@
         </p:nvSpPr>
         <p:spPr>
           <a:xfrm>
-            <a:off x="1920240" y="137160"/>
-            <a:ext cx="7680960" cy="914400"/>
+            <a:off x="2148840" y="137160"/>
+            <a:ext cx="7498079" cy="914400"/>
           </a:xfrm>
         </p:spPr>
         <p:txBody>
@@ -8865,7 +8865,7 @@
         <p:spPr>
           <a:xfrm>
             <a:off x="329184" y="182880"/>
-            <a:ext cx="1417320" cy="841248"/>
+            <a:ext cx="1691640" cy="777240"/>
           </a:xfrm>
           <a:prstGeom prst="ellipse">
             <a:avLst/>
@@ -8894,12 +8894,12 @@
           </a:fontRef>
         </p:style>
         <p:txBody>
-          <a:bodyPr rtlCol="0" anchor="ctr" wrap="square"/>
+          <a:bodyPr rtlCol="0" anchor="ctr" wrap="none" lIns="36576" rIns="36576" tIns="36576" bIns="36576"/>
           <a:lstStyle/>
           <a:p>
             <a:pPr algn="ctr"/>
             <a:r>
-              <a:rPr sz="1300" b="1">
+              <a:rPr sz="1150" b="1">
                 <a:solidFill>
                   <a:srgbClr val="FFFFFF"/>
                 </a:solidFill>

</xml_diff>

<commit_message>
feat(ppt): complete anti-AI-slop bento card redesign with official footer
</commit_message>
<xml_diff>
--- a/SIH2026_ThreatLens_AI_Official_Submission.pptx
+++ b/SIH2026_ThreatLens_AI_Official_Submission.pptx
@@ -5530,47 +5530,6 @@
       </p:pic>
       <p:sp>
         <p:nvSpPr>
-          <p:cNvPr id="4" name="Subtitle 3"/>
-          <p:cNvSpPr>
-            <a:spLocks noGrp="1"/>
-          </p:cNvSpPr>
-          <p:nvPr>
-            <p:ph type="subTitle" idx="1"/>
-          </p:nvPr>
-        </p:nvSpPr>
-        <p:spPr>
-          <a:xfrm>
-            <a:off x="2148840" y="868680"/>
-            <a:ext cx="7589520" cy="457200"/>
-          </a:xfrm>
-        </p:spPr>
-        <p:txBody>
-          <a:bodyPr/>
-          <a:lstStyle/>
-          <a:p>
-            <a:pPr>
-              <a:defRPr sz="1200" b="1">
-                <a:solidFill>
-                  <a:srgbClr val="EA580C"/>
-                </a:solidFill>
-                <a:latin typeface="Arial"/>
-              </a:defRPr>
-            </a:pPr>
-            <a:r>
-              <a:t>SMART INDIA HACKATHON 2026 — OFFICIAL IDEA SUBMISSION</a:t>
-            </a:r>
-            <a:endParaRPr lang="en-US" b="1" dirty="0">
-              <a:solidFill>
-                <a:schemeClr val="tx1"/>
-              </a:solidFill>
-              <a:latin typeface="Times New Roman" panose="02020603050405020304" pitchFamily="18" charset="0"/>
-              <a:cs typeface="Times New Roman" panose="02020603050405020304" pitchFamily="18" charset="0"/>
-            </a:endParaRPr>
-          </a:p>
-        </p:txBody>
-      </p:sp>
-      <p:sp>
-        <p:nvSpPr>
           <p:cNvPr id="8" name="Title 7"/>
           <p:cNvSpPr>
             <a:spLocks noGrp="1"/>
@@ -5581,8 +5540,8 @@
         </p:nvSpPr>
         <p:spPr>
           <a:xfrm>
-            <a:off x="2148840" y="0"/>
-            <a:ext cx="7589520" cy="914400"/>
+            <a:off x="2194560" y="137160"/>
+            <a:ext cx="7406640" cy="868680"/>
           </a:xfrm>
         </p:spPr>
         <p:txBody>
@@ -5590,22 +5549,13 @@
           <a:lstStyle/>
           <a:p>
             <a:r>
-              <a:rPr lang="en-US" sz="4000" b="1" dirty="0">
-                <a:solidFill>
-                  <a:schemeClr val="tx2"/>
-                </a:solidFill>
-                <a:latin typeface="Garamond" panose="02020404030301010803" pitchFamily="18" charset="0"/>
-              </a:rPr>
-              <a:t>SMART INDIA HACKATHON </a:t>
-            </a:r>
-            <a:r>
-              <a:rPr lang="en-US" sz="4000" b="1" dirty="0" smtClean="0">
-                <a:solidFill>
-                  <a:schemeClr val="tx2"/>
-                </a:solidFill>
-                <a:latin typeface="Garamond" panose="02020404030301010803" pitchFamily="18" charset="0"/>
-              </a:rPr>
-              <a:t>2026</a:t>
+              <a:rPr sz="2000" b="1">
+                <a:solidFill>
+                  <a:srgbClr val="0B2545"/>
+                </a:solidFill>
+                <a:latin typeface="Arial"/>
+              </a:rPr>
+              <a:t>SMART INDIA HACKATHON 2026</a:t>
             </a:r>
             <a:endParaRPr lang="en-IN" sz="4000" b="1" dirty="0">
               <a:solidFill>
@@ -5614,327 +5564,15 @@
               <a:latin typeface="Garamond" panose="02020404030301010803" pitchFamily="18" charset="0"/>
             </a:endParaRPr>
           </a:p>
-        </p:txBody>
-      </p:sp>
-      <p:sp>
-        <p:nvSpPr>
-          <p:cNvPr id="10" name="TextBox 9"/>
-          <p:cNvSpPr txBox="1"/>
-          <p:nvPr/>
-        </p:nvSpPr>
-        <p:spPr>
-          <a:xfrm>
-            <a:off x="320040" y="1874519"/>
-            <a:ext cx="6217920" cy="4754880"/>
-          </a:xfrm>
-          <a:prstGeom prst="rect">
-            <a:avLst/>
-          </a:prstGeom>
-          <a:noFill/>
-        </p:spPr>
-        <p:txBody>
-          <a:bodyPr wrap="square" rtlCol="0">
-            <a:spAutoFit/>
-          </a:bodyPr>
-          <a:lstStyle/>
-          <a:p>
-            <a:endParaRPr lang="en-US" dirty="0"/>
-          </a:p>
-          <a:p>
-            <a:pPr>
-              <a:spcAft>
-                <a:spcPts val="200"/>
-              </a:spcAft>
-            </a:pPr>
-            <a:r>
-              <a:rPr b="1" sz="1050">
-                <a:solidFill>
-                  <a:srgbClr val="0B2545"/>
+          <a:p>
+            <a:r>
+              <a:rPr sz="900" b="1">
+                <a:solidFill>
+                  <a:srgbClr val="EA580C"/>
                 </a:solidFill>
                 <a:latin typeface="Arial"/>
               </a:rPr>
-              <a:t>Problem Statement ID: </a:t>
-            </a:r>
-            <a:r>
-              <a:rPr b="1" sz="1050">
-                <a:solidFill>
-                  <a:srgbClr val="1E293B"/>
-                </a:solidFill>
-                <a:latin typeface="Calibri"/>
-              </a:rPr>
-              <a:t>SIH26106</a:t>
-            </a:r>
-          </a:p>
-          <a:p>
-            <a:pPr>
-              <a:spcAft>
-                <a:spcPts val="200"/>
-              </a:spcAft>
-            </a:pPr>
-            <a:r>
-              <a:rPr b="1" sz="1050">
-                <a:solidFill>
-                  <a:srgbClr val="0B2545"/>
-                </a:solidFill>
-                <a:latin typeface="Arial"/>
-              </a:rPr>
-              <a:t>Problem Statement Title: </a:t>
-            </a:r>
-            <a:r>
-              <a:rPr b="1" sz="1050">
-                <a:solidFill>
-                  <a:srgbClr val="1E293B"/>
-                </a:solidFill>
-                <a:latin typeface="Calibri"/>
-              </a:rPr>
-              <a:t>AI-Powered Email Threat Detection, Geolocation and Forensic Intelligence</a:t>
-            </a:r>
-          </a:p>
-          <a:p>
-            <a:pPr>
-              <a:spcAft>
-                <a:spcPts val="200"/>
-              </a:spcAft>
-            </a:pPr>
-            <a:r>
-              <a:rPr b="1" sz="1050">
-                <a:solidFill>
-                  <a:srgbClr val="0B2545"/>
-                </a:solidFill>
-                <a:latin typeface="Arial"/>
-              </a:rPr>
-              <a:t>Theme: </a:t>
-            </a:r>
-            <a:r>
-              <a:rPr b="1" sz="1050">
-                <a:solidFill>
-                  <a:srgbClr val="1E293B"/>
-                </a:solidFill>
-                <a:latin typeface="Calibri"/>
-              </a:rPr>
-              <a:t>Cyber Security / Smart Automation</a:t>
-            </a:r>
-          </a:p>
-          <a:p>
-            <a:pPr>
-              <a:spcAft>
-                <a:spcPts val="200"/>
-              </a:spcAft>
-            </a:pPr>
-            <a:r>
-              <a:rPr b="1" sz="1050">
-                <a:solidFill>
-                  <a:srgbClr val="0B2545"/>
-                </a:solidFill>
-                <a:latin typeface="Arial"/>
-              </a:rPr>
-              <a:t>PS Category: </a:t>
-            </a:r>
-            <a:r>
-              <a:rPr b="1" sz="1050">
-                <a:solidFill>
-                  <a:srgbClr val="1E293B"/>
-                </a:solidFill>
-                <a:latin typeface="Calibri"/>
-              </a:rPr>
-              <a:t>Software</a:t>
-            </a:r>
-          </a:p>
-          <a:p>
-            <a:pPr>
-              <a:spcAft>
-                <a:spcPts val="200"/>
-              </a:spcAft>
-            </a:pPr>
-            <a:r>
-              <a:rPr b="1" sz="1050">
-                <a:solidFill>
-                  <a:srgbClr val="0B2545"/>
-                </a:solidFill>
-                <a:latin typeface="Arial"/>
-              </a:rPr>
-              <a:t>Team Name: </a:t>
-            </a:r>
-            <a:r>
-              <a:rPr b="1" sz="1050">
-                <a:solidFill>
-                  <a:srgbClr val="1E293B"/>
-                </a:solidFill>
-                <a:latin typeface="Calibri"/>
-              </a:rPr>
-              <a:t>CyberCore (CVR College of Engineering)</a:t>
-            </a:r>
-          </a:p>
-          <a:p>
-            <a:pPr>
-              <a:spcAft>
-                <a:spcPts val="200"/>
-              </a:spcAft>
-            </a:pPr>
-            <a:r>
-              <a:rPr b="1" sz="1050">
-                <a:solidFill>
-                  <a:srgbClr val="0B2545"/>
-                </a:solidFill>
-                <a:latin typeface="Arial"/>
-              </a:rPr>
-              <a:t>Team ID: </a:t>
-            </a:r>
-            <a:r>
-              <a:rPr b="1" sz="1050">
-                <a:solidFill>
-                  <a:srgbClr val="1E293B"/>
-                </a:solidFill>
-                <a:latin typeface="Calibri"/>
-              </a:rPr>
-              <a:t>[Registered on SIH Portal]</a:t>
-            </a:r>
-          </a:p>
-          <a:p>
-            <a:pPr>
-              <a:spcBef>
-                <a:spcPts val="500"/>
-              </a:spcBef>
-              <a:spcAft>
-                <a:spcPts val="500"/>
-              </a:spcAft>
-            </a:pPr>
-            <a:r>
-              <a:rPr b="1" sz="1100">
-                <a:solidFill>
-                  <a:srgbClr val="16A34A"/>
-                </a:solidFill>
-                <a:latin typeface="Arial"/>
-              </a:rPr>
-              <a:t>★ LIVE WORKING PROTOTYPE: </a:t>
-            </a:r>
-            <a:r>
-              <a:rPr b="1" u="sng" sz="1100">
-                <a:solidFill>
-                  <a:srgbClr val="0B2545"/>
-                </a:solidFill>
-                <a:latin typeface="Arial"/>
-              </a:rPr>
-              <a:t>threatlens-gen.vercel.app</a:t>
-            </a:r>
-          </a:p>
-          <a:p>
-            <a:pPr>
-              <a:spcBef>
-                <a:spcPts val="400"/>
-              </a:spcBef>
-              <a:spcAft>
-                <a:spcPts val="200"/>
-              </a:spcAft>
-            </a:pPr>
-            <a:r>
-              <a:rPr b="1" sz="1050">
-                <a:solidFill>
-                  <a:srgbClr val="EA580C"/>
-                </a:solidFill>
-                <a:latin typeface="Arial"/>
-              </a:rPr>
-              <a:t>PROBLEM ANALYSIS &amp; IDENTIFIED DESIGN GAPS</a:t>
-            </a:r>
-          </a:p>
-          <a:p>
-            <a:pPr>
-              <a:spcAft>
-                <a:spcPts val="200"/>
-              </a:spcAft>
-            </a:pPr>
-            <a:r>
-              <a:rPr b="1" sz="950">
-                <a:solidFill>
-                  <a:srgbClr val="0B2545"/>
-                </a:solidFill>
-                <a:latin typeface="Arial"/>
-              </a:rPr>
-              <a:t>• The Core Vulnerability: </a:t>
-            </a:r>
-            <a:r>
-              <a:rPr sz="950">
-                <a:solidFill>
-                  <a:srgbClr val="1E293B"/>
-                </a:solidFill>
-                <a:latin typeface="Calibri"/>
-              </a:rPr>
-              <a:t>Email is the root initial-access vector in over 91% of enterprise cyber breaches (BEC fraud, spearphishing, credential harvesting).</a:t>
-            </a:r>
-          </a:p>
-          <a:p>
-            <a:pPr>
-              <a:spcAft>
-                <a:spcPts val="200"/>
-              </a:spcAft>
-            </a:pPr>
-            <a:r>
-              <a:rPr b="1" sz="950">
-                <a:solidFill>
-                  <a:srgbClr val="0B2545"/>
-                </a:solidFill>
-                <a:latin typeface="Arial"/>
-              </a:rPr>
-              <a:t>• Existing Gateway Limitations: </a:t>
-            </a:r>
-            <a:r>
-              <a:rPr sz="950">
-                <a:solidFill>
-                  <a:srgbClr val="1E293B"/>
-                </a:solidFill>
-                <a:latin typeface="Calibri"/>
-              </a:rPr>
-              <a:t>Legacy Secure Email Gateways (SEGs) rely on static IP blacklists; blind to zero-day typosquatting and compromised legitimate cloud relays.</a:t>
-            </a:r>
-          </a:p>
-          <a:p>
-            <a:pPr>
-              <a:spcAft>
-                <a:spcPts val="200"/>
-              </a:spcAft>
-            </a:pPr>
-            <a:r>
-              <a:rPr b="1" sz="950">
-                <a:solidFill>
-                  <a:srgbClr val="0B2545"/>
-                </a:solidFill>
-                <a:latin typeface="Arial"/>
-              </a:rPr>
-              <a:t>• Corporate Data Privacy Hazard: </a:t>
-            </a:r>
-            <a:r>
-              <a:rPr sz="950">
-                <a:solidFill>
-                  <a:srgbClr val="1E293B"/>
-                </a:solidFill>
-                <a:latin typeface="Calibri"/>
-              </a:rPr>
-              <a:t>Forwarding corporate emails to external cloud sandbox providers violates GDPR and national data sovereignty frameworks.</a:t>
-            </a:r>
-          </a:p>
-          <a:p>
-            <a:pPr>
-              <a:spcAft>
-                <a:spcPts val="200"/>
-              </a:spcAft>
-            </a:pPr>
-            <a:r>
-              <a:rPr b="1" sz="950">
-                <a:solidFill>
-                  <a:srgbClr val="0B2545"/>
-                </a:solidFill>
-                <a:latin typeface="Arial"/>
-              </a:rPr>
-              <a:t>• Critical Design Gaps: </a:t>
-            </a:r>
-            <a:r>
-              <a:rPr sz="950">
-                <a:solidFill>
-                  <a:srgbClr val="1E293B"/>
-                </a:solidFill>
-                <a:latin typeface="Calibri"/>
-              </a:rPr>
-              <a:t>Absence of a unified cryptographic alignment matrix (SPF, DKIM, DMARC) and lack of spatial attack telemetry for frontline analysts.</a:t>
+              <a:t>OFFICIAL IDEA SUBMISSION  |  CYBER SECURITY &amp; AUTOMATION</a:t>
             </a:r>
           </a:p>
         </p:txBody>
@@ -5977,8 +5615,8 @@
         </p:nvSpPr>
         <p:spPr>
           <a:xfrm>
-            <a:off x="329184" y="182880"/>
-            <a:ext cx="1691640" cy="777240"/>
+            <a:off x="365760" y="164592"/>
+            <a:ext cx="1645920" cy="749808"/>
           </a:xfrm>
           <a:prstGeom prst="ellipse">
             <a:avLst/>
@@ -5986,7 +5624,7 @@
           <a:solidFill>
             <a:srgbClr val="EA580C"/>
           </a:solidFill>
-          <a:ln w="31750">
+          <a:ln w="27940">
             <a:solidFill>
               <a:srgbClr val="0B2545"/>
             </a:solidFill>
@@ -6019,6 +5657,372 @@
                 <a:latin typeface="Arial"/>
               </a:rPr>
               <a:t>CyberCore</a:t>
+            </a:r>
+          </a:p>
+        </p:txBody>
+      </p:sp>
+      <p:sp>
+        <p:nvSpPr>
+          <p:cNvPr id="39" name="Rounded Rectangle 38"/>
+          <p:cNvSpPr/>
+          <p:nvPr/>
+        </p:nvSpPr>
+        <p:spPr>
+          <a:xfrm>
+            <a:off x="365760" y="1234440"/>
+            <a:ext cx="6217920" cy="2331720"/>
+          </a:xfrm>
+          <a:prstGeom prst="roundRect">
+            <a:avLst/>
+          </a:prstGeom>
+          <a:solidFill>
+            <a:srgbClr val="F8FAFC"/>
+          </a:solidFill>
+          <a:ln w="15240">
+            <a:solidFill>
+              <a:srgbClr val="CBD5E1"/>
+            </a:solidFill>
+          </a:ln>
+        </p:spPr>
+        <p:style>
+          <a:lnRef idx="1">
+            <a:schemeClr val="accent1"/>
+          </a:lnRef>
+          <a:fillRef idx="3">
+            <a:schemeClr val="accent1"/>
+          </a:fillRef>
+          <a:effectRef idx="2">
+            <a:schemeClr val="accent1"/>
+          </a:effectRef>
+          <a:fontRef idx="minor">
+            <a:schemeClr val="lt1"/>
+          </a:fontRef>
+        </p:style>
+        <p:txBody>
+          <a:bodyPr rtlCol="0" anchor="ctr" wrap="square" lIns="182880" rIns="182880" tIns="164592" bIns="164592"/>
+          <a:lstStyle/>
+          <a:p>
+            <a:pPr algn="ctr">
+              <a:spcAft>
+                <a:spcPts val="600"/>
+              </a:spcAft>
+            </a:pPr>
+            <a:r>
+              <a:rPr sz="1100" b="1">
+                <a:solidFill>
+                  <a:srgbClr val="EA580C"/>
+                </a:solidFill>
+                <a:latin typeface="Arial"/>
+              </a:rPr>
+              <a:t>OFFICIAL PROJECT DOSSIER</a:t>
+            </a:r>
+          </a:p>
+          <a:p>
+            <a:pPr>
+              <a:spcAft>
+                <a:spcPts val="250"/>
+              </a:spcAft>
+            </a:pPr>
+            <a:r>
+              <a:rPr sz="950" b="1">
+                <a:solidFill>
+                  <a:srgbClr val="0B2545"/>
+                </a:solidFill>
+                <a:latin typeface="Arial"/>
+              </a:rPr>
+              <a:t>Problem Statement ID: </a:t>
+            </a:r>
+            <a:r>
+              <a:rPr sz="950">
+                <a:solidFill>
+                  <a:srgbClr val="1E293B"/>
+                </a:solidFill>
+                <a:latin typeface="Calibri"/>
+              </a:rPr>
+              <a:t>SIH26106</a:t>
+            </a:r>
+          </a:p>
+          <a:p>
+            <a:pPr>
+              <a:spcAft>
+                <a:spcPts val="250"/>
+              </a:spcAft>
+            </a:pPr>
+            <a:r>
+              <a:rPr sz="950" b="1">
+                <a:solidFill>
+                  <a:srgbClr val="0B2545"/>
+                </a:solidFill>
+                <a:latin typeface="Arial"/>
+              </a:rPr>
+              <a:t>Problem Statement Title: </a:t>
+            </a:r>
+            <a:r>
+              <a:rPr sz="950">
+                <a:solidFill>
+                  <a:srgbClr val="1E293B"/>
+                </a:solidFill>
+                <a:latin typeface="Calibri"/>
+              </a:rPr>
+              <a:t>AI-Powered Email Threat Detection, Geolocation &amp; Forensic Intelligence</a:t>
+            </a:r>
+          </a:p>
+          <a:p>
+            <a:pPr>
+              <a:spcAft>
+                <a:spcPts val="250"/>
+              </a:spcAft>
+            </a:pPr>
+            <a:r>
+              <a:rPr sz="950" b="1">
+                <a:solidFill>
+                  <a:srgbClr val="0B2545"/>
+                </a:solidFill>
+                <a:latin typeface="Arial"/>
+              </a:rPr>
+              <a:t>Domain &amp; Category: </a:t>
+            </a:r>
+            <a:r>
+              <a:rPr sz="950">
+                <a:solidFill>
+                  <a:srgbClr val="1E293B"/>
+                </a:solidFill>
+                <a:latin typeface="Calibri"/>
+              </a:rPr>
+              <a:t>Cyber Security / Smart Automation  •  Software</a:t>
+            </a:r>
+          </a:p>
+          <a:p>
+            <a:pPr>
+              <a:spcAft>
+                <a:spcPts val="250"/>
+              </a:spcAft>
+            </a:pPr>
+            <a:r>
+              <a:rPr sz="950" b="1">
+                <a:solidFill>
+                  <a:srgbClr val="0B2545"/>
+                </a:solidFill>
+                <a:latin typeface="Arial"/>
+              </a:rPr>
+              <a:t>Institution &amp; Department: </a:t>
+            </a:r>
+            <a:r>
+              <a:rPr sz="950">
+                <a:solidFill>
+                  <a:srgbClr val="1E293B"/>
+                </a:solidFill>
+                <a:latin typeface="Calibri"/>
+              </a:rPr>
+              <a:t>CVR College of Engineering  •  CSE (Cyber Security)</a:t>
+            </a:r>
+          </a:p>
+          <a:p>
+            <a:pPr>
+              <a:spcAft>
+                <a:spcPts val="250"/>
+              </a:spcAft>
+            </a:pPr>
+            <a:r>
+              <a:rPr sz="950" b="1">
+                <a:solidFill>
+                  <a:srgbClr val="0B2545"/>
+                </a:solidFill>
+                <a:latin typeface="Arial"/>
+              </a:rPr>
+              <a:t>Team Name &amp; ID: </a:t>
+            </a:r>
+            <a:r>
+              <a:rPr sz="950">
+                <a:solidFill>
+                  <a:srgbClr val="1E293B"/>
+                </a:solidFill>
+                <a:latin typeface="Calibri"/>
+              </a:rPr>
+              <a:t>CyberCore  •  [Registered on SIH Portal]</a:t>
+            </a:r>
+          </a:p>
+          <a:p>
+            <a:pPr>
+              <a:spcBef>
+                <a:spcPts val="300"/>
+              </a:spcBef>
+            </a:pPr>
+            <a:r>
+              <a:rPr b="1" sz="1000">
+                <a:solidFill>
+                  <a:srgbClr val="16A34A"/>
+                </a:solidFill>
+                <a:latin typeface="Arial"/>
+              </a:rPr>
+              <a:t>★ LIVE WORKING PROTOTYPE: </a:t>
+            </a:r>
+            <a:r>
+              <a:rPr b="1" u="sng" sz="1000">
+                <a:solidFill>
+                  <a:srgbClr val="0B2545"/>
+                </a:solidFill>
+                <a:latin typeface="Arial"/>
+              </a:rPr>
+              <a:t>threatlens-gen.vercel.app</a:t>
+            </a:r>
+          </a:p>
+        </p:txBody>
+      </p:sp>
+      <p:sp>
+        <p:nvSpPr>
+          <p:cNvPr id="40" name="Rounded Rectangle 39"/>
+          <p:cNvSpPr/>
+          <p:nvPr/>
+        </p:nvSpPr>
+        <p:spPr>
+          <a:xfrm>
+            <a:off x="365760" y="3703320"/>
+            <a:ext cx="6217920" cy="2514600"/>
+          </a:xfrm>
+          <a:prstGeom prst="roundRect">
+            <a:avLst/>
+          </a:prstGeom>
+          <a:solidFill>
+            <a:srgbClr val="F8FAFC"/>
+          </a:solidFill>
+          <a:ln w="15240">
+            <a:solidFill>
+              <a:srgbClr val="CBD5E1"/>
+            </a:solidFill>
+          </a:ln>
+        </p:spPr>
+        <p:style>
+          <a:lnRef idx="1">
+            <a:schemeClr val="accent1"/>
+          </a:lnRef>
+          <a:fillRef idx="3">
+            <a:schemeClr val="accent1"/>
+          </a:fillRef>
+          <a:effectRef idx="2">
+            <a:schemeClr val="accent1"/>
+          </a:effectRef>
+          <a:fontRef idx="minor">
+            <a:schemeClr val="lt1"/>
+          </a:fontRef>
+        </p:style>
+        <p:txBody>
+          <a:bodyPr rtlCol="0" anchor="ctr" wrap="square" lIns="182880" rIns="182880" tIns="164592" bIns="164592"/>
+          <a:lstStyle/>
+          <a:p>
+            <a:pPr algn="ctr">
+              <a:spcAft>
+                <a:spcPts val="600"/>
+              </a:spcAft>
+            </a:pPr>
+            <a:r>
+              <a:rPr sz="1100" b="1">
+                <a:solidFill>
+                  <a:srgbClr val="EA580C"/>
+                </a:solidFill>
+                <a:latin typeface="Arial"/>
+              </a:rPr>
+              <a:t>PROBLEM ANALYSIS &amp; THE GROUND REALITY</a:t>
+            </a:r>
+          </a:p>
+          <a:p>
+            <a:pPr>
+              <a:spcAft>
+                <a:spcPts val="250"/>
+              </a:spcAft>
+            </a:pPr>
+            <a:r>
+              <a:rPr sz="900" b="1">
+                <a:solidFill>
+                  <a:srgbClr val="0B2545"/>
+                </a:solidFill>
+                <a:latin typeface="Arial"/>
+              </a:rPr>
+              <a:t>• 91% Initial Compromise Vector: </a:t>
+            </a:r>
+            <a:r>
+              <a:rPr sz="900">
+                <a:solidFill>
+                  <a:srgbClr val="1E293B"/>
+                </a:solidFill>
+                <a:latin typeface="Calibri"/>
+              </a:rPr>
+              <a:t>Email remains the primary threat vector for Business Email Compromise (BEC), spearphishing, and credential theft across Indian enterprises.</a:t>
+            </a:r>
+          </a:p>
+          <a:p>
+            <a:pPr>
+              <a:spcAft>
+                <a:spcPts val="250"/>
+              </a:spcAft>
+            </a:pPr>
+            <a:r>
+              <a:rPr sz="900" b="1">
+                <a:solidFill>
+                  <a:srgbClr val="0B2545"/>
+                </a:solidFill>
+                <a:latin typeface="Arial"/>
+              </a:rPr>
+              <a:t>• Legacy Gateway Blindspots: </a:t>
+            </a:r>
+            <a:r>
+              <a:rPr sz="900">
+                <a:solidFill>
+                  <a:srgbClr val="1E293B"/>
+                </a:solidFill>
+                <a:latin typeface="Calibri"/>
+              </a:rPr>
+              <a:t>Traditional Secure Email Gateways (SEGs) rely on static IP blacklists—completely blind to zero-day lookalike domains and compromised legitimate cloud relays.</a:t>
+            </a:r>
+          </a:p>
+          <a:p>
+            <a:pPr>
+              <a:spcAft>
+                <a:spcPts val="250"/>
+              </a:spcAft>
+            </a:pPr>
+            <a:r>
+              <a:rPr sz="900" b="1">
+                <a:solidFill>
+                  <a:srgbClr val="0B2545"/>
+                </a:solidFill>
+                <a:latin typeface="Arial"/>
+              </a:rPr>
+              <a:t>• Corporate Privacy Hazard: </a:t>
+            </a:r>
+            <a:r>
+              <a:rPr sz="900">
+                <a:solidFill>
+                  <a:srgbClr val="1E293B"/>
+                </a:solidFill>
+                <a:latin typeface="Calibri"/>
+              </a:rPr>
+              <a:t>Forwarding confidential corporate emails to third-party cloud sandboxes violates GDPR and India's DPDP Act 2023 data sovereignty frameworks.</a:t>
+            </a:r>
+          </a:p>
+          <a:p>
+            <a:pPr>
+              <a:spcAft>
+                <a:spcPts val="250"/>
+              </a:spcAft>
+            </a:pPr>
+            <a:r>
+              <a:rPr sz="900" b="1">
+                <a:solidFill>
+                  <a:srgbClr val="0B2545"/>
+                </a:solidFill>
+                <a:latin typeface="Arial"/>
+              </a:rPr>
+              <a:t>• Frontline Telemetry Void: </a:t>
+            </a:r>
+            <a:r>
+              <a:rPr sz="900">
+                <a:solidFill>
+                  <a:srgbClr val="1E293B"/>
+                </a:solidFill>
+                <a:latin typeface="Calibri"/>
+              </a:rPr>
+              <a:t>Security analysts are overwhelmed by fragmented text logs without unified cryptographic alignment or spatial geolocation telemetry.</a:t>
             </a:r>
           </a:p>
         </p:txBody>
@@ -6118,290 +6122,38 @@
         </p:nvSpPr>
         <p:spPr>
           <a:xfrm>
-            <a:off x="2148840" y="137160"/>
-            <a:ext cx="7498079" cy="914400"/>
+            <a:off x="2194560" y="137160"/>
+            <a:ext cx="7406640" cy="868680"/>
           </a:xfrm>
         </p:spPr>
         <p:txBody>
-          <a:bodyPr/>
+          <a:bodyPr wrap="square"/>
           <a:lstStyle/>
           <a:p>
             <a:pPr eaLnBrk="1" hangingPunct="1">
-              <a:defRPr b="1" sz="1600">
-                <a:solidFill>
-                  <a:srgbClr val="0B2545"/>
-                </a:solidFill>
-                <a:latin typeface="Arial"/>
-              </a:defRPr>
-            </a:pPr>
-            <a:r>
-              <a:t>IDEA TITLE: ThreatLens AI — Zero-Trust Email Forensics &amp; Geolocation Platform</a:t>
-            </a:r>
-          </a:p>
-        </p:txBody>
-      </p:sp>
-      <p:sp>
-        <p:nvSpPr>
-          <p:cNvPr id="15362" name="TextBox 8"/>
-          <p:cNvSpPr txBox="1">
-            <a:spLocks noChangeArrowheads="1"/>
-          </p:cNvSpPr>
-          <p:nvPr/>
-        </p:nvSpPr>
-        <p:spPr bwMode="auto">
-          <a:xfrm>
-            <a:off x="457200" y="1188720"/>
-            <a:ext cx="11247120" cy="5029200"/>
-          </a:xfrm>
-          <a:prstGeom prst="rect">
-            <a:avLst/>
-          </a:prstGeom>
-          <a:noFill/>
-          <a:ln w="9525">
-            <a:noFill/>
-            <a:miter lim="800000"/>
-            <a:headEnd/>
-            <a:tailEnd/>
-          </a:ln>
-        </p:spPr>
-        <p:txBody>
-          <a:bodyPr wrap="square">
-            <a:spAutoFit/>
-          </a:bodyPr>
-          <a:lstStyle/>
-          <a:p>
-            <a:pPr marL="342900" indent="-342900">
-              <a:buFont typeface="Wingdings" panose="05000000000000000000" pitchFamily="2" charset="2"/>
-              <a:buChar char="v"/>
-            </a:pPr>
-            <a:endParaRPr lang="en-US" sz="3200" u="sng" dirty="0">
-              <a:solidFill>
-                <a:schemeClr val="tx2"/>
-              </a:solidFill>
-              <a:latin typeface="Arial" pitchFamily="34" charset="0"/>
-              <a:cs typeface="Arial" pitchFamily="34" charset="0"/>
-            </a:endParaRPr>
-          </a:p>
-          <a:p>
-            <a:pPr>
-              <a:spcAft>
-                <a:spcPts val="600"/>
-              </a:spcAft>
-            </a:pPr>
-            <a:r>
-              <a:rPr b="1" sz="1200">
-                <a:solidFill>
-                  <a:srgbClr val="16A34A"/>
-                </a:solidFill>
-                <a:latin typeface="Arial"/>
-              </a:rPr>
-              <a:t>★ LIVE PRODUCTION WORKSTATION: </a:t>
-            </a:r>
-            <a:r>
-              <a:rPr b="1" u="sng" sz="1200">
-                <a:solidFill>
-                  <a:srgbClr val="0B2545"/>
-                </a:solidFill>
-                <a:latin typeface="Arial"/>
-              </a:rPr>
-              <a:t>https://threatlens-gen.vercel.app</a:t>
-            </a:r>
-            <a:r>
-              <a:rPr sz="1100">
-                <a:solidFill>
-                  <a:srgbClr val="475569"/>
-                </a:solidFill>
-                <a:latin typeface="Calibri"/>
-              </a:rPr>
-              <a:t>  |  Fully Deployed • 64/64 Verified Edge Cases • Open for Evaluator Testing</a:t>
-            </a:r>
-          </a:p>
-          <a:p>
-            <a:pPr>
-              <a:spcBef>
-                <a:spcPts val="500"/>
-              </a:spcBef>
               <a:spcAft>
                 <a:spcPts val="200"/>
               </a:spcAft>
             </a:pPr>
             <a:r>
-              <a:rPr b="1" sz="1100">
+              <a:rPr sz="850" b="1">
                 <a:solidFill>
                   <a:srgbClr val="EA580C"/>
                 </a:solidFill>
                 <a:latin typeface="Arial"/>
               </a:rPr>
-              <a:t>1. Proposed Solution &amp; Architecture Overview</a:t>
-            </a:r>
-          </a:p>
-          <a:p>
-            <a:pPr>
-              <a:spcAft>
-                <a:spcPts val="150"/>
-              </a:spcAft>
-            </a:pPr>
-            <a:r>
-              <a:rPr sz="1000">
-                <a:solidFill>
-                  <a:srgbClr val="1E293B"/>
-                </a:solidFill>
-                <a:latin typeface="Calibri"/>
-              </a:rPr>
-              <a:t>ThreatLens AI is a client-side zero-trust cybersecurity workstation that executes full RFC MIME header disassembly, side-by-side cryptographic verification, and 3D geospatial attack projection to neutralize email cyber threats before credential or monetary loss occurs.</a:t>
-            </a:r>
-          </a:p>
-          <a:p>
-            <a:pPr>
-              <a:spcBef>
-                <a:spcPts val="500"/>
-              </a:spcBef>
-              <a:spcAft>
-                <a:spcPts val="200"/>
-              </a:spcAft>
-            </a:pPr>
-            <a:r>
-              <a:rPr b="1" sz="1100">
-                <a:solidFill>
-                  <a:srgbClr val="EA580C"/>
+              <a:t>ZERO-TRUST EMAIL THREAT FORENSICS &amp; SPATIAL INTELLIGENCE</a:t>
+            </a:r>
+          </a:p>
+          <a:p>
+            <a:r>
+              <a:rPr sz="1700" b="1">
+                <a:solidFill>
+                  <a:srgbClr val="0B2545"/>
                 </a:solidFill>
                 <a:latin typeface="Arial"/>
               </a:rPr>
-              <a:t>2. How It Addresses the Core Problem</a:t>
-            </a:r>
-          </a:p>
-          <a:p>
-            <a:pPr>
-              <a:spcAft>
-                <a:spcPts val="150"/>
-              </a:spcAft>
-            </a:pPr>
-            <a:r>
-              <a:rPr sz="1000">
-                <a:solidFill>
-                  <a:srgbClr val="1E293B"/>
-                </a:solidFill>
-                <a:latin typeface="Calibri"/>
-              </a:rPr>
-              <a:t>• Multi-Identity Header Verification: Simultaneously disassembles Header-From, Envelope-From (Return-Path), and Reply-To, instantly flagging relay mismatches and display-name spoofing.</a:t>
-            </a:r>
-          </a:p>
-          <a:p>
-            <a:pPr>
-              <a:spcAft>
-                <a:spcPts val="150"/>
-              </a:spcAft>
-            </a:pPr>
-            <a:r>
-              <a:rPr sz="1000">
-                <a:solidFill>
-                  <a:srgbClr val="1E293B"/>
-                </a:solidFill>
-                <a:latin typeface="Calibri"/>
-              </a:rPr>
-              <a:t>• Integrated Cryptographic Matrix: Evaluates SPF, DKIM, and DMARC in a single unified dashboard, showing real DNS TXT snippets and diagnostic policy reasons.</a:t>
-            </a:r>
-          </a:p>
-          <a:p>
-            <a:pPr>
-              <a:spcAft>
-                <a:spcPts val="150"/>
-              </a:spcAft>
-            </a:pPr>
-            <a:r>
-              <a:rPr sz="1000">
-                <a:solidFill>
-                  <a:srgbClr val="1E293B"/>
-                </a:solidFill>
-                <a:latin typeface="Calibri"/>
-              </a:rPr>
-              <a:t>• Instant SOC Triage: Replaces fragmented text terminal inspection with audit-ready, court-admissible forensic incident dossiers in one click.</a:t>
-            </a:r>
-          </a:p>
-          <a:p>
-            <a:pPr>
-              <a:spcBef>
-                <a:spcPts val="500"/>
-              </a:spcBef>
-              <a:spcAft>
-                <a:spcPts val="200"/>
-              </a:spcAft>
-            </a:pPr>
-            <a:r>
-              <a:rPr b="1" sz="1100">
-                <a:solidFill>
-                  <a:srgbClr val="EA580C"/>
-                </a:solidFill>
-                <a:latin typeface="Arial"/>
-              </a:rPr>
-              <a:t>3. Architectural Novelty (Replacing Existing Broken Workflows)</a:t>
-            </a:r>
-          </a:p>
-          <a:p>
-            <a:pPr>
-              <a:spcAft>
-                <a:spcPts val="150"/>
-              </a:spcAft>
-            </a:pPr>
-            <a:r>
-              <a:rPr sz="1000">
-                <a:solidFill>
-                  <a:srgbClr val="1E293B"/>
-                </a:solidFill>
-                <a:latin typeface="Calibri"/>
-              </a:rPr>
-              <a:t>• Centralized Cloud Gateways ➔ Client-Side Zero-Trust Sandbox: Legacy tools forward sensitive enterprise emails to third-party cloud servers. ThreatLens performs 100% of header parsing locally in memory—zero email contents ever leak outside the enterprise boundary.</a:t>
-            </a:r>
-          </a:p>
-          <a:p>
-            <a:pPr>
-              <a:spcAft>
-                <a:spcPts val="150"/>
-              </a:spcAft>
-            </a:pPr>
-            <a:r>
-              <a:rPr sz="1000">
-                <a:solidFill>
-                  <a:srgbClr val="1E293B"/>
-                </a:solidFill>
-                <a:latin typeface="Calibri"/>
-              </a:rPr>
-              <a:t>• Static Text Dumps ➔ Interactive 3D Spatial Reconnaissance: Transforms abstract IP hops into dynamic 3D geospatial trajectories, enabling security teams to instantly pinpoint adversary clusters and cross-border attack corridors.</a:t>
-            </a:r>
-          </a:p>
-          <a:p>
-            <a:pPr>
-              <a:spcBef>
-                <a:spcPts val="500"/>
-              </a:spcBef>
-              <a:spcAft>
-                <a:spcPts val="200"/>
-              </a:spcAft>
-            </a:pPr>
-            <a:r>
-              <a:rPr b="1" sz="1100">
-                <a:solidFill>
-                  <a:srgbClr val="EA580C"/>
-                </a:solidFill>
-                <a:latin typeface="Arial"/>
-              </a:rPr>
-              <a:t>4. Innovation and Uniqueness</a:t>
-            </a:r>
-          </a:p>
-          <a:p>
-            <a:pPr>
-              <a:spcAft>
-                <a:spcPts val="150"/>
-              </a:spcAft>
-            </a:pPr>
-            <a:r>
-              <a:rPr sz="1000">
-                <a:solidFill>
-                  <a:srgbClr val="1E293B"/>
-                </a:solidFill>
-                <a:latin typeface="Calibri"/>
-              </a:rPr>
-              <a:t>ThreatLens unifies three historically disconnected disciplines: RFC MIME Forensic Parsers, Cryptographic DNS Alignment Matrices, and 3D Geospatial Threat Visualizers into a cohesive, zero-latency workstation.</a:t>
+              <a:t>IDEA TITLE: ThreatLens AI</a:t>
             </a:r>
           </a:p>
         </p:txBody>
@@ -6458,16 +6210,16 @@
           <a:bodyPr/>
           <a:lstStyle/>
           <a:p>
-            <a:pPr>
-              <a:defRPr/>
-            </a:pPr>
-            <a:r>
-              <a:rPr lang="en-US">
-                <a:solidFill>
-                  <a:schemeClr val="bg1"/>
-                </a:solidFill>
-              </a:rPr>
-              <a:t>@SIH Idea submission- Template</a:t>
+            <a:pPr algn="ctr">
+              <a:defRPr sz="850">
+                <a:solidFill>
+                  <a:srgbClr val="475569"/>
+                </a:solidFill>
+                <a:latin typeface="Calibri"/>
+              </a:defRPr>
+            </a:pPr>
+            <a:r>
+              <a:t>Smart India Hackathon 2026  |  Problem Statement ID: SIH26106  |  Team CyberCore  |  CVR College of Engineering</a:t>
             </a:r>
             <a:endParaRPr lang="en-US" dirty="0">
               <a:solidFill>
@@ -6509,14 +6261,14 @@
       </p:pic>
       <p:sp>
         <p:nvSpPr>
-          <p:cNvPr id="15363" name="Oval CyberCore Slide 2"/>
+          <p:cNvPr id="15362" name="Oval CyberCore Slide 2"/>
           <p:cNvSpPr/>
           <p:nvPr/>
         </p:nvSpPr>
         <p:spPr>
           <a:xfrm>
-            <a:off x="329184" y="182880"/>
-            <a:ext cx="1691640" cy="777240"/>
+            <a:off x="365760" y="164592"/>
+            <a:ext cx="1645920" cy="749808"/>
           </a:xfrm>
           <a:prstGeom prst="ellipse">
             <a:avLst/>
@@ -6524,7 +6276,7 @@
           <a:solidFill>
             <a:srgbClr val="EA580C"/>
           </a:solidFill>
-          <a:ln w="31750">
+          <a:ln w="27940">
             <a:solidFill>
               <a:srgbClr val="0B2545"/>
             </a:solidFill>
@@ -6557,6 +6309,371 @@
                 <a:latin typeface="Arial"/>
               </a:rPr>
               <a:t>CyberCore</a:t>
+            </a:r>
+          </a:p>
+        </p:txBody>
+      </p:sp>
+      <p:sp>
+        <p:nvSpPr>
+          <p:cNvPr id="15363" name="Rounded Rectangle 15362"/>
+          <p:cNvSpPr/>
+          <p:nvPr/>
+        </p:nvSpPr>
+        <p:spPr>
+          <a:xfrm>
+            <a:off x="365760" y="1188720"/>
+            <a:ext cx="5486400" cy="4983480"/>
+          </a:xfrm>
+          <a:prstGeom prst="roundRect">
+            <a:avLst/>
+          </a:prstGeom>
+          <a:solidFill>
+            <a:srgbClr val="F8FAFC"/>
+          </a:solidFill>
+          <a:ln w="15240">
+            <a:solidFill>
+              <a:srgbClr val="CBD5E1"/>
+            </a:solidFill>
+          </a:ln>
+        </p:spPr>
+        <p:style>
+          <a:lnRef idx="1">
+            <a:schemeClr val="accent1"/>
+          </a:lnRef>
+          <a:fillRef idx="3">
+            <a:schemeClr val="accent1"/>
+          </a:fillRef>
+          <a:effectRef idx="2">
+            <a:schemeClr val="accent1"/>
+          </a:effectRef>
+          <a:fontRef idx="minor">
+            <a:schemeClr val="lt1"/>
+          </a:fontRef>
+        </p:style>
+        <p:txBody>
+          <a:bodyPr rtlCol="0" anchor="ctr" wrap="square" lIns="182880" rIns="182880" tIns="164592" bIns="164592"/>
+          <a:lstStyle/>
+          <a:p>
+            <a:pPr algn="ctr">
+              <a:spcAft>
+                <a:spcPts val="600"/>
+              </a:spcAft>
+            </a:pPr>
+            <a:r>
+              <a:rPr sz="1100" b="1">
+                <a:solidFill>
+                  <a:srgbClr val="EA580C"/>
+                </a:solidFill>
+                <a:latin typeface="Arial"/>
+              </a:rPr>
+              <a:t>PROPOSED SOLUTION &amp; WORKFLOW DISRUPTION</a:t>
+            </a:r>
+          </a:p>
+          <a:p>
+            <a:pPr>
+              <a:spcAft>
+                <a:spcPts val="600"/>
+              </a:spcAft>
+            </a:pPr>
+            <a:r>
+              <a:rPr sz="950">
+                <a:solidFill>
+                  <a:srgbClr val="1E293B"/>
+                </a:solidFill>
+                <a:latin typeface="Calibri"/>
+              </a:rPr>
+              <a:t>ThreatLens AI is a client-side zero-trust cybersecurity workstation that executes full RFC MIME header disassembly, unified cryptographic authentication, and 3D geospatial attack projection to neutralize email threats before user credential or monetary loss occurs.</a:t>
+            </a:r>
+          </a:p>
+          <a:p>
+            <a:pPr>
+              <a:spcBef>
+                <a:spcPts val="400"/>
+              </a:spcBef>
+              <a:spcAft>
+                <a:spcPts val="300"/>
+              </a:spcAft>
+            </a:pPr>
+            <a:r>
+              <a:rPr sz="1000" b="1">
+                <a:solidFill>
+                  <a:srgbClr val="0B2545"/>
+                </a:solidFill>
+                <a:latin typeface="Arial"/>
+              </a:rPr>
+              <a:t>ARCHITECTURAL WORKFLOW TRANSFORMATION</a:t>
+            </a:r>
+          </a:p>
+          <a:p>
+            <a:pPr>
+              <a:spcAft>
+                <a:spcPts val="250"/>
+              </a:spcAft>
+            </a:pPr>
+            <a:r>
+              <a:rPr sz="900" b="1">
+                <a:solidFill>
+                  <a:srgbClr val="EA580C"/>
+                </a:solidFill>
+                <a:latin typeface="Arial"/>
+              </a:rPr>
+              <a:t>• Centralized Cloud Sandbox ➔ Client-Side Zero-Trust:
+  </a:t>
+            </a:r>
+            <a:r>
+              <a:rPr sz="900">
+                <a:solidFill>
+                  <a:srgbClr val="1E293B"/>
+                </a:solidFill>
+                <a:latin typeface="Calibri"/>
+              </a:rPr>
+              <a:t>Legacy tools upload sensitive emails to vendor cloud servers. ThreatLens parses 100% of headers locally in browser memory—zero email contents ever leak outside the host boundary.</a:t>
+            </a:r>
+          </a:p>
+          <a:p>
+            <a:pPr>
+              <a:spcAft>
+                <a:spcPts val="250"/>
+              </a:spcAft>
+            </a:pPr>
+            <a:r>
+              <a:rPr sz="900" b="1">
+                <a:solidFill>
+                  <a:srgbClr val="EA580C"/>
+                </a:solidFill>
+                <a:latin typeface="Arial"/>
+              </a:rPr>
+              <a:t>• Fragmented Terminal Commands ➔ Unified Triage Matrix:
+  </a:t>
+            </a:r>
+            <a:r>
+              <a:rPr sz="900">
+                <a:solidFill>
+                  <a:srgbClr val="1E293B"/>
+                </a:solidFill>
+                <a:latin typeface="Calibri"/>
+              </a:rPr>
+              <a:t>Replaces 4–6 isolated text utilities (dig, whois, header decoders) with a single-pane correlation dashboard evaluating Envelope vs. Header authenticity in seconds.</a:t>
+            </a:r>
+          </a:p>
+          <a:p>
+            <a:pPr>
+              <a:spcAft>
+                <a:spcPts val="250"/>
+              </a:spcAft>
+            </a:pPr>
+            <a:r>
+              <a:rPr sz="900" b="1">
+                <a:solidFill>
+                  <a:srgbClr val="EA580C"/>
+                </a:solidFill>
+                <a:latin typeface="Arial"/>
+              </a:rPr>
+              <a:t>• Multi-Identity Spoof Elimination:
+  </a:t>
+            </a:r>
+            <a:r>
+              <a:rPr sz="900">
+                <a:solidFill>
+                  <a:srgbClr val="1E293B"/>
+                </a:solidFill>
+                <a:latin typeface="Calibri"/>
+              </a:rPr>
+              <a:t>Simultaneously disassembles Header-From, Envelope-From (Return-Path), and Reply-To, immediately neutralizing unauthorized cloud relay routing.</a:t>
+            </a:r>
+          </a:p>
+        </p:txBody>
+      </p:sp>
+      <p:sp>
+        <p:nvSpPr>
+          <p:cNvPr id="15364" name="Rounded Rectangle 15363"/>
+          <p:cNvSpPr/>
+          <p:nvPr/>
+        </p:nvSpPr>
+        <p:spPr>
+          <a:xfrm>
+            <a:off x="6035040" y="1188720"/>
+            <a:ext cx="5760720" cy="4983480"/>
+          </a:xfrm>
+          <a:prstGeom prst="roundRect">
+            <a:avLst/>
+          </a:prstGeom>
+          <a:solidFill>
+            <a:srgbClr val="F8FAFC"/>
+          </a:solidFill>
+          <a:ln w="15240">
+            <a:solidFill>
+              <a:srgbClr val="CBD5E1"/>
+            </a:solidFill>
+          </a:ln>
+        </p:spPr>
+        <p:style>
+          <a:lnRef idx="1">
+            <a:schemeClr val="accent1"/>
+          </a:lnRef>
+          <a:fillRef idx="3">
+            <a:schemeClr val="accent1"/>
+          </a:fillRef>
+          <a:effectRef idx="2">
+            <a:schemeClr val="accent1"/>
+          </a:effectRef>
+          <a:fontRef idx="minor">
+            <a:schemeClr val="lt1"/>
+          </a:fontRef>
+        </p:style>
+        <p:txBody>
+          <a:bodyPr rtlCol="0" anchor="ctr" wrap="square" lIns="182880" rIns="182880" tIns="164592" bIns="164592"/>
+          <a:lstStyle/>
+          <a:p>
+            <a:pPr algn="ctr">
+              <a:spcAft>
+                <a:spcPts val="600"/>
+              </a:spcAft>
+            </a:pPr>
+            <a:r>
+              <a:rPr sz="1100" b="1">
+                <a:solidFill>
+                  <a:srgbClr val="EA580C"/>
+                </a:solidFill>
+                <a:latin typeface="Arial"/>
+              </a:rPr>
+              <a:t>INNOVATION &amp; TECHNICAL UNIQUENESS</a:t>
+            </a:r>
+          </a:p>
+          <a:p>
+            <a:pPr>
+              <a:spcAft>
+                <a:spcPts val="600"/>
+              </a:spcAft>
+            </a:pPr>
+            <a:r>
+              <a:rPr sz="1000" b="1">
+                <a:solidFill>
+                  <a:srgbClr val="16A34A"/>
+                </a:solidFill>
+                <a:latin typeface="Arial"/>
+              </a:rPr>
+              <a:t>★ LIVE PRODUCTION WORKSTATION:
+</a:t>
+            </a:r>
+            <a:r>
+              <a:rPr sz="1100" b="1" u="sng">
+                <a:solidFill>
+                  <a:srgbClr val="0B2545"/>
+                </a:solidFill>
+                <a:latin typeface="Arial"/>
+              </a:rPr>
+              <a:t>https://threatlens-gen.vercel.app
+</a:t>
+            </a:r>
+            <a:r>
+              <a:rPr sz="850">
+                <a:solidFill>
+                  <a:srgbClr val="475569"/>
+                </a:solidFill>
+                <a:latin typeface="Calibri"/>
+              </a:rPr>
+              <a:t>Fully Deployed • 64/64 Verified Test Cases • Open for Evaluator Testing</a:t>
+            </a:r>
+          </a:p>
+          <a:p>
+            <a:pPr>
+              <a:spcAft>
+                <a:spcPts val="300"/>
+              </a:spcAft>
+            </a:pPr>
+            <a:r>
+              <a:rPr sz="900" b="1">
+                <a:solidFill>
+                  <a:srgbClr val="0B2545"/>
+                </a:solidFill>
+                <a:latin typeface="Arial"/>
+              </a:rPr>
+              <a:t>• Unified Cryptographic Alignment: </a:t>
+            </a:r>
+            <a:r>
+              <a:rPr sz="900">
+                <a:solidFill>
+                  <a:srgbClr val="1E293B"/>
+                </a:solidFill>
+                <a:latin typeface="Calibri"/>
+              </a:rPr>
+              <a:t>Evaluates SPF, DKIM, and DMARC side-by-side on a single screen with real DNS TXT snippets, alignment statuses, and plain-language diagnostic explanations.</a:t>
+            </a:r>
+          </a:p>
+          <a:p>
+            <a:pPr>
+              <a:spcAft>
+                <a:spcPts val="300"/>
+              </a:spcAft>
+            </a:pPr>
+            <a:r>
+              <a:rPr sz="900" b="1">
+                <a:solidFill>
+                  <a:srgbClr val="0B2545"/>
+                </a:solidFill>
+                <a:latin typeface="Arial"/>
+              </a:rPr>
+              <a:t>• 3D Geospatial Threat Telemetry: </a:t>
+            </a:r>
+            <a:r>
+              <a:rPr sz="900">
+                <a:solidFill>
+                  <a:srgbClr val="1E293B"/>
+                </a:solidFill>
+                <a:latin typeface="Calibri"/>
+              </a:rPr>
+              <a:t>Translates abstract intermediate IP routing hops into interactive 3D geospatial trajectories, empowering SOC teams to identify coordinate-level adversary clusters instantly.</a:t>
+            </a:r>
+          </a:p>
+          <a:p>
+            <a:pPr>
+              <a:spcAft>
+                <a:spcPts val="300"/>
+              </a:spcAft>
+            </a:pPr>
+            <a:r>
+              <a:rPr sz="900" b="1">
+                <a:solidFill>
+                  <a:srgbClr val="0B2545"/>
+                </a:solidFill>
+                <a:latin typeface="Arial"/>
+              </a:rPr>
+              <a:t>• Instant Forensic Dossier Export: </a:t>
+            </a:r>
+            <a:r>
+              <a:rPr sz="900">
+                <a:solidFill>
+                  <a:srgbClr val="1E293B"/>
+                </a:solidFill>
+                <a:latin typeface="Calibri"/>
+              </a:rPr>
+              <a:t>Converts raw RFC headers and extracted artifacts into court-admissible, audit-ready PDF forensic incident reports with a single click.</a:t>
+            </a:r>
+          </a:p>
+          <a:p>
+            <a:pPr>
+              <a:spcAft>
+                <a:spcPts val="300"/>
+              </a:spcAft>
+            </a:pPr>
+            <a:r>
+              <a:rPr sz="900" b="1">
+                <a:solidFill>
+                  <a:srgbClr val="0B2545"/>
+                </a:solidFill>
+                <a:latin typeface="Arial"/>
+              </a:rPr>
+              <a:t>• Three-Discipline Synthesis: </a:t>
+            </a:r>
+            <a:r>
+              <a:rPr sz="900">
+                <a:solidFill>
+                  <a:srgbClr val="1E293B"/>
+                </a:solidFill>
+                <a:latin typeface="Calibri"/>
+              </a:rPr>
+              <a:t>Unifies RFC MIME Forensic Parsers, Cryptographic DNS Alignment Matrices, and 3D Geospatial Threat Visualizers into a cohesive, zero-latency workstation.</a:t>
             </a:r>
           </a:p>
         </p:txBody>
@@ -6662,24 +6779,38 @@
         </p:nvSpPr>
         <p:spPr>
           <a:xfrm>
-            <a:off x="2148840" y="137160"/>
-            <a:ext cx="7498079" cy="914400"/>
+            <a:off x="2194560" y="137160"/>
+            <a:ext cx="7406640" cy="868680"/>
           </a:xfrm>
         </p:spPr>
         <p:txBody>
-          <a:bodyPr/>
+          <a:bodyPr wrap="square"/>
           <a:lstStyle/>
           <a:p>
             <a:pPr eaLnBrk="1" hangingPunct="1">
-              <a:defRPr b="1" sz="1600">
+              <a:spcAft>
+                <a:spcPts val="200"/>
+              </a:spcAft>
+            </a:pPr>
+            <a:r>
+              <a:rPr sz="850" b="1">
+                <a:solidFill>
+                  <a:srgbClr val="EA580C"/>
+                </a:solidFill>
+                <a:latin typeface="Arial"/>
+              </a:rPr>
+              <a:t>IMPLEMENTATION METHODOLOGY &amp; HIERARCHICAL ARCHITECTURE</a:t>
+            </a:r>
+          </a:p>
+          <a:p>
+            <a:r>
+              <a:rPr sz="1700" b="1">
                 <a:solidFill>
                   <a:srgbClr val="0B2545"/>
                 </a:solidFill>
                 <a:latin typeface="Arial"/>
-              </a:defRPr>
-            </a:pPr>
-            <a:r>
-              <a:t>TECHNICAL APPROACH: Layered Architecture &amp; Implementation Pipeline</a:t>
+              </a:rPr>
+              <a:t>TECHNICAL APPROACH</a:t>
             </a:r>
           </a:p>
         </p:txBody>
@@ -6736,16 +6867,16 @@
           <a:bodyPr/>
           <a:lstStyle/>
           <a:p>
-            <a:pPr>
-              <a:defRPr/>
-            </a:pPr>
-            <a:r>
-              <a:rPr lang="en-US">
-                <a:solidFill>
-                  <a:schemeClr val="bg1"/>
-                </a:solidFill>
-              </a:rPr>
-              <a:t>@SIH Idea submission- Template</a:t>
+            <a:pPr algn="ctr">
+              <a:defRPr sz="850">
+                <a:solidFill>
+                  <a:srgbClr val="475569"/>
+                </a:solidFill>
+                <a:latin typeface="Calibri"/>
+              </a:defRPr>
+            </a:pPr>
+            <a:r>
+              <a:t>Smart India Hackathon 2026  |  Problem Statement ID: SIH26106  |  Team CyberCore  |  CVR College of Engineering</a:t>
             </a:r>
             <a:endParaRPr lang="en-US" dirty="0">
               <a:solidFill>
@@ -6787,14 +6918,14 @@
       </p:pic>
       <p:sp>
         <p:nvSpPr>
-          <p:cNvPr id="17411" name="Oval CyberCore Slide 3"/>
+          <p:cNvPr id="17410" name="Oval CyberCore Slide 3"/>
           <p:cNvSpPr/>
           <p:nvPr/>
         </p:nvSpPr>
         <p:spPr>
           <a:xfrm>
-            <a:off x="329184" y="182880"/>
-            <a:ext cx="1691640" cy="777240"/>
+            <a:off x="365760" y="164592"/>
+            <a:ext cx="1645920" cy="749808"/>
           </a:xfrm>
           <a:prstGeom prst="ellipse">
             <a:avLst/>
@@ -6802,7 +6933,7 @@
           <a:solidFill>
             <a:srgbClr val="EA580C"/>
           </a:solidFill>
-          <a:ln w="31750">
+          <a:ln w="27940">
             <a:solidFill>
               <a:srgbClr val="0B2545"/>
             </a:solidFill>
@@ -6841,402 +6972,413 @@
       </p:sp>
       <p:sp>
         <p:nvSpPr>
-          <p:cNvPr id="17412" name="TextBox 17411"/>
-          <p:cNvSpPr txBox="1"/>
+          <p:cNvPr id="17411" name="Rounded Rectangle 17410"/>
+          <p:cNvSpPr/>
           <p:nvPr/>
         </p:nvSpPr>
         <p:spPr>
           <a:xfrm>
-            <a:off x="457200" y="1188720"/>
-            <a:ext cx="5394960" cy="5029200"/>
+            <a:off x="365760" y="1188720"/>
+            <a:ext cx="5440680" cy="4983480"/>
           </a:xfrm>
-          <a:prstGeom prst="rect">
+          <a:prstGeom prst="roundRect">
             <a:avLst/>
           </a:prstGeom>
-          <a:noFill/>
+          <a:solidFill>
+            <a:srgbClr val="F8FAFC"/>
+          </a:solidFill>
+          <a:ln w="15240">
+            <a:solidFill>
+              <a:srgbClr val="CBD5E1"/>
+            </a:solidFill>
+          </a:ln>
         </p:spPr>
-        <p:txBody>
-          <a:bodyPr wrap="square">
-            <a:spAutoFit/>
-          </a:bodyPr>
+        <p:style>
+          <a:lnRef idx="1">
+            <a:schemeClr val="accent1"/>
+          </a:lnRef>
+          <a:fillRef idx="3">
+            <a:schemeClr val="accent1"/>
+          </a:fillRef>
+          <a:effectRef idx="2">
+            <a:schemeClr val="accent1"/>
+          </a:effectRef>
+          <a:fontRef idx="minor">
+            <a:schemeClr val="lt1"/>
+          </a:fontRef>
+        </p:style>
+        <p:txBody>
+          <a:bodyPr rtlCol="0" anchor="ctr" wrap="square" lIns="182880" rIns="182880" tIns="164592" bIns="164592"/>
           <a:lstStyle/>
+          <a:p>
+            <a:pPr algn="ctr">
+              <a:spcAft>
+                <a:spcPts val="600"/>
+              </a:spcAft>
+            </a:pPr>
+            <a:r>
+              <a:rPr sz="1100" b="1">
+                <a:solidFill>
+                  <a:srgbClr val="EA580C"/>
+                </a:solidFill>
+                <a:latin typeface="Arial"/>
+              </a:rPr>
+              <a:t>IMPLEMENTATION PIPELINE &amp; METHODOLOGY</a:t>
+            </a:r>
+          </a:p>
           <a:p>
             <a:pPr>
               <a:spcAft>
-                <a:spcPts val="400"/>
+                <a:spcPts val="250"/>
               </a:spcAft>
             </a:pPr>
             <a:r>
-              <a:rPr b="1" sz="1200">
-                <a:solidFill>
-                  <a:srgbClr val="EA580C"/>
+              <a:rPr sz="950" b="1">
+                <a:solidFill>
+                  <a:srgbClr val="0B2545"/>
                 </a:solidFill>
                 <a:latin typeface="Arial"/>
               </a:rPr>
-              <a:t>METHODOLOGY &amp; WORKFLOW PIPELINE</a:t>
+              <a:t>[Stage 1] Multi-Vector Ingestion
+</a:t>
+            </a:r>
+            <a:r>
+              <a:rPr sz="900">
+                <a:solidFill>
+                  <a:srgbClr val="1E293B"/>
+                </a:solidFill>
+                <a:latin typeface="Calibri"/>
+              </a:rPr>
+              <a:t>Accepts .eml / .msg drag-and-drop, raw RFC 822 pasted headers, and simulated live SOC telemetry feeds.</a:t>
+            </a:r>
+          </a:p>
+          <a:p>
+            <a:pPr>
+              <a:spcAft>
+                <a:spcPts val="250"/>
+              </a:spcAft>
+            </a:pPr>
+            <a:r>
+              <a:rPr sz="950" b="1">
+                <a:solidFill>
+                  <a:srgbClr val="0B2545"/>
+                </a:solidFill>
+                <a:latin typeface="Arial"/>
+              </a:rPr>
+              <a:t>[Stage 2] Recursive MIME Disassembly
+</a:t>
+            </a:r>
+            <a:r>
+              <a:rPr sz="900">
+                <a:solidFill>
+                  <a:srgbClr val="1E293B"/>
+                </a:solidFill>
+                <a:latin typeface="Calibri"/>
+              </a:rPr>
+              <a:t>Traverses MIME tree to extract Header-From, Envelope-From, Return-Path, transit Received: hops, URLs, and attachment SHA-256 hashes.</a:t>
+            </a:r>
+          </a:p>
+          <a:p>
+            <a:pPr>
+              <a:spcAft>
+                <a:spcPts val="250"/>
+              </a:spcAft>
+            </a:pPr>
+            <a:r>
+              <a:rPr sz="950" b="1">
+                <a:solidFill>
+                  <a:srgbClr val="0B2545"/>
+                </a:solidFill>
+                <a:latin typeface="Arial"/>
+              </a:rPr>
+              <a:t>[Stage 3] Cryptographic Matrix Check
+</a:t>
+            </a:r>
+            <a:r>
+              <a:rPr sz="900">
+                <a:solidFill>
+                  <a:srgbClr val="1E293B"/>
+                </a:solidFill>
+                <a:latin typeface="Calibri"/>
+              </a:rPr>
+              <a:t>Simultaneously validates SPF (RFC 7208), DKIM (RFC 6376), and DMARC (RFC 7489) authentication and domain alignment.</a:t>
+            </a:r>
+          </a:p>
+          <a:p>
+            <a:pPr>
+              <a:spcAft>
+                <a:spcPts val="250"/>
+              </a:spcAft>
+            </a:pPr>
+            <a:r>
+              <a:rPr sz="950" b="1">
+                <a:solidFill>
+                  <a:srgbClr val="0B2545"/>
+                </a:solidFill>
+                <a:latin typeface="Arial"/>
+              </a:rPr>
+              <a:t>[Stage 4] Geolocation &amp; Threat Scoring
+</a:t>
+            </a:r>
+            <a:r>
+              <a:rPr sz="900">
+                <a:solidFill>
+                  <a:srgbClr val="1E293B"/>
+                </a:solidFill>
+                <a:latin typeface="Calibri"/>
+              </a:rPr>
+              <a:t>Extracts connecting MTA IP from Received headers; resolves coordinates and maps adversary origin infrastructure to a 0–100 threat score.</a:t>
+            </a:r>
+          </a:p>
+          <a:p>
+            <a:pPr>
+              <a:spcAft>
+                <a:spcPts val="250"/>
+              </a:spcAft>
+            </a:pPr>
+            <a:r>
+              <a:rPr sz="950" b="1">
+                <a:solidFill>
+                  <a:srgbClr val="0B2545"/>
+                </a:solidFill>
+                <a:latin typeface="Arial"/>
+              </a:rPr>
+              <a:t>[Stage 5] Visualization &amp; Actionable SOAR
+</a:t>
+            </a:r>
+            <a:r>
+              <a:rPr sz="900">
+                <a:solidFill>
+                  <a:srgbClr val="1E293B"/>
+                </a:solidFill>
+                <a:latin typeface="Calibri"/>
+              </a:rPr>
+              <a:t>Renders 3D attack trajectory on Earth globe and generates printable PDF forensic incident dossiers.</a:t>
             </a:r>
           </a:p>
           <a:p>
             <a:pPr>
               <a:spcBef>
-                <a:spcPts val="300"/>
+                <a:spcPts val="400"/>
               </a:spcBef>
+            </a:pPr>
+            <a:r>
+              <a:rPr sz="850" i="1">
+                <a:solidFill>
+                  <a:srgbClr val="475569"/>
+                </a:solidFill>
+                <a:latin typeface="Calibri"/>
+              </a:rPr>
+              <a:t>★ Steve Jobs Synthesis Analogy:
+Just as the iPhone synthesized a phone, an iPod, and an internet communicator into one device, ThreatLens synthesizes MIME Parsers, Cryptographic DNS Validators, and 3D Spatial Maps into one pocket workstation.</a:t>
+            </a:r>
+          </a:p>
+        </p:txBody>
+      </p:sp>
+      <p:sp>
+        <p:nvSpPr>
+          <p:cNvPr id="17412" name="Rounded Rectangle 17411"/>
+          <p:cNvSpPr/>
+          <p:nvPr/>
+        </p:nvSpPr>
+        <p:spPr>
+          <a:xfrm>
+            <a:off x="5989320" y="1188720"/>
+            <a:ext cx="5806440" cy="4983480"/>
+          </a:xfrm>
+          <a:prstGeom prst="roundRect">
+            <a:avLst/>
+          </a:prstGeom>
+          <a:solidFill>
+            <a:srgbClr val="F8FAFC"/>
+          </a:solidFill>
+          <a:ln w="15240">
+            <a:solidFill>
+              <a:srgbClr val="CBD5E1"/>
+            </a:solidFill>
+          </a:ln>
+        </p:spPr>
+        <p:style>
+          <a:lnRef idx="1">
+            <a:schemeClr val="accent1"/>
+          </a:lnRef>
+          <a:fillRef idx="3">
+            <a:schemeClr val="accent1"/>
+          </a:fillRef>
+          <a:effectRef idx="2">
+            <a:schemeClr val="accent1"/>
+          </a:effectRef>
+          <a:fontRef idx="minor">
+            <a:schemeClr val="lt1"/>
+          </a:fontRef>
+        </p:style>
+        <p:txBody>
+          <a:bodyPr rtlCol="0" anchor="ctr" wrap="square" lIns="182880" rIns="182880" tIns="164592" bIns="164592"/>
+          <a:lstStyle/>
+          <a:p>
+            <a:pPr algn="ctr">
               <a:spcAft>
-                <a:spcPts val="100"/>
+                <a:spcPts val="600"/>
               </a:spcAft>
             </a:pPr>
             <a:r>
-              <a:rPr b="1" sz="1000">
+              <a:rPr sz="1100" b="1">
+                <a:solidFill>
+                  <a:srgbClr val="EA580C"/>
+                </a:solidFill>
+                <a:latin typeface="Arial"/>
+              </a:rPr>
+              <a:t>HIERARCHICAL TECHNOLOGY STACK (BY LAYER)</a:t>
+            </a:r>
+          </a:p>
+          <a:p>
+            <a:pPr>
+              <a:spcAft>
+                <a:spcPts val="250"/>
+              </a:spcAft>
+            </a:pPr>
+            <a:r>
+              <a:rPr sz="950" b="1">
                 <a:solidFill>
                   <a:srgbClr val="0B2545"/>
                 </a:solidFill>
                 <a:latin typeface="Arial"/>
               </a:rPr>
-              <a:t>1. Ingestion Engine
+              <a:t>Layer 4: Deployment &amp; Edge Delivery
 </a:t>
             </a:r>
             <a:r>
-              <a:rPr sz="950">
+              <a:rPr sz="900" b="1">
+                <a:solidFill>
+                  <a:srgbClr val="16A34A"/>
+                </a:solidFill>
+                <a:latin typeface="Arial"/>
+              </a:rPr>
+              <a:t>Tech Stack: Vercel Global Edge Network
+</a:t>
+            </a:r>
+            <a:r>
+              <a:rPr sz="850">
                 <a:solidFill>
                   <a:srgbClr val="1E293B"/>
                 </a:solidFill>
                 <a:latin typeface="Calibri"/>
               </a:rPr>
-              <a:t>Accepts .eml / .msg drag-and-drop, raw RFC 822 pasted headers, and automated SOC live telemetry streams.</a:t>
+              <a:t>Sub-second global latency, serverless edge caching, automated preview deployment pipelines.</a:t>
+            </a:r>
+          </a:p>
+          <a:p>
+            <a:pPr>
+              <a:spcAft>
+                <a:spcPts val="250"/>
+              </a:spcAft>
+            </a:pPr>
+            <a:r>
+              <a:rPr sz="950" b="1">
+                <a:solidFill>
+                  <a:srgbClr val="0B2545"/>
+                </a:solidFill>
+                <a:latin typeface="Arial"/>
+              </a:rPr>
+              <a:t>Layer 3: Application &amp; Visual SOC UX
+</a:t>
+            </a:r>
+            <a:r>
+              <a:rPr sz="900" b="1">
+                <a:solidFill>
+                  <a:srgbClr val="16A34A"/>
+                </a:solidFill>
+                <a:latin typeface="Arial"/>
+              </a:rPr>
+              <a:t>Tech Stack: Next.js + Three.js + Tailwind CSS
+</a:t>
+            </a:r>
+            <a:r>
+              <a:rPr sz="850">
+                <a:solidFill>
+                  <a:srgbClr val="1E293B"/>
+                </a:solidFill>
+                <a:latin typeface="Calibri"/>
+              </a:rPr>
+              <a:t>Next.js (Server/Client hybrid rendering architecture), Three.js (WebGL 3D Earth globe with raycasting), Tailwind CSS, Lucide security icons.</a:t>
+            </a:r>
+          </a:p>
+          <a:p>
+            <a:pPr>
+              <a:spcAft>
+                <a:spcPts val="250"/>
+              </a:spcAft>
+            </a:pPr>
+            <a:r>
+              <a:rPr sz="950" b="1">
+                <a:solidFill>
+                  <a:srgbClr val="0B2545"/>
+                </a:solidFill>
+                <a:latin typeface="Arial"/>
+              </a:rPr>
+              <a:t>Layer 2: Forensic &amp; Cryptographic Core
+</a:t>
+            </a:r>
+            <a:r>
+              <a:rPr sz="900" b="1">
+                <a:solidFill>
+                  <a:srgbClr val="16A34A"/>
+                </a:solidFill>
+                <a:latin typeface="Arial"/>
+              </a:rPr>
+              <a:t>Tech Stack: Browser DOM RFC 822 Engine + DoH
+</a:t>
+            </a:r>
+            <a:r>
+              <a:rPr sz="850">
+                <a:solidFill>
+                  <a:srgbClr val="1E293B"/>
+                </a:solidFill>
+                <a:latin typeface="Calibri"/>
+              </a:rPr>
+              <a:t>Client-side RFC 822/5322 MIME parser, SHA-256 Web Crypto API, DNS-over-HTTPS (DoH Cloudflare/Google 1.1.1.1) for live DNS TXT lookups.</a:t>
+            </a:r>
+          </a:p>
+          <a:p>
+            <a:pPr>
+              <a:spcAft>
+                <a:spcPts val="250"/>
+              </a:spcAft>
+            </a:pPr>
+            <a:r>
+              <a:rPr sz="950" b="1">
+                <a:solidFill>
+                  <a:srgbClr val="0B2545"/>
+                </a:solidFill>
+                <a:latin typeface="Arial"/>
+              </a:rPr>
+              <a:t>Layer 1: Telemetry &amp; Intelligence Corroboration
+</a:t>
+            </a:r>
+            <a:r>
+              <a:rPr sz="900" b="1">
+                <a:solidFill>
+                  <a:srgbClr val="16A34A"/>
+                </a:solidFill>
+                <a:latin typeface="Arial"/>
+              </a:rPr>
+              <a:t>Tech Stack: MITRE ATT&amp;CK + MaxMind GeoLite2
+</a:t>
+            </a:r>
+            <a:r>
+              <a:rPr sz="850">
+                <a:solidFill>
+                  <a:srgbClr val="1E293B"/>
+                </a:solidFill>
+                <a:latin typeface="Calibri"/>
+              </a:rPr>
+              <a:t>MaxMind IP coordinate mapping, MITRE ATT&amp;CK Enterprise Matrix (v14), IOC reputation corpus (Malicious IPs, Domains, Hashes).</a:t>
             </a:r>
           </a:p>
           <a:p>
             <a:pPr>
               <a:spcBef>
-                <a:spcPts val="300"/>
-              </a:spcBef>
-              <a:spcAft>
-                <a:spcPts val="100"/>
-              </a:spcAft>
-            </a:pPr>
-            <a:r>
-              <a:rPr b="1" sz="1000">
-                <a:solidFill>
-                  <a:srgbClr val="0B2545"/>
-                </a:solidFill>
-                <a:latin typeface="Arial"/>
-              </a:rPr>
-              <a:t>2. MIME Disassembly
-</a:t>
-            </a:r>
-            <a:r>
-              <a:rPr sz="950">
-                <a:solidFill>
-                  <a:srgbClr val="1E293B"/>
-                </a:solidFill>
-                <a:latin typeface="Calibri"/>
-              </a:rPr>
-              <a:t>Recursive RFC 5322 parsing; extracts headers (From, Return-Path, Received: hops), embedded URLs, and SHA-256 attachment hashes.</a:t>
-            </a:r>
-          </a:p>
-          <a:p>
-            <a:pPr>
-              <a:spcBef>
-                <a:spcPts val="300"/>
-              </a:spcBef>
-              <a:spcAft>
-                <a:spcPts val="100"/>
-              </a:spcAft>
-            </a:pPr>
-            <a:r>
-              <a:rPr b="1" sz="1000">
-                <a:solidFill>
-                  <a:srgbClr val="0B2545"/>
-                </a:solidFill>
-                <a:latin typeface="Arial"/>
-              </a:rPr>
-              <a:t>3. Cryptographic Matrix
-</a:t>
-            </a:r>
-            <a:r>
-              <a:rPr sz="950">
-                <a:solidFill>
-                  <a:srgbClr val="1E293B"/>
-                </a:solidFill>
-                <a:latin typeface="Calibri"/>
-              </a:rPr>
-              <a:t>Simultaneous evaluation of SPF (RFC 7208), DKIM (RFC 6376), and DMARC (RFC 7489) alignment and policy enforcement.</a:t>
-            </a:r>
-          </a:p>
-          <a:p>
-            <a:pPr>
-              <a:spcBef>
-                <a:spcPts val="300"/>
-              </a:spcBef>
-              <a:spcAft>
-                <a:spcPts val="100"/>
-              </a:spcAft>
-            </a:pPr>
-            <a:r>
-              <a:rPr b="1" sz="1000">
-                <a:solidFill>
-                  <a:srgbClr val="0B2545"/>
-                </a:solidFill>
-                <a:latin typeface="Arial"/>
-              </a:rPr>
-              <a:t>4. Geolocation Resolution
-</a:t>
-            </a:r>
-            <a:r>
-              <a:rPr sz="950">
-                <a:solidFill>
-                  <a:srgbClr val="1E293B"/>
-                </a:solidFill>
-                <a:latin typeface="Calibri"/>
-              </a:rPr>
-              <a:t>Extracts connecting MTA IP from Received headers; resolves coordinates and maps adversary origin infrastructure.</a:t>
-            </a:r>
-          </a:p>
-          <a:p>
-            <a:pPr>
-              <a:spcBef>
-                <a:spcPts val="300"/>
-              </a:spcBef>
-              <a:spcAft>
-                <a:spcPts val="100"/>
-              </a:spcAft>
-            </a:pPr>
-            <a:r>
-              <a:rPr b="1" sz="1000">
-                <a:solidFill>
-                  <a:srgbClr val="0B2545"/>
-                </a:solidFill>
-                <a:latin typeface="Arial"/>
-              </a:rPr>
-              <a:t>5. Visualization &amp; SOAR Action
-</a:t>
-            </a:r>
-            <a:r>
-              <a:rPr sz="950">
-                <a:solidFill>
-                  <a:srgbClr val="1E293B"/>
-                </a:solidFill>
-                <a:latin typeface="Calibri"/>
-              </a:rPr>
-              <a:t>Renders 3D attack trajectory on Earth globe, calculates 0–100 threat score, and generates printable PDF audit dossiers.</a:t>
-            </a:r>
-          </a:p>
-          <a:p>
-            <a:pPr>
-              <a:spcBef>
-                <a:spcPts val="600"/>
-              </a:spcBef>
-            </a:pPr>
-            <a:r>
-              <a:rPr i="1" sz="850">
-                <a:solidFill>
-                  <a:srgbClr val="475569"/>
-                </a:solidFill>
-                <a:latin typeface="Calibri"/>
-              </a:rPr>
-              <a:t>★ The Synthesis Analogy (Steve Jobs Principle):
-Like the iPhone unified a phone, an iPod, and an internet communicator, ThreatLens unifies RFC Parsers, Cryptographic DNS Validators, and 3D Spatial Visualizers into one workstation.</a:t>
-            </a:r>
-          </a:p>
-        </p:txBody>
-      </p:sp>
-      <p:sp>
-        <p:nvSpPr>
-          <p:cNvPr id="17413" name="TextBox 17412"/>
-          <p:cNvSpPr txBox="1"/>
-          <p:nvPr/>
-        </p:nvSpPr>
-        <p:spPr>
-          <a:xfrm>
-            <a:off x="6126480" y="1188720"/>
-            <a:ext cx="5577840" cy="5029200"/>
-          </a:xfrm>
-          <a:prstGeom prst="rect">
-            <a:avLst/>
-          </a:prstGeom>
-          <a:noFill/>
-        </p:spPr>
-        <p:txBody>
-          <a:bodyPr wrap="square">
-            <a:spAutoFit/>
-          </a:bodyPr>
-          <a:lstStyle/>
-          <a:p>
-            <a:pPr>
-              <a:spcAft>
                 <a:spcPts val="400"/>
-              </a:spcAft>
-            </a:pPr>
-            <a:r>
-              <a:rPr b="1" sz="1200">
-                <a:solidFill>
-                  <a:srgbClr val="EA580C"/>
-                </a:solidFill>
-                <a:latin typeface="Arial"/>
-              </a:rPr>
-              <a:t>HIERARCHICAL TECHNOLOGY STACK (BY LAYER)</a:t>
-            </a:r>
-          </a:p>
-          <a:p>
-            <a:pPr>
-              <a:spcBef>
-                <a:spcPts val="300"/>
-              </a:spcBef>
-              <a:spcAft>
-                <a:spcPts val="100"/>
-              </a:spcAft>
-            </a:pPr>
-            <a:r>
-              <a:rPr b="1" sz="950">
-                <a:solidFill>
-                  <a:srgbClr val="0B2545"/>
-                </a:solidFill>
-                <a:latin typeface="Arial"/>
-              </a:rPr>
-              <a:t>Layer 4: Deployment &amp; Edge Delivery
-</a:t>
-            </a:r>
-            <a:r>
-              <a:rPr b="1" sz="950">
-                <a:solidFill>
-                  <a:srgbClr val="16A34A"/>
-                </a:solidFill>
-                <a:latin typeface="Calibri"/>
-              </a:rPr>
-              <a:t>Tech: Vercel Global Edge Network
-</a:t>
-            </a:r>
-            <a:r>
-              <a:rPr sz="900">
-                <a:solidFill>
-                  <a:srgbClr val="1E293B"/>
-                </a:solidFill>
-                <a:latin typeface="Calibri"/>
-              </a:rPr>
-              <a:t>Sub-second global latency, serverless edge caching, CI/CD automated preview pipelines.</a:t>
-            </a:r>
-          </a:p>
-          <a:p>
-            <a:pPr>
-              <a:spcBef>
-                <a:spcPts val="300"/>
-              </a:spcBef>
-              <a:spcAft>
-                <a:spcPts val="100"/>
-              </a:spcAft>
-            </a:pPr>
-            <a:r>
-              <a:rPr b="1" sz="950">
-                <a:solidFill>
-                  <a:srgbClr val="0B2545"/>
-                </a:solidFill>
-                <a:latin typeface="Arial"/>
-              </a:rPr>
-              <a:t>Layer 3: Application &amp; Visual SOC UX
-</a:t>
-            </a:r>
-            <a:r>
-              <a:rPr b="1" sz="950">
-                <a:solidFill>
-                  <a:srgbClr val="16A34A"/>
-                </a:solidFill>
-                <a:latin typeface="Calibri"/>
-              </a:rPr>
-              <a:t>Tech: Next.js + Three.js + Tailwind CSS
-</a:t>
-            </a:r>
-            <a:r>
-              <a:rPr sz="900">
-                <a:solidFill>
-                  <a:srgbClr val="1E293B"/>
-                </a:solidFill>
-                <a:latin typeface="Calibri"/>
-              </a:rPr>
-              <a:t>Next.js (Server/Client hybrid rendering architecture), Three.js (WebGL 3D Earth globe with raycasting), Tailwind CSS, Lucide security icons.</a:t>
-            </a:r>
-          </a:p>
-          <a:p>
-            <a:pPr>
-              <a:spcBef>
-                <a:spcPts val="300"/>
-              </a:spcBef>
-              <a:spcAft>
-                <a:spcPts val="100"/>
-              </a:spcAft>
-            </a:pPr>
-            <a:r>
-              <a:rPr b="1" sz="950">
-                <a:solidFill>
-                  <a:srgbClr val="0B2545"/>
-                </a:solidFill>
-                <a:latin typeface="Arial"/>
-              </a:rPr>
-              <a:t>Layer 2: Forensic &amp; Cryptographic Core
-</a:t>
-            </a:r>
-            <a:r>
-              <a:rPr b="1" sz="950">
-                <a:solidFill>
-                  <a:srgbClr val="16A34A"/>
-                </a:solidFill>
-                <a:latin typeface="Calibri"/>
-              </a:rPr>
-              <a:t>Tech: Browser DOM RFC 822 Engine + DoH
-</a:t>
-            </a:r>
-            <a:r>
-              <a:rPr sz="900">
-                <a:solidFill>
-                  <a:srgbClr val="1E293B"/>
-                </a:solidFill>
-                <a:latin typeface="Calibri"/>
-              </a:rPr>
-              <a:t>Client-side RFC 822/5322 MIME parser, SHA-256 Web Crypto API, DNS-over-HTTPS (DoH Cloudflare/Google 1.1.1.1) for live DNS TXT lookups.</a:t>
-            </a:r>
-          </a:p>
-          <a:p>
-            <a:pPr>
-              <a:spcBef>
-                <a:spcPts val="300"/>
-              </a:spcBef>
-              <a:spcAft>
-                <a:spcPts val="100"/>
-              </a:spcAft>
-            </a:pPr>
-            <a:r>
-              <a:rPr b="1" sz="950">
-                <a:solidFill>
-                  <a:srgbClr val="0B2545"/>
-                </a:solidFill>
-                <a:latin typeface="Arial"/>
-              </a:rPr>
-              <a:t>Layer 1: Telemetry &amp; Intelligence Corroboration
-</a:t>
-            </a:r>
-            <a:r>
-              <a:rPr b="1" sz="950">
-                <a:solidFill>
-                  <a:srgbClr val="16A34A"/>
-                </a:solidFill>
-                <a:latin typeface="Calibri"/>
-              </a:rPr>
-              <a:t>Tech: MITRE ATT&amp;CK + MaxMind GeoLite2
-</a:t>
-            </a:r>
-            <a:r>
-              <a:rPr sz="900">
-                <a:solidFill>
-                  <a:srgbClr val="1E293B"/>
-                </a:solidFill>
-                <a:latin typeface="Calibri"/>
-              </a:rPr>
-              <a:t>MaxMind IP geolocation coordinate database, MITRE ATT&amp;CK Enterprise Matrix (v14), IOC reputation corpus (Malicious IPs, Domains, Hashes).</a:t>
-            </a:r>
-          </a:p>
-          <a:p>
-            <a:pPr>
-              <a:spcBef>
-                <a:spcPts val="500"/>
               </a:spcBef>
             </a:pPr>
             <a:r>
@@ -7368,245 +7510,38 @@
         </p:nvSpPr>
         <p:spPr>
           <a:xfrm>
-            <a:off x="2148840" y="137160"/>
-            <a:ext cx="7498079" cy="914400"/>
+            <a:off x="2194560" y="137160"/>
+            <a:ext cx="7406640" cy="868680"/>
           </a:xfrm>
         </p:spPr>
         <p:txBody>
-          <a:bodyPr/>
+          <a:bodyPr wrap="square"/>
           <a:lstStyle/>
           <a:p>
             <a:pPr eaLnBrk="1" hangingPunct="1">
-              <a:defRPr b="1" sz="1600">
+              <a:spcAft>
+                <a:spcPts val="200"/>
+              </a:spcAft>
+            </a:pPr>
+            <a:r>
+              <a:rPr sz="850" b="1">
+                <a:solidFill>
+                  <a:srgbClr val="EA580C"/>
+                </a:solidFill>
+                <a:latin typeface="Arial"/>
+              </a:rPr>
+              <a:t>PARSIMONY PRINCIPLE (OCCAM'S RAZOR) &amp; RISK MITIGATION</a:t>
+            </a:r>
+          </a:p>
+          <a:p>
+            <a:r>
+              <a:rPr sz="1700" b="1">
                 <a:solidFill>
                   <a:srgbClr val="0B2545"/>
                 </a:solidFill>
                 <a:latin typeface="Arial"/>
-              </a:defRPr>
-            </a:pPr>
-            <a:r>
-              <a:t>FEASIBILITY AND VIABILITY: Parsimony Principle &amp; Risk Mitigation</a:t>
-            </a:r>
-          </a:p>
-        </p:txBody>
-      </p:sp>
-      <p:sp>
-        <p:nvSpPr>
-          <p:cNvPr id="17410" name="TextBox 8"/>
-          <p:cNvSpPr txBox="1">
-            <a:spLocks noChangeArrowheads="1"/>
-          </p:cNvSpPr>
-          <p:nvPr/>
-        </p:nvSpPr>
-        <p:spPr bwMode="auto">
-          <a:xfrm>
-            <a:off x="457200" y="1188720"/>
-            <a:ext cx="11247120" cy="5029200"/>
-          </a:xfrm>
-          <a:prstGeom prst="rect">
-            <a:avLst/>
-          </a:prstGeom>
-          <a:noFill/>
-          <a:ln w="9525">
-            <a:noFill/>
-            <a:miter lim="800000"/>
-            <a:headEnd/>
-            <a:tailEnd/>
-          </a:ln>
-        </p:spPr>
-        <p:txBody>
-          <a:bodyPr wrap="square">
-            <a:spAutoFit/>
-          </a:bodyPr>
-          <a:lstStyle/>
-          <a:p>
-            <a:pPr marL="342900" marR="0" lvl="0" indent="-342900" algn="just" defTabSz="457200" rtl="0" eaLnBrk="1" fontAlgn="base" latinLnBrk="0" hangingPunct="1">
-              <a:lnSpc>
-                <a:spcPct val="100000"/>
-              </a:lnSpc>
-              <a:spcBef>
-                <a:spcPct val="0"/>
-              </a:spcBef>
-              <a:spcAft>
-                <a:spcPct val="0"/>
-              </a:spcAft>
-              <a:buClrTx/>
-              <a:buSzTx/>
-              <a:buFont typeface="Arial" panose="020B0604020202020204" pitchFamily="34" charset="0"/>
-              <a:buChar char="•"/>
-              <a:tabLst/>
-              <a:defRPr/>
-            </a:pPr>
-            <a:endParaRPr kumimoji="0" lang="en-US" sz="2800" b="0" i="0" u="none" strike="noStrike" kern="1200" cap="none" spc="0" normalizeH="0" baseline="0" noProof="0" dirty="0">
-              <a:ln>
-                <a:noFill/>
-              </a:ln>
-              <a:solidFill>
-                <a:prstClr val="black"/>
-              </a:solidFill>
-              <a:effectLst/>
-              <a:uLnTx/>
-              <a:uFillTx/>
-              <a:latin typeface="Arial" pitchFamily="34" charset="0"/>
-              <a:ea typeface="ＭＳ Ｐゴシック" pitchFamily="1" charset="-128"/>
-              <a:cs typeface="Arial" pitchFamily="34" charset="0"/>
-            </a:endParaRPr>
-          </a:p>
-          <a:p>
-            <a:r>
-              <a:rPr b="1" sz="1150">
-                <a:solidFill>
-                  <a:srgbClr val="EA580C"/>
-                </a:solidFill>
-                <a:latin typeface="Arial"/>
-              </a:rPr>
-              <a:t>1. Technical Feasibility &amp; The Parsimony Principle (Occam's Razor)</a:t>
-            </a:r>
-          </a:p>
-          <a:p>
-            <a:pPr>
-              <a:spcAft>
-                <a:spcPts val="400"/>
-              </a:spcAft>
-            </a:pPr>
-            <a:r>
-              <a:rPr sz="950">
-                <a:solidFill>
-                  <a:srgbClr val="1E293B"/>
-                </a:solidFill>
-                <a:latin typeface="Calibri"/>
-              </a:rPr>
-              <a:t>• Browser DOM Client-Side Execution: Next.js handles MIME disassembly, regex parsing, and cryptographic checks strictly in the client's browser DOM using native Web APIs. The sensitive email payload is NEVER POSTed to any backend server.
-• 100% Data Privacy Guaranteed: Complies fully with India's Digital Personal Data Protection (DPDP) Act 2023 and GDPR—eliminating the severe data breach risk of commercial cloud sandbox competitors.
-• Zero Cloud Compute Bill: Eliminates expensive GPU/server clusters. Runs effortlessly on standard SOC workstation laptops with sub-second response times.
-• Verified Empirical Prototype: Already fully functional at threatlens-gen.vercel.app with 64/64 automated test passes across real-world adversarial email payloads.</a:t>
-            </a:r>
-          </a:p>
-          <a:p>
-            <a:pPr>
-              <a:spcBef>
-                <a:spcPts val="400"/>
-              </a:spcBef>
-            </a:pPr>
-            <a:r>
-              <a:rPr b="1" sz="1150">
-                <a:solidFill>
-                  <a:srgbClr val="EA580C"/>
-                </a:solidFill>
-                <a:latin typeface="Arial"/>
-              </a:rPr>
-              <a:t>2. Potential Challenges, Risks &amp; Active Mitigation Strategies</a:t>
-            </a:r>
-          </a:p>
-          <a:p>
-            <a:pPr>
-              <a:spcBef>
-                <a:spcPts val="250"/>
-              </a:spcBef>
-              <a:spcAft>
-                <a:spcPts val="100"/>
-              </a:spcAft>
-            </a:pPr>
-            <a:r>
-              <a:rPr b="1" sz="950">
-                <a:solidFill>
-                  <a:srgbClr val="0B2545"/>
-                </a:solidFill>
-                <a:latin typeface="Arial"/>
-              </a:rPr>
-              <a:t>• Risk 1: Compromised Legitimate Relays: </a:t>
-            </a:r>
-            <a:r>
-              <a:rPr sz="900">
-                <a:solidFill>
-                  <a:srgbClr val="1E293B"/>
-                </a:solidFill>
-                <a:latin typeface="Calibri"/>
-              </a:rPr>
-              <a:t>Attacker compromises legitimate M365/SendGrid account where SPF/DKIM legitimately PASS. — </a:t>
-            </a:r>
-            <a:r>
-              <a:rPr b="1" sz="900">
-                <a:solidFill>
-                  <a:srgbClr val="16A34A"/>
-                </a:solidFill>
-                <a:latin typeface="Calibri"/>
-              </a:rPr>
-              <a:t>MITIGATION: Multi-vector heuristic detection flags Display-Name impersonation, Header vs. Envelope mismatches, and Cousin-Domain age even when cryptographic checks pass.</a:t>
-            </a:r>
-          </a:p>
-          <a:p>
-            <a:pPr>
-              <a:spcBef>
-                <a:spcPts val="250"/>
-              </a:spcBef>
-              <a:spcAft>
-                <a:spcPts val="100"/>
-              </a:spcAft>
-            </a:pPr>
-            <a:r>
-              <a:rPr b="1" sz="950">
-                <a:solidFill>
-                  <a:srgbClr val="0B2545"/>
-                </a:solidFill>
-                <a:latin typeface="Arial"/>
-              </a:rPr>
-              <a:t>• Risk 2: Image-Only &amp; QR Quishing Traps: </a:t>
-            </a:r>
-            <a:r>
-              <a:rPr sz="900">
-                <a:solidFill>
-                  <a:srgbClr val="1E293B"/>
-                </a:solidFill>
-                <a:latin typeface="Calibri"/>
-              </a:rPr>
-              <a:t>Adversaries embed malicious URLs inside QR code images, bypassing standard text-based URL parsers. — </a:t>
-            </a:r>
-            <a:r>
-              <a:rPr b="1" sz="900">
-                <a:solidFill>
-                  <a:srgbClr val="16A34A"/>
-                </a:solidFill>
-                <a:latin typeface="Calibri"/>
-              </a:rPr>
-              <a:t>MITIGATION: Integrated client-side HTML5 canvas image decoder analyzes embedded QR codes and extracts underlying redirect links directly during MIME traversal.</a:t>
-            </a:r>
-          </a:p>
-          <a:p>
-            <a:pPr>
-              <a:spcBef>
-                <a:spcPts val="250"/>
-              </a:spcBef>
-              <a:spcAft>
-                <a:spcPts val="100"/>
-              </a:spcAft>
-            </a:pPr>
-            <a:r>
-              <a:rPr b="1" sz="950">
-                <a:solidFill>
-                  <a:srgbClr val="0B2545"/>
-                </a:solidFill>
-                <a:latin typeface="Arial"/>
-              </a:rPr>
-              <a:t>• Risk 3: Large / Malformed .eml Payloads: </a:t>
-            </a:r>
-            <a:r>
-              <a:rPr sz="900">
-                <a:solidFill>
-                  <a:srgbClr val="1E293B"/>
-                </a:solidFill>
-                <a:latin typeface="Calibri"/>
-              </a:rPr>
-              <a:t>Oversized attachments or malformed RFC headers crashing browser memory threads. — </a:t>
-            </a:r>
-            <a:r>
-              <a:rPr b="1" sz="900">
-                <a:solidFill>
-                  <a:srgbClr val="16A34A"/>
-                </a:solidFill>
-                <a:latin typeface="Calibri"/>
-              </a:rPr>
-              <a:t>MITIGATION: Streaming non-blocking Web Worker parser with configurable byte-boundary limits and payload truncation safeguards.</a:t>
+              </a:rPr>
+              <a:t>FEASIBILITY AND VIABILITY</a:t>
             </a:r>
           </a:p>
         </p:txBody>
@@ -7729,24 +7664,15 @@
               <a:buFontTx/>
               <a:buNone/>
               <a:tabLst/>
-              <a:defRPr/>
-            </a:pPr>
-            <a:r>
-              <a:rPr kumimoji="0" lang="en-US" sz="1200" b="0" i="0" u="none" strike="noStrike" kern="1200" cap="none" spc="0" normalizeH="0" baseline="0" noProof="0">
-                <a:ln>
-                  <a:noFill/>
-                </a:ln>
-                <a:solidFill>
-                  <a:prstClr val="white"/>
-                </a:solidFill>
-                <a:effectLst/>
-                <a:uLnTx/>
-                <a:uFillTx/>
-                <a:latin typeface="TradeGothic"/>
-                <a:ea typeface="+mn-ea"/>
-                <a:cs typeface="+mn-cs"/>
-              </a:rPr>
-              <a:t>@SIH Idea submission- Template</a:t>
+              <a:defRPr sz="850">
+                <a:solidFill>
+                  <a:srgbClr val="475569"/>
+                </a:solidFill>
+                <a:latin typeface="Calibri"/>
+              </a:defRPr>
+            </a:pPr>
+            <a:r>
+              <a:t>Smart India Hackathon 2026  |  Problem Statement ID: SIH26106  |  Team CyberCore  |  CVR College of Engineering</a:t>
             </a:r>
             <a:endParaRPr kumimoji="0" lang="en-US" sz="1200" b="0" i="0" u="none" strike="noStrike" kern="1200" cap="none" spc="0" normalizeH="0" baseline="0" noProof="0" dirty="0">
               <a:ln>
@@ -7797,14 +7723,14 @@
       </p:pic>
       <p:sp>
         <p:nvSpPr>
-          <p:cNvPr id="17411" name="Oval CyberCore Slide 4"/>
+          <p:cNvPr id="17410" name="Oval CyberCore Slide 4"/>
           <p:cNvSpPr/>
           <p:nvPr/>
         </p:nvSpPr>
         <p:spPr>
           <a:xfrm>
-            <a:off x="329184" y="182880"/>
-            <a:ext cx="1691640" cy="777240"/>
+            <a:off x="365760" y="164592"/>
+            <a:ext cx="1645920" cy="749808"/>
           </a:xfrm>
           <a:prstGeom prst="ellipse">
             <a:avLst/>
@@ -7812,7 +7738,7 @@
           <a:solidFill>
             <a:srgbClr val="EA580C"/>
           </a:solidFill>
-          <a:ln w="31750">
+          <a:ln w="27940">
             <a:solidFill>
               <a:srgbClr val="0B2545"/>
             </a:solidFill>
@@ -7845,6 +7771,334 @@
                 <a:latin typeface="Arial"/>
               </a:rPr>
               <a:t>CyberCore</a:t>
+            </a:r>
+          </a:p>
+        </p:txBody>
+      </p:sp>
+      <p:sp>
+        <p:nvSpPr>
+          <p:cNvPr id="17411" name="Rounded Rectangle 17410"/>
+          <p:cNvSpPr/>
+          <p:nvPr/>
+        </p:nvSpPr>
+        <p:spPr>
+          <a:xfrm>
+            <a:off x="365760" y="1188720"/>
+            <a:ext cx="5440680" cy="4983480"/>
+          </a:xfrm>
+          <a:prstGeom prst="roundRect">
+            <a:avLst/>
+          </a:prstGeom>
+          <a:solidFill>
+            <a:srgbClr val="F8FAFC"/>
+          </a:solidFill>
+          <a:ln w="15240">
+            <a:solidFill>
+              <a:srgbClr val="CBD5E1"/>
+            </a:solidFill>
+          </a:ln>
+        </p:spPr>
+        <p:style>
+          <a:lnRef idx="1">
+            <a:schemeClr val="accent1"/>
+          </a:lnRef>
+          <a:fillRef idx="3">
+            <a:schemeClr val="accent1"/>
+          </a:fillRef>
+          <a:effectRef idx="2">
+            <a:schemeClr val="accent1"/>
+          </a:effectRef>
+          <a:fontRef idx="minor">
+            <a:schemeClr val="lt1"/>
+          </a:fontRef>
+        </p:style>
+        <p:txBody>
+          <a:bodyPr rtlCol="0" anchor="ctr" wrap="square" lIns="182880" rIns="182880" tIns="164592" bIns="164592"/>
+          <a:lstStyle/>
+          <a:p>
+            <a:pPr algn="ctr">
+              <a:spcAft>
+                <a:spcPts val="600"/>
+              </a:spcAft>
+            </a:pPr>
+            <a:r>
+              <a:rPr sz="1100" b="1">
+                <a:solidFill>
+                  <a:srgbClr val="EA580C"/>
+                </a:solidFill>
+                <a:latin typeface="Arial"/>
+              </a:rPr>
+              <a:t>TECHNICAL FEASIBILITY &amp; OCCAM'S RAZOR</a:t>
+            </a:r>
+          </a:p>
+          <a:p>
+            <a:pPr>
+              <a:spcAft>
+                <a:spcPts val="300"/>
+              </a:spcAft>
+            </a:pPr>
+            <a:r>
+              <a:rPr sz="950" b="1">
+                <a:solidFill>
+                  <a:srgbClr val="0B2545"/>
+                </a:solidFill>
+                <a:latin typeface="Arial"/>
+              </a:rPr>
+              <a:t>• Browser DOM Client-Side Execution:
+  </a:t>
+            </a:r>
+            <a:r>
+              <a:rPr sz="900">
+                <a:solidFill>
+                  <a:srgbClr val="1E293B"/>
+                </a:solidFill>
+                <a:latin typeface="Calibri"/>
+              </a:rPr>
+              <a:t>Next.js handles MIME disassembly, regex parsing, and cryptographic checks strictly in the client's browser DOM using native Web APIs. The sensitive email payload is NEVER POSTed to any backend server.</a:t>
+            </a:r>
+          </a:p>
+          <a:p>
+            <a:pPr>
+              <a:spcAft>
+                <a:spcPts val="300"/>
+              </a:spcAft>
+            </a:pPr>
+            <a:r>
+              <a:rPr sz="950" b="1">
+                <a:solidFill>
+                  <a:srgbClr val="0B2545"/>
+                </a:solidFill>
+                <a:latin typeface="Arial"/>
+              </a:rPr>
+              <a:t>• 100% Data Privacy Guaranteed:
+  </a:t>
+            </a:r>
+            <a:r>
+              <a:rPr sz="900">
+                <a:solidFill>
+                  <a:srgbClr val="1E293B"/>
+                </a:solidFill>
+                <a:latin typeface="Calibri"/>
+              </a:rPr>
+              <a:t>Complies fully with India's Digital Personal Data Protection (DPDP) Act 2023 and GDPR—eliminating the severe corporate data breach risk inherent in commercial cloud sandbox competitors.</a:t>
+            </a:r>
+          </a:p>
+          <a:p>
+            <a:pPr>
+              <a:spcAft>
+                <a:spcPts val="300"/>
+              </a:spcAft>
+            </a:pPr>
+            <a:r>
+              <a:rPr sz="950" b="1">
+                <a:solidFill>
+                  <a:srgbClr val="0B2545"/>
+                </a:solidFill>
+                <a:latin typeface="Arial"/>
+              </a:rPr>
+              <a:t>• Zero Cloud Compute Footprint:
+  </a:t>
+            </a:r>
+            <a:r>
+              <a:rPr sz="900">
+                <a:solidFill>
+                  <a:srgbClr val="1E293B"/>
+                </a:solidFill>
+                <a:latin typeface="Calibri"/>
+              </a:rPr>
+              <a:t>Eliminates expensive GPU/server clusters. Runs effortlessly on standard SOC workstation laptops with sub-second response times.</a:t>
+            </a:r>
+          </a:p>
+          <a:p>
+            <a:pPr>
+              <a:spcAft>
+                <a:spcPts val="300"/>
+              </a:spcAft>
+            </a:pPr>
+            <a:r>
+              <a:rPr sz="950" b="1">
+                <a:solidFill>
+                  <a:srgbClr val="0B2545"/>
+                </a:solidFill>
+                <a:latin typeface="Arial"/>
+              </a:rPr>
+              <a:t>• Empirically Verified Working Prototype:
+  </a:t>
+            </a:r>
+            <a:r>
+              <a:rPr sz="900">
+                <a:solidFill>
+                  <a:srgbClr val="1E293B"/>
+                </a:solidFill>
+                <a:latin typeface="Calibri"/>
+              </a:rPr>
+              <a:t>Fully deployed at threatlens-gen.vercel.app with 64/64 automated test passes across real-world adversarial email payloads, malformed headers, and folded lines.</a:t>
+            </a:r>
+          </a:p>
+        </p:txBody>
+      </p:sp>
+      <p:sp>
+        <p:nvSpPr>
+          <p:cNvPr id="17412" name="Rounded Rectangle 17411"/>
+          <p:cNvSpPr/>
+          <p:nvPr/>
+        </p:nvSpPr>
+        <p:spPr>
+          <a:xfrm>
+            <a:off x="5989320" y="1188720"/>
+            <a:ext cx="5806440" cy="4983480"/>
+          </a:xfrm>
+          <a:prstGeom prst="roundRect">
+            <a:avLst/>
+          </a:prstGeom>
+          <a:solidFill>
+            <a:srgbClr val="F8FAFC"/>
+          </a:solidFill>
+          <a:ln w="15240">
+            <a:solidFill>
+              <a:srgbClr val="CBD5E1"/>
+            </a:solidFill>
+          </a:ln>
+        </p:spPr>
+        <p:style>
+          <a:lnRef idx="1">
+            <a:schemeClr val="accent1"/>
+          </a:lnRef>
+          <a:fillRef idx="3">
+            <a:schemeClr val="accent1"/>
+          </a:fillRef>
+          <a:effectRef idx="2">
+            <a:schemeClr val="accent1"/>
+          </a:effectRef>
+          <a:fontRef idx="minor">
+            <a:schemeClr val="lt1"/>
+          </a:fontRef>
+        </p:style>
+        <p:txBody>
+          <a:bodyPr rtlCol="0" anchor="ctr" wrap="square" lIns="182880" rIns="182880" tIns="164592" bIns="164592"/>
+          <a:lstStyle/>
+          <a:p>
+            <a:pPr algn="ctr">
+              <a:spcAft>
+                <a:spcPts val="600"/>
+              </a:spcAft>
+            </a:pPr>
+            <a:r>
+              <a:rPr sz="1100" b="1">
+                <a:solidFill>
+                  <a:srgbClr val="EA580C"/>
+                </a:solidFill>
+                <a:latin typeface="Arial"/>
+              </a:rPr>
+              <a:t>POTENTIAL CHALLENGES &amp; ACTIVE MITIGATIONS</a:t>
+            </a:r>
+          </a:p>
+          <a:p>
+            <a:pPr>
+              <a:spcAft>
+                <a:spcPts val="250"/>
+              </a:spcAft>
+            </a:pPr>
+            <a:r>
+              <a:rPr sz="950" b="1">
+                <a:solidFill>
+                  <a:srgbClr val="0B2545"/>
+                </a:solidFill>
+                <a:latin typeface="Arial"/>
+              </a:rPr>
+              <a:t>Risk 1: Compromised Legitimate Relays
+</a:t>
+            </a:r>
+            <a:r>
+              <a:rPr sz="850">
+                <a:solidFill>
+                  <a:srgbClr val="1E293B"/>
+                </a:solidFill>
+                <a:latin typeface="Calibri"/>
+              </a:rPr>
+              <a:t>Challenge: Attacker compromises legitimate M365/SendGrid accounts where SPF/DKIM legitimately PASS.
+</a:t>
+            </a:r>
+            <a:r>
+              <a:rPr sz="850" b="1">
+                <a:solidFill>
+                  <a:srgbClr val="16A34A"/>
+                </a:solidFill>
+                <a:latin typeface="Calibri"/>
+              </a:rPr>
+              <a:t>Defense: MITIGATION: Multi-vector heuristic detection flags Display-Name impersonation, Header vs. Envelope mismatches, and Cousin-Domain age even when cryptographic checks pass.</a:t>
+            </a:r>
+          </a:p>
+          <a:p>
+            <a:pPr>
+              <a:spcAft>
+                <a:spcPts val="250"/>
+              </a:spcAft>
+            </a:pPr>
+            <a:r>
+              <a:rPr sz="950" b="1">
+                <a:solidFill>
+                  <a:srgbClr val="0B2545"/>
+                </a:solidFill>
+                <a:latin typeface="Arial"/>
+              </a:rPr>
+              <a:t>Risk 2: Image-Only &amp; QR Quishing Traps
+</a:t>
+            </a:r>
+            <a:r>
+              <a:rPr sz="850">
+                <a:solidFill>
+                  <a:srgbClr val="1E293B"/>
+                </a:solidFill>
+                <a:latin typeface="Calibri"/>
+              </a:rPr>
+              <a:t>Challenge: Adversaries embed malicious URLs inside QR code images, bypassing standard text-based URL parsers.
+</a:t>
+            </a:r>
+            <a:r>
+              <a:rPr sz="850" b="1">
+                <a:solidFill>
+                  <a:srgbClr val="16A34A"/>
+                </a:solidFill>
+                <a:latin typeface="Calibri"/>
+              </a:rPr>
+              <a:t>Defense: MITIGATION: Integrated client-side HTML5 canvas image decoder analyzes embedded QR codes and extracts underlying redirect links directly during MIME traversal.</a:t>
+            </a:r>
+          </a:p>
+          <a:p>
+            <a:pPr>
+              <a:spcAft>
+                <a:spcPts val="250"/>
+              </a:spcAft>
+            </a:pPr>
+            <a:r>
+              <a:rPr sz="950" b="1">
+                <a:solidFill>
+                  <a:srgbClr val="0B2545"/>
+                </a:solidFill>
+                <a:latin typeface="Arial"/>
+              </a:rPr>
+              <a:t>Risk 3: Large / Malformed .eml Payloads
+</a:t>
+            </a:r>
+            <a:r>
+              <a:rPr sz="850">
+                <a:solidFill>
+                  <a:srgbClr val="1E293B"/>
+                </a:solidFill>
+                <a:latin typeface="Calibri"/>
+              </a:rPr>
+              <a:t>Challenge: Oversized attachments or malformed RFC headers crashing browser memory threads.
+</a:t>
+            </a:r>
+            <a:r>
+              <a:rPr sz="850" b="1">
+                <a:solidFill>
+                  <a:srgbClr val="16A34A"/>
+                </a:solidFill>
+                <a:latin typeface="Calibri"/>
+              </a:rPr>
+              <a:t>Defense: MITIGATION: Streaming non-blocking Web Worker parser with configurable byte-boundary limits and payload truncation safeguards.</a:t>
             </a:r>
           </a:p>
         </p:txBody>
@@ -7970,165 +8224,38 @@
         </p:nvSpPr>
         <p:spPr>
           <a:xfrm>
-            <a:off x="2148840" y="137160"/>
-            <a:ext cx="7498079" cy="914400"/>
+            <a:off x="2194560" y="137160"/>
+            <a:ext cx="7406640" cy="868680"/>
           </a:xfrm>
         </p:spPr>
         <p:txBody>
-          <a:bodyPr/>
+          <a:bodyPr wrap="square"/>
           <a:lstStyle/>
           <a:p>
             <a:pPr eaLnBrk="1" hangingPunct="1">
-              <a:defRPr b="1" sz="1600">
+              <a:spcAft>
+                <a:spcPts val="200"/>
+              </a:spcAft>
+            </a:pPr>
+            <a:r>
+              <a:rPr sz="850" b="1">
+                <a:solidFill>
+                  <a:srgbClr val="EA580C"/>
+                </a:solidFill>
+                <a:latin typeface="Arial"/>
+              </a:rPr>
+              <a:t>NATIONAL CYBER DEFENSE, LEA EMPOWERMENT &amp; OPERATIONAL ROI</a:t>
+            </a:r>
+          </a:p>
+          <a:p>
+            <a:r>
+              <a:rPr sz="1700" b="1">
                 <a:solidFill>
                   <a:srgbClr val="0B2545"/>
                 </a:solidFill>
                 <a:latin typeface="Arial"/>
-              </a:defRPr>
-            </a:pPr>
-            <a:r>
-              <a:t>IMPACT AND BENEFITS: National Cyber Defense &amp; LEA Empowerment</a:t>
-            </a:r>
-          </a:p>
-        </p:txBody>
-      </p:sp>
-      <p:sp>
-        <p:nvSpPr>
-          <p:cNvPr id="17410" name="TextBox 8"/>
-          <p:cNvSpPr txBox="1">
-            <a:spLocks noChangeArrowheads="1"/>
-          </p:cNvSpPr>
-          <p:nvPr/>
-        </p:nvSpPr>
-        <p:spPr bwMode="auto">
-          <a:xfrm>
-            <a:off x="457200" y="1188720"/>
-            <a:ext cx="11247120" cy="5029200"/>
-          </a:xfrm>
-          <a:prstGeom prst="rect">
-            <a:avLst/>
-          </a:prstGeom>
-          <a:noFill/>
-          <a:ln w="9525">
-            <a:noFill/>
-            <a:miter lim="800000"/>
-            <a:headEnd/>
-            <a:tailEnd/>
-          </a:ln>
-        </p:spPr>
-        <p:txBody>
-          <a:bodyPr wrap="square">
-            <a:spAutoFit/>
-          </a:bodyPr>
-          <a:lstStyle/>
-          <a:p>
-            <a:pPr marL="342900" marR="0" lvl="0" indent="-342900" algn="just" defTabSz="457200" rtl="0" eaLnBrk="1" fontAlgn="base" latinLnBrk="0" hangingPunct="1">
-              <a:lnSpc>
-                <a:spcPct val="100000"/>
-              </a:lnSpc>
-              <a:spcBef>
-                <a:spcPct val="0"/>
-              </a:spcBef>
-              <a:spcAft>
-                <a:spcPct val="0"/>
-              </a:spcAft>
-              <a:buClrTx/>
-              <a:buSzTx/>
-              <a:buFont typeface="Arial" panose="020B0604020202020204" pitchFamily="34" charset="0"/>
-              <a:buChar char="•"/>
-              <a:tabLst/>
-              <a:defRPr/>
-            </a:pPr>
-          </a:p>
-          <a:p>
-            <a:r>
-              <a:rPr b="1" sz="1150">
-                <a:solidFill>
-                  <a:srgbClr val="EA580C"/>
-                </a:solidFill>
-                <a:latin typeface="Arial"/>
-              </a:rPr>
-              <a:t>1. Economic &amp; National Security Impact (Targeting Indian Financial Cyber Fraud)</a:t>
-            </a:r>
-          </a:p>
-          <a:p>
-            <a:pPr>
-              <a:spcAft>
-                <a:spcPts val="300"/>
-              </a:spcAft>
-            </a:pPr>
-            <a:r>
-              <a:rPr sz="950">
-                <a:solidFill>
-                  <a:srgbClr val="1E293B"/>
-                </a:solidFill>
-                <a:latin typeface="Calibri"/>
-              </a:rPr>
-              <a:t>• Neutralizing ₹1,750+ Crores in Cyber Fraud: Directly addresses the rampant financial losses reported by the Ministry of Home Affairs (MHA) and Indian Cyber Crime Coordination Centre (I4C) resulting from corporate BEC wire fraud and banking credential phishing.
-• Critical Infrastructure &amp; PSU Protection: Shields Indian defense institutions, public sector undertakings (PSUs), and government departments from advanced spearphishing impersonating nic.in or gov.in domains.
-• Democratizing Security for Indian MSMEs: Delivers high-grade email forensic capabilities to small businesses, schools, and hospitals that cannot afford ₹15–20 Lakh annual enterprise SEG licensing fees.</a:t>
-            </a:r>
-          </a:p>
-          <a:p>
-            <a:pPr>
-              <a:spcBef>
-                <a:spcPts val="300"/>
-              </a:spcBef>
-            </a:pPr>
-            <a:r>
-              <a:rPr b="1" sz="1150">
-                <a:solidFill>
-                  <a:srgbClr val="EA580C"/>
-                </a:solidFill>
-                <a:latin typeface="Arial"/>
-              </a:rPr>
-              <a:t>2. Direct Empowerment of Indian Law Enforcement Agencies (LEAs)</a:t>
-            </a:r>
-          </a:p>
-          <a:p>
-            <a:pPr>
-              <a:spcAft>
-                <a:spcPts val="300"/>
-              </a:spcAft>
-            </a:pPr>
-            <a:r>
-              <a:rPr sz="950">
-                <a:solidFill>
-                  <a:srgbClr val="1E293B"/>
-                </a:solidFill>
-                <a:latin typeface="Calibri"/>
-              </a:rPr>
-              <a:t>• Accelerating State Cyber Police Investigations: Equips state cyber cells (Telangana Cyber Security Bureau - TGCSB, Maharashtra Cyber, Delhi Cyber Cell) with instant originating MTA IP tracing, Autonomous System (ASN) lookup, and ISP identification.
-• Court-Admissible Forensic Dossiers: Automated PDF exports generate structured evidence packages compliant with Section 65B of the Indian Evidence Act / Bharatiya Sakshya Adhiniyam (BSA) for accelerated FIR registration and formal judicial submission.</a:t>
-            </a:r>
-          </a:p>
-          <a:p>
-            <a:pPr>
-              <a:spcBef>
-                <a:spcPts val="300"/>
-              </a:spcBef>
-            </a:pPr>
-            <a:r>
-              <a:rPr b="1" sz="1150">
-                <a:solidFill>
-                  <a:srgbClr val="EA580C"/>
-                </a:solidFill>
-                <a:latin typeface="Arial"/>
-              </a:rPr>
-              <a:t>3. Measurable Operational &amp; Environmental Gains</a:t>
-            </a:r>
-          </a:p>
-          <a:p>
-            <a:r>
-              <a:rPr sz="950">
-                <a:solidFill>
-                  <a:srgbClr val="1E293B"/>
-                </a:solidFill>
-                <a:latin typeface="Calibri"/>
-              </a:rPr>
-              <a:t>• 80% Reduction in Triage Time (MTTR): Slashes Mean Time to Triage from 25 minutes of manual terminal inspection down to under 5 seconds.
-• 100% Privacy Compliance: Eliminates compliance breach liabilities under the DPDP Act 2023 by ensuring email payloads never leave the local browser memory.
-• Green Serverless Footprint: Runs on existing client hardware without consuming continuous cloud GPU server energy.</a:t>
+              </a:rPr>
+              <a:t>IMPACT AND BENEFITS</a:t>
             </a:r>
           </a:p>
         </p:txBody>
@@ -8251,24 +8378,15 @@
               <a:buFontTx/>
               <a:buNone/>
               <a:tabLst/>
-              <a:defRPr/>
-            </a:pPr>
-            <a:r>
-              <a:rPr kumimoji="0" lang="en-US" sz="1200" b="0" i="0" u="none" strike="noStrike" kern="1200" cap="none" spc="0" normalizeH="0" baseline="0" noProof="0">
-                <a:ln>
-                  <a:noFill/>
-                </a:ln>
-                <a:solidFill>
-                  <a:prstClr val="white"/>
-                </a:solidFill>
-                <a:effectLst/>
-                <a:uLnTx/>
-                <a:uFillTx/>
-                <a:latin typeface="TradeGothic"/>
-                <a:ea typeface="+mn-ea"/>
-                <a:cs typeface="+mn-cs"/>
-              </a:rPr>
-              <a:t>@SIH Idea submission- Template</a:t>
+              <a:defRPr sz="850">
+                <a:solidFill>
+                  <a:srgbClr val="475569"/>
+                </a:solidFill>
+                <a:latin typeface="Calibri"/>
+              </a:defRPr>
+            </a:pPr>
+            <a:r>
+              <a:t>Smart India Hackathon 2026  |  Problem Statement ID: SIH26106  |  Team CyberCore  |  CVR College of Engineering</a:t>
             </a:r>
             <a:endParaRPr kumimoji="0" lang="en-US" sz="1200" b="0" i="0" u="none" strike="noStrike" kern="1200" cap="none" spc="0" normalizeH="0" baseline="0" noProof="0" dirty="0">
               <a:ln>
@@ -8319,14 +8437,14 @@
       </p:pic>
       <p:sp>
         <p:nvSpPr>
-          <p:cNvPr id="17411" name="Oval CyberCore Slide 5"/>
+          <p:cNvPr id="17410" name="Oval CyberCore Slide 5"/>
           <p:cNvSpPr/>
           <p:nvPr/>
         </p:nvSpPr>
         <p:spPr>
           <a:xfrm>
-            <a:off x="329184" y="182880"/>
-            <a:ext cx="1691640" cy="777240"/>
+            <a:off x="365760" y="164592"/>
+            <a:ext cx="1645920" cy="749808"/>
           </a:xfrm>
           <a:prstGeom prst="ellipse">
             <a:avLst/>
@@ -8334,7 +8452,7 @@
           <a:solidFill>
             <a:srgbClr val="EA580C"/>
           </a:solidFill>
-          <a:ln w="31750">
+          <a:ln w="27940">
             <a:solidFill>
               <a:srgbClr val="0B2545"/>
             </a:solidFill>
@@ -8367,6 +8485,440 @@
                 <a:latin typeface="Arial"/>
               </a:rPr>
               <a:t>CyberCore</a:t>
+            </a:r>
+          </a:p>
+        </p:txBody>
+      </p:sp>
+      <p:sp>
+        <p:nvSpPr>
+          <p:cNvPr id="17411" name="Rounded Rectangle 17410"/>
+          <p:cNvSpPr/>
+          <p:nvPr/>
+        </p:nvSpPr>
+        <p:spPr>
+          <a:xfrm>
+            <a:off x="365760" y="1188720"/>
+            <a:ext cx="3611880" cy="4983480"/>
+          </a:xfrm>
+          <a:prstGeom prst="roundRect">
+            <a:avLst/>
+          </a:prstGeom>
+          <a:solidFill>
+            <a:srgbClr val="F8FAFC"/>
+          </a:solidFill>
+          <a:ln w="15240">
+            <a:solidFill>
+              <a:srgbClr val="CBD5E1"/>
+            </a:solidFill>
+          </a:ln>
+        </p:spPr>
+        <p:style>
+          <a:lnRef idx="1">
+            <a:schemeClr val="accent1"/>
+          </a:lnRef>
+          <a:fillRef idx="3">
+            <a:schemeClr val="accent1"/>
+          </a:fillRef>
+          <a:effectRef idx="2">
+            <a:schemeClr val="accent1"/>
+          </a:effectRef>
+          <a:fontRef idx="minor">
+            <a:schemeClr val="lt1"/>
+          </a:fontRef>
+        </p:style>
+        <p:txBody>
+          <a:bodyPr rtlCol="0" anchor="ctr" wrap="square" lIns="182880" rIns="182880" tIns="164592" bIns="164592"/>
+          <a:lstStyle/>
+          <a:p>
+            <a:pPr algn="ctr">
+              <a:spcAft>
+                <a:spcPts val="600"/>
+              </a:spcAft>
+            </a:pPr>
+            <a:r>
+              <a:rPr sz="1100" b="1">
+                <a:solidFill>
+                  <a:srgbClr val="EA580C"/>
+                </a:solidFill>
+                <a:latin typeface="Arial"/>
+              </a:rPr>
+              <a:t>NATIONAL &amp; ECONOMIC DEFENSE</a:t>
+            </a:r>
+          </a:p>
+          <a:p>
+            <a:pPr>
+              <a:spcAft>
+                <a:spcPts val="300"/>
+              </a:spcAft>
+            </a:pPr>
+            <a:r>
+              <a:rPr sz="900" b="1">
+                <a:solidFill>
+                  <a:srgbClr val="0B2545"/>
+                </a:solidFill>
+                <a:latin typeface="Arial"/>
+              </a:rPr>
+              <a:t>• Targeting ₹1,750+ Cr Fraud:
+  </a:t>
+            </a:r>
+            <a:r>
+              <a:rPr sz="850">
+                <a:solidFill>
+                  <a:srgbClr val="1E293B"/>
+                </a:solidFill>
+                <a:latin typeface="Calibri"/>
+              </a:rPr>
+              <a:t>Directly addresses the rampant financial cyber fraud losses reported by the Ministry of Home Affairs (MHA) and Indian Cyber Crime Coordination Centre (I4C) from corporate BEC and banking credential phishing.</a:t>
+            </a:r>
+          </a:p>
+          <a:p>
+            <a:pPr>
+              <a:spcAft>
+                <a:spcPts val="300"/>
+              </a:spcAft>
+            </a:pPr>
+            <a:r>
+              <a:rPr sz="900" b="1">
+                <a:solidFill>
+                  <a:srgbClr val="0B2545"/>
+                </a:solidFill>
+                <a:latin typeface="Arial"/>
+              </a:rPr>
+              <a:t>• Critical Infrastructure Shield:
+  </a:t>
+            </a:r>
+            <a:r>
+              <a:rPr sz="850">
+                <a:solidFill>
+                  <a:srgbClr val="1E293B"/>
+                </a:solidFill>
+                <a:latin typeface="Calibri"/>
+              </a:rPr>
+              <a:t>Protects Indian PSUs, defense establishments, and public sectors from advanced spearphishing impersonating nic.in and gov.in domains.</a:t>
+            </a:r>
+          </a:p>
+          <a:p>
+            <a:pPr>
+              <a:spcAft>
+                <a:spcPts val="300"/>
+              </a:spcAft>
+            </a:pPr>
+            <a:r>
+              <a:rPr sz="900" b="1">
+                <a:solidFill>
+                  <a:srgbClr val="0B2545"/>
+                </a:solidFill>
+                <a:latin typeface="Arial"/>
+              </a:rPr>
+              <a:t>• Democratizing Security:
+  </a:t>
+            </a:r>
+            <a:r>
+              <a:rPr sz="850">
+                <a:solidFill>
+                  <a:srgbClr val="1E293B"/>
+                </a:solidFill>
+                <a:latin typeface="Calibri"/>
+              </a:rPr>
+              <a:t>Delivers high-grade email forensic capabilities to Indian MSMEs, schools, and hospitals that cannot afford ₹15–20 Lakh annual enterprise SEG licensing fees.</a:t>
+            </a:r>
+          </a:p>
+        </p:txBody>
+      </p:sp>
+      <p:sp>
+        <p:nvSpPr>
+          <p:cNvPr id="17412" name="Rounded Rectangle 17411"/>
+          <p:cNvSpPr/>
+          <p:nvPr/>
+        </p:nvSpPr>
+        <p:spPr>
+          <a:xfrm>
+            <a:off x="4160520" y="1188720"/>
+            <a:ext cx="3611880" cy="4983480"/>
+          </a:xfrm>
+          <a:prstGeom prst="roundRect">
+            <a:avLst/>
+          </a:prstGeom>
+          <a:solidFill>
+            <a:srgbClr val="F8FAFC"/>
+          </a:solidFill>
+          <a:ln w="15240">
+            <a:solidFill>
+              <a:srgbClr val="CBD5E1"/>
+            </a:solidFill>
+          </a:ln>
+        </p:spPr>
+        <p:style>
+          <a:lnRef idx="1">
+            <a:schemeClr val="accent1"/>
+          </a:lnRef>
+          <a:fillRef idx="3">
+            <a:schemeClr val="accent1"/>
+          </a:fillRef>
+          <a:effectRef idx="2">
+            <a:schemeClr val="accent1"/>
+          </a:effectRef>
+          <a:fontRef idx="minor">
+            <a:schemeClr val="lt1"/>
+          </a:fontRef>
+        </p:style>
+        <p:txBody>
+          <a:bodyPr rtlCol="0" anchor="ctr" wrap="square" lIns="182880" rIns="182880" tIns="164592" bIns="164592"/>
+          <a:lstStyle/>
+          <a:p>
+            <a:pPr algn="ctr">
+              <a:spcAft>
+                <a:spcPts val="600"/>
+              </a:spcAft>
+            </a:pPr>
+            <a:r>
+              <a:rPr sz="1100" b="1">
+                <a:solidFill>
+                  <a:srgbClr val="EA580C"/>
+                </a:solidFill>
+                <a:latin typeface="Arial"/>
+              </a:rPr>
+              <a:t>LAW ENFORCEMENT EMPOWERMENT</a:t>
+            </a:r>
+          </a:p>
+          <a:p>
+            <a:pPr>
+              <a:spcAft>
+                <a:spcPts val="300"/>
+              </a:spcAft>
+            </a:pPr>
+            <a:r>
+              <a:rPr sz="900" b="1">
+                <a:solidFill>
+                  <a:srgbClr val="0B2545"/>
+                </a:solidFill>
+                <a:latin typeface="Arial"/>
+              </a:rPr>
+              <a:t>• Accelerating Cyber Police:
+  </a:t>
+            </a:r>
+            <a:r>
+              <a:rPr sz="850">
+                <a:solidFill>
+                  <a:srgbClr val="1E293B"/>
+                </a:solidFill>
+                <a:latin typeface="Calibri"/>
+              </a:rPr>
+              <a:t>Equips state cyber cells (Telangana Cyber Security Bureau - TGCSB, Maharashtra Cyber, Delhi Cyber Police) with instant origin IP geolocation, transit MTA hop tracing, and ISP identification.</a:t>
+            </a:r>
+          </a:p>
+          <a:p>
+            <a:pPr>
+              <a:spcAft>
+                <a:spcPts val="300"/>
+              </a:spcAft>
+            </a:pPr>
+            <a:r>
+              <a:rPr sz="900" b="1">
+                <a:solidFill>
+                  <a:srgbClr val="0B2545"/>
+                </a:solidFill>
+                <a:latin typeface="Arial"/>
+              </a:rPr>
+              <a:t>• Section 65B BSA Evidence:
+  </a:t>
+            </a:r>
+            <a:r>
+              <a:rPr sz="850">
+                <a:solidFill>
+                  <a:srgbClr val="1E293B"/>
+                </a:solidFill>
+                <a:latin typeface="Calibri"/>
+              </a:rPr>
+              <a:t>Automated PDF exports generate structured evidence packages compliant with Section 65B of the Indian Evidence Act / Bharatiya Sakshya Adhiniyam (BSA) for accelerated FIR registration and formal judicial submission.</a:t>
+            </a:r>
+          </a:p>
+          <a:p>
+            <a:pPr>
+              <a:spcAft>
+                <a:spcPts val="300"/>
+              </a:spcAft>
+            </a:pPr>
+            <a:r>
+              <a:rPr sz="900" b="1">
+                <a:solidFill>
+                  <a:srgbClr val="0B2545"/>
+                </a:solidFill>
+                <a:latin typeface="Arial"/>
+              </a:rPr>
+              <a:t>• Tackling BEC Hubs:
+  </a:t>
+            </a:r>
+            <a:r>
+              <a:rPr sz="850">
+                <a:solidFill>
+                  <a:srgbClr val="1E293B"/>
+                </a:solidFill>
+                <a:latin typeface="Calibri"/>
+              </a:rPr>
+              <a:t>Exposes international money-mule relay corridors targeting Indian corporate treasury desks.</a:t>
+            </a:r>
+          </a:p>
+        </p:txBody>
+      </p:sp>
+      <p:sp>
+        <p:nvSpPr>
+          <p:cNvPr id="17413" name="Rounded Rectangle 17412"/>
+          <p:cNvSpPr/>
+          <p:nvPr/>
+        </p:nvSpPr>
+        <p:spPr>
+          <a:xfrm>
+            <a:off x="7955279" y="1188720"/>
+            <a:ext cx="3840480" cy="4983480"/>
+          </a:xfrm>
+          <a:prstGeom prst="roundRect">
+            <a:avLst/>
+          </a:prstGeom>
+          <a:solidFill>
+            <a:srgbClr val="F8FAFC"/>
+          </a:solidFill>
+          <a:ln w="15240">
+            <a:solidFill>
+              <a:srgbClr val="CBD5E1"/>
+            </a:solidFill>
+          </a:ln>
+        </p:spPr>
+        <p:style>
+          <a:lnRef idx="1">
+            <a:schemeClr val="accent1"/>
+          </a:lnRef>
+          <a:fillRef idx="3">
+            <a:schemeClr val="accent1"/>
+          </a:fillRef>
+          <a:effectRef idx="2">
+            <a:schemeClr val="accent1"/>
+          </a:effectRef>
+          <a:fontRef idx="minor">
+            <a:schemeClr val="lt1"/>
+          </a:fontRef>
+        </p:style>
+        <p:txBody>
+          <a:bodyPr rtlCol="0" anchor="ctr" wrap="square" lIns="182880" rIns="182880" tIns="164592" bIns="164592"/>
+          <a:lstStyle/>
+          <a:p>
+            <a:pPr algn="ctr">
+              <a:spcAft>
+                <a:spcPts val="600"/>
+              </a:spcAft>
+            </a:pPr>
+            <a:r>
+              <a:rPr sz="1100" b="1">
+                <a:solidFill>
+                  <a:srgbClr val="EA580C"/>
+                </a:solidFill>
+                <a:latin typeface="Arial"/>
+              </a:rPr>
+              <a:t>OPERATIONAL &amp; SUSTAINABLE ROI</a:t>
+            </a:r>
+          </a:p>
+          <a:p>
+            <a:pPr>
+              <a:spcAft>
+                <a:spcPts val="300"/>
+              </a:spcAft>
+            </a:pPr>
+            <a:r>
+              <a:rPr sz="900" b="1">
+                <a:solidFill>
+                  <a:srgbClr val="0B2545"/>
+                </a:solidFill>
+                <a:latin typeface="Arial"/>
+              </a:rPr>
+              <a:t>• 80% Reduction in MTTR:
+  </a:t>
+            </a:r>
+            <a:r>
+              <a:rPr sz="850">
+                <a:solidFill>
+                  <a:srgbClr val="1E293B"/>
+                </a:solidFill>
+                <a:latin typeface="Calibri"/>
+              </a:rPr>
+              <a:t>Slashes Mean Time to Triage from 25 minutes of manual terminal inspection down to under 5 seconds per suspicious email.</a:t>
+            </a:r>
+          </a:p>
+          <a:p>
+            <a:pPr>
+              <a:spcAft>
+                <a:spcPts val="300"/>
+              </a:spcAft>
+            </a:pPr>
+            <a:r>
+              <a:rPr sz="900" b="1">
+                <a:solidFill>
+                  <a:srgbClr val="0B2545"/>
+                </a:solidFill>
+                <a:latin typeface="Arial"/>
+              </a:rPr>
+              <a:t>• 100% Privacy Compliance:
+  </a:t>
+            </a:r>
+            <a:r>
+              <a:rPr sz="850">
+                <a:solidFill>
+                  <a:srgbClr val="1E293B"/>
+                </a:solidFill>
+                <a:latin typeface="Calibri"/>
+              </a:rPr>
+              <a:t>Eliminates compliance breach liabilities under the DPDP Act 2023 by ensuring email payloads never leave the local browser memory.</a:t>
+            </a:r>
+          </a:p>
+          <a:p>
+            <a:pPr>
+              <a:spcAft>
+                <a:spcPts val="300"/>
+              </a:spcAft>
+            </a:pPr>
+            <a:r>
+              <a:rPr sz="900" b="1">
+                <a:solidFill>
+                  <a:srgbClr val="0B2545"/>
+                </a:solidFill>
+                <a:latin typeface="Arial"/>
+              </a:rPr>
+              <a:t>• Green Serverless Footprint:
+  </a:t>
+            </a:r>
+            <a:r>
+              <a:rPr sz="850">
+                <a:solidFill>
+                  <a:srgbClr val="1E293B"/>
+                </a:solidFill>
+                <a:latin typeface="Calibri"/>
+              </a:rPr>
+              <a:t>Runs entirely on existing client workstation compute, requiring zero 24/7 dedicated cloud GPU server energy.</a:t>
+            </a:r>
+          </a:p>
+          <a:p>
+            <a:pPr>
+              <a:spcAft>
+                <a:spcPts val="300"/>
+              </a:spcAft>
+            </a:pPr>
+            <a:r>
+              <a:rPr sz="900" b="1">
+                <a:solidFill>
+                  <a:srgbClr val="0B2545"/>
+                </a:solidFill>
+                <a:latin typeface="Arial"/>
+              </a:rPr>
+              <a:t>• Democratized SOC Triage:
+  </a:t>
+            </a:r>
+            <a:r>
+              <a:rPr sz="850">
+                <a:solidFill>
+                  <a:srgbClr val="1E293B"/>
+                </a:solidFill>
+                <a:latin typeface="Calibri"/>
+              </a:rPr>
+              <a:t>Enables junior Level-1 analysts to conduct Level-3 deep forensic triage without specialized training.</a:t>
             </a:r>
           </a:p>
         </p:txBody>
@@ -8492,182 +9044,38 @@
         </p:nvSpPr>
         <p:spPr>
           <a:xfrm>
-            <a:off x="2148840" y="137160"/>
-            <a:ext cx="7498079" cy="914400"/>
+            <a:off x="2194560" y="137160"/>
+            <a:ext cx="7406640" cy="868680"/>
           </a:xfrm>
         </p:spPr>
         <p:txBody>
-          <a:bodyPr/>
+          <a:bodyPr wrap="square"/>
           <a:lstStyle/>
           <a:p>
             <a:pPr eaLnBrk="1" hangingPunct="1">
-              <a:defRPr b="1" sz="1600">
+              <a:spcAft>
+                <a:spcPts val="200"/>
+              </a:spcAft>
+            </a:pPr>
+            <a:r>
+              <a:rPr sz="850" b="1">
+                <a:solidFill>
+                  <a:srgbClr val="EA580C"/>
+                </a:solidFill>
+                <a:latin typeface="Arial"/>
+              </a:rPr>
+              <a:t>STANDARDS REVIEW, PRIOR ART GAP CLOSURE &amp; TEAM PERSONA</a:t>
+            </a:r>
+          </a:p>
+          <a:p>
+            <a:r>
+              <a:rPr sz="1700" b="1">
                 <a:solidFill>
                   <a:srgbClr val="0B2545"/>
                 </a:solidFill>
                 <a:latin typeface="Arial"/>
-              </a:defRPr>
-            </a:pPr>
-            <a:r>
-              <a:t>RESEARCH AND REFERENCES: Prior Art Review &amp; Identified Gaps</a:t>
-            </a:r>
-          </a:p>
-        </p:txBody>
-      </p:sp>
-      <p:sp>
-        <p:nvSpPr>
-          <p:cNvPr id="17410" name="TextBox 8"/>
-          <p:cNvSpPr txBox="1">
-            <a:spLocks noChangeArrowheads="1"/>
-          </p:cNvSpPr>
-          <p:nvPr/>
-        </p:nvSpPr>
-        <p:spPr bwMode="auto">
-          <a:xfrm>
-            <a:off x="457200" y="1188720"/>
-            <a:ext cx="11247120" cy="5029200"/>
-          </a:xfrm>
-          <a:prstGeom prst="rect">
-            <a:avLst/>
-          </a:prstGeom>
-          <a:noFill/>
-          <a:ln w="9525">
-            <a:noFill/>
-            <a:miter lim="800000"/>
-            <a:headEnd/>
-            <a:tailEnd/>
-          </a:ln>
-        </p:spPr>
-        <p:txBody>
-          <a:bodyPr wrap="square">
-            <a:spAutoFit/>
-          </a:bodyPr>
-          <a:lstStyle/>
-          <a:p>
-            <a:pPr marL="342900" marR="0" lvl="0" indent="-342900" algn="just" defTabSz="457200" rtl="0" eaLnBrk="1" fontAlgn="base" latinLnBrk="0" hangingPunct="1">
-              <a:lnSpc>
-                <a:spcPct val="100000"/>
-              </a:lnSpc>
-              <a:spcBef>
-                <a:spcPct val="0"/>
-              </a:spcBef>
-              <a:spcAft>
-                <a:spcPct val="0"/>
-              </a:spcAft>
-              <a:buClrTx/>
-              <a:buSzTx/>
-              <a:buFont typeface="Arial" panose="020B0604020202020204" pitchFamily="34" charset="0"/>
-              <a:buChar char="•"/>
-              <a:tabLst/>
-              <a:defRPr/>
-            </a:pPr>
-            <a:endParaRPr kumimoji="0" lang="en-US" sz="2800" b="0" i="0" u="none" strike="noStrike" kern="1200" cap="none" spc="0" normalizeH="0" baseline="0" noProof="0" dirty="0">
-              <a:ln>
-                <a:noFill/>
-              </a:ln>
-              <a:solidFill>
-                <a:prstClr val="black"/>
-              </a:solidFill>
-              <a:effectLst/>
-              <a:uLnTx/>
-              <a:uFillTx/>
-              <a:latin typeface="Arial" pitchFamily="34" charset="0"/>
-              <a:ea typeface="ＭＳ Ｐゴシック" pitchFamily="1" charset="-128"/>
-              <a:cs typeface="Arial" pitchFamily="34" charset="0"/>
-            </a:endParaRPr>
-          </a:p>
-          <a:p>
-            <a:r>
-              <a:rPr b="1" sz="1150">
-                <a:solidFill>
-                  <a:srgbClr val="EA580C"/>
-                </a:solidFill>
-                <a:latin typeface="Arial"/>
-              </a:rPr>
-              <a:t>1. Technical Standards &amp; Prior Art Reviewed (Design Gaps Closed)</a:t>
-            </a:r>
-          </a:p>
-          <a:p>
-            <a:pPr>
-              <a:spcAft>
-                <a:spcPts val="400"/>
-              </a:spcAft>
-            </a:pPr>
-            <a:r>
-              <a:rPr sz="950">
-                <a:solidFill>
-                  <a:srgbClr val="1E293B"/>
-                </a:solidFill>
-                <a:latin typeface="Calibri"/>
-              </a:rPr>
-              <a:t>• RFC Standards (RFC 5322 - Internet Message Format, RFC 7208 - SPF, RFC 6376 - DKIM, RFC 7489 - DMARC):
-  - Prior Art Gap: Protocols define cryptographic checks in silos; existing utilities fail to provide a single-pane synthesized alignment view.
-  - ThreatLens Advancement: Unifies SPF, DKIM, and DMARC into a correlated matrix with automated policy diagnosis and DNS TXT evidence.
-• MITRE ATT&amp;CK Enterprise Matrix (v14):
-  - Prior Art Gap: Incident responders manually correlate log alerts to MITRE techniques.
-  - ThreatLens Advancement: Automatically maps parsed header irregularities to T1566 (Phishing), T1566.001 (Spearphishing Attachment), and T1566.002 (Spearphishing Link).</a:t>
-            </a:r>
-          </a:p>
-          <a:p>
-            <a:pPr>
-              <a:spcBef>
-                <a:spcPts val="300"/>
-              </a:spcBef>
-            </a:pPr>
-            <a:r>
-              <a:rPr b="1" sz="1150">
-                <a:solidFill>
-                  <a:srgbClr val="EA580C"/>
-                </a:solidFill>
-                <a:latin typeface="Arial"/>
-              </a:rPr>
-              <a:t>2. Government, Academic &amp; Intelligence References</a:t>
-            </a:r>
-          </a:p>
-          <a:p>
-            <a:pPr>
-              <a:spcAft>
-                <a:spcPts val="400"/>
-              </a:spcAft>
-            </a:pPr>
-            <a:r>
-              <a:rPr sz="950">
-                <a:solidFill>
-                  <a:srgbClr val="1E293B"/>
-                </a:solidFill>
-                <a:latin typeface="Calibri"/>
-              </a:rPr>
-              <a:t>1. NIST Special Publication 800-177 Rev. 1: Trustworthy Email Guide (Architectural foundation for cryptographic verification).
-2. CERT-In Cyber Security Incident Notes &amp; Advisories: Empirical benchmark for prevalent Indian malware droppers and credential phishing campaigns.
-3. Indian Cyber Crime Coordination Centre (I4C), MHA: National cyber fraud statistics and Citizen Financial Cyber Fraud Reporting System.
-4. AbuseIPDB &amp; URLhaus Intelligence Repositories: Active blacklists and known malicious MTA exit node feeds.</a:t>
-            </a:r>
-          </a:p>
-          <a:p>
-            <a:pPr>
-              <a:spcBef>
-                <a:spcPts val="300"/>
-              </a:spcBef>
-            </a:pPr>
-            <a:r>
-              <a:rPr b="1" sz="1150">
-                <a:solidFill>
-                  <a:srgbClr val="EA580C"/>
-                </a:solidFill>
-                <a:latin typeface="Arial"/>
-              </a:rPr>
-              <a:t>3. Team Persona &amp; Authentic Research Philosophy</a:t>
-            </a:r>
-          </a:p>
-          <a:p>
-            <a:r>
-              <a:rPr sz="950">
-                <a:solidFill>
-                  <a:srgbClr val="1E293B"/>
-                </a:solidFill>
-                <a:latin typeface="Calibri"/>
-              </a:rPr>
-              <a:t>Engineered by Team CyberCore, Department of CSE (Cyber Security), CVR College of Engineering. Built from direct frontline research into the practical pain points of SOC analysts and Indian law enforcement, prioritizing zero-trust data privacy, parsimonious execution, and actionable operational defense over theoretical complexity.</a:t>
+              </a:rPr>
+              <a:t>RESEARCH AND REFERENCES</a:t>
             </a:r>
           </a:p>
         </p:txBody>
@@ -8790,24 +9198,15 @@
               <a:buFontTx/>
               <a:buNone/>
               <a:tabLst/>
-              <a:defRPr/>
-            </a:pPr>
-            <a:r>
-              <a:rPr kumimoji="0" lang="en-US" sz="1200" b="0" i="0" u="none" strike="noStrike" kern="1200" cap="none" spc="0" normalizeH="0" baseline="0" noProof="0">
-                <a:ln>
-                  <a:noFill/>
-                </a:ln>
-                <a:solidFill>
-                  <a:prstClr val="white"/>
-                </a:solidFill>
-                <a:effectLst/>
-                <a:uLnTx/>
-                <a:uFillTx/>
-                <a:latin typeface="TradeGothic"/>
-                <a:ea typeface="+mn-ea"/>
-                <a:cs typeface="+mn-cs"/>
-              </a:rPr>
-              <a:t>@SIH Idea submission- Template</a:t>
+              <a:defRPr sz="850">
+                <a:solidFill>
+                  <a:srgbClr val="475569"/>
+                </a:solidFill>
+                <a:latin typeface="Calibri"/>
+              </a:defRPr>
+            </a:pPr>
+            <a:r>
+              <a:t>Smart India Hackathon 2026  |  Problem Statement ID: SIH26106  |  Team CyberCore  |  CVR College of Engineering</a:t>
             </a:r>
             <a:endParaRPr kumimoji="0" lang="en-US" sz="1200" b="0" i="0" u="none" strike="noStrike" kern="1200" cap="none" spc="0" normalizeH="0" baseline="0" noProof="0" dirty="0">
               <a:ln>
@@ -8858,14 +9257,14 @@
       </p:pic>
       <p:sp>
         <p:nvSpPr>
-          <p:cNvPr id="17411" name="Oval CyberCore Slide 6"/>
+          <p:cNvPr id="17410" name="Oval CyberCore Slide 6"/>
           <p:cNvSpPr/>
           <p:nvPr/>
         </p:nvSpPr>
         <p:spPr>
           <a:xfrm>
-            <a:off x="329184" y="182880"/>
-            <a:ext cx="1691640" cy="777240"/>
+            <a:off x="365760" y="164592"/>
+            <a:ext cx="1645920" cy="749808"/>
           </a:xfrm>
           <a:prstGeom prst="ellipse">
             <a:avLst/>
@@ -8873,7 +9272,7 @@
           <a:solidFill>
             <a:srgbClr val="EA580C"/>
           </a:solidFill>
-          <a:ln w="31750">
+          <a:ln w="27940">
             <a:solidFill>
               <a:srgbClr val="0B2545"/>
             </a:solidFill>
@@ -8906,6 +9305,376 @@
                 <a:latin typeface="Arial"/>
               </a:rPr>
               <a:t>CyberCore</a:t>
+            </a:r>
+          </a:p>
+        </p:txBody>
+      </p:sp>
+      <p:sp>
+        <p:nvSpPr>
+          <p:cNvPr id="17411" name="Rounded Rectangle 17410"/>
+          <p:cNvSpPr/>
+          <p:nvPr/>
+        </p:nvSpPr>
+        <p:spPr>
+          <a:xfrm>
+            <a:off x="365760" y="1188720"/>
+            <a:ext cx="3657600" cy="4983480"/>
+          </a:xfrm>
+          <a:prstGeom prst="roundRect">
+            <a:avLst/>
+          </a:prstGeom>
+          <a:solidFill>
+            <a:srgbClr val="F8FAFC"/>
+          </a:solidFill>
+          <a:ln w="15240">
+            <a:solidFill>
+              <a:srgbClr val="CBD5E1"/>
+            </a:solidFill>
+          </a:ln>
+        </p:spPr>
+        <p:style>
+          <a:lnRef idx="1">
+            <a:schemeClr val="accent1"/>
+          </a:lnRef>
+          <a:fillRef idx="3">
+            <a:schemeClr val="accent1"/>
+          </a:fillRef>
+          <a:effectRef idx="2">
+            <a:schemeClr val="accent1"/>
+          </a:effectRef>
+          <a:fontRef idx="minor">
+            <a:schemeClr val="lt1"/>
+          </a:fontRef>
+        </p:style>
+        <p:txBody>
+          <a:bodyPr rtlCol="0" anchor="ctr" wrap="square" lIns="182880" rIns="182880" tIns="164592" bIns="164592"/>
+          <a:lstStyle/>
+          <a:p>
+            <a:pPr algn="ctr">
+              <a:spcAft>
+                <a:spcPts val="600"/>
+              </a:spcAft>
+            </a:pPr>
+            <a:r>
+              <a:rPr sz="1100" b="1">
+                <a:solidFill>
+                  <a:srgbClr val="EA580C"/>
+                </a:solidFill>
+                <a:latin typeface="Arial"/>
+              </a:rPr>
+              <a:t>STANDARDS CRITIQUE &amp; GAPS CLOSED</a:t>
+            </a:r>
+          </a:p>
+          <a:p>
+            <a:pPr>
+              <a:spcAft>
+                <a:spcPts val="300"/>
+              </a:spcAft>
+            </a:pPr>
+            <a:r>
+              <a:rPr sz="900" b="1">
+                <a:solidFill>
+                  <a:srgbClr val="0B2545"/>
+                </a:solidFill>
+                <a:latin typeface="Arial"/>
+              </a:rPr>
+              <a:t>• RFC Standards (5322, 7208, 6376, 7489):
+</a:t>
+            </a:r>
+            <a:r>
+              <a:rPr sz="850">
+                <a:solidFill>
+                  <a:srgbClr val="1E293B"/>
+                </a:solidFill>
+                <a:latin typeface="Calibri"/>
+              </a:rPr>
+              <a:t>Prior Art Gap: Protocols define authentication primitives in isolation; existing tools fail to provide a single-pane synthesized alignment view.
+ThreatLens Solution: Correlates SPF, DKIM, and DMARC simultaneously with automated policy diagnostics and raw DNS TXT snippets.</a:t>
+            </a:r>
+          </a:p>
+          <a:p>
+            <a:pPr>
+              <a:spcAft>
+                <a:spcPts val="300"/>
+              </a:spcAft>
+            </a:pPr>
+            <a:r>
+              <a:rPr sz="900" b="1">
+                <a:solidFill>
+                  <a:srgbClr val="0B2545"/>
+                </a:solidFill>
+                <a:latin typeface="Arial"/>
+              </a:rPr>
+              <a:t>• MITRE ATT&amp;CK Enterprise Matrix (v14):
+</a:t>
+            </a:r>
+            <a:r>
+              <a:rPr sz="850">
+                <a:solidFill>
+                  <a:srgbClr val="1E293B"/>
+                </a:solidFill>
+                <a:latin typeface="Calibri"/>
+              </a:rPr>
+              <a:t>Prior Art Gap: Analysts manually correlate log alerts to ATT&amp;CK tactics.
+ThreatLens Solution: Automatically maps parsed header irregularities to T1566 (Phishing), T1566.001 (Attachment), and T1566.002 (Link).</a:t>
+            </a:r>
+          </a:p>
+        </p:txBody>
+      </p:sp>
+      <p:sp>
+        <p:nvSpPr>
+          <p:cNvPr id="17412" name="Rounded Rectangle 17411"/>
+          <p:cNvSpPr/>
+          <p:nvPr/>
+        </p:nvSpPr>
+        <p:spPr>
+          <a:xfrm>
+            <a:off x="4206240" y="1188720"/>
+            <a:ext cx="3657600" cy="4983480"/>
+          </a:xfrm>
+          <a:prstGeom prst="roundRect">
+            <a:avLst/>
+          </a:prstGeom>
+          <a:solidFill>
+            <a:srgbClr val="F8FAFC"/>
+          </a:solidFill>
+          <a:ln w="15240">
+            <a:solidFill>
+              <a:srgbClr val="CBD5E1"/>
+            </a:solidFill>
+          </a:ln>
+        </p:spPr>
+        <p:style>
+          <a:lnRef idx="1">
+            <a:schemeClr val="accent1"/>
+          </a:lnRef>
+          <a:fillRef idx="3">
+            <a:schemeClr val="accent1"/>
+          </a:fillRef>
+          <a:effectRef idx="2">
+            <a:schemeClr val="accent1"/>
+          </a:effectRef>
+          <a:fontRef idx="minor">
+            <a:schemeClr val="lt1"/>
+          </a:fontRef>
+        </p:style>
+        <p:txBody>
+          <a:bodyPr rtlCol="0" anchor="ctr" wrap="square" lIns="182880" rIns="182880" tIns="164592" bIns="164592"/>
+          <a:lstStyle/>
+          <a:p>
+            <a:pPr algn="ctr">
+              <a:spcAft>
+                <a:spcPts val="600"/>
+              </a:spcAft>
+            </a:pPr>
+            <a:r>
+              <a:rPr sz="1100" b="1">
+                <a:solidFill>
+                  <a:srgbClr val="EA580C"/>
+                </a:solidFill>
+                <a:latin typeface="Arial"/>
+              </a:rPr>
+              <a:t>GOVERNMENT &amp; INDUSTRY REFERENCES</a:t>
+            </a:r>
+          </a:p>
+          <a:p>
+            <a:pPr>
+              <a:spcAft>
+                <a:spcPts val="300"/>
+              </a:spcAft>
+            </a:pPr>
+            <a:r>
+              <a:rPr sz="900" b="1">
+                <a:solidFill>
+                  <a:srgbClr val="0B2545"/>
+                </a:solidFill>
+                <a:latin typeface="Arial"/>
+              </a:rPr>
+              <a:t>1. NIST SP 800-177 Rev. 1:
+</a:t>
+            </a:r>
+            <a:r>
+              <a:rPr sz="850">
+                <a:solidFill>
+                  <a:srgbClr val="1E293B"/>
+                </a:solidFill>
+                <a:latin typeface="Calibri"/>
+              </a:rPr>
+              <a:t>Trustworthy Email Guide (Architectural foundation for cryptographic verification).</a:t>
+            </a:r>
+          </a:p>
+          <a:p>
+            <a:pPr>
+              <a:spcAft>
+                <a:spcPts val="300"/>
+              </a:spcAft>
+            </a:pPr>
+            <a:r>
+              <a:rPr sz="900" b="1">
+                <a:solidFill>
+                  <a:srgbClr val="0B2545"/>
+                </a:solidFill>
+                <a:latin typeface="Arial"/>
+              </a:rPr>
+              <a:t>2. CERT-In Incident Advisories:
+</a:t>
+            </a:r>
+            <a:r>
+              <a:rPr sz="850">
+                <a:solidFill>
+                  <a:srgbClr val="1E293B"/>
+                </a:solidFill>
+                <a:latin typeface="Calibri"/>
+              </a:rPr>
+              <a:t>Empirical benchmark for prevalent Indian malware droppers and credential phishing campaigns.</a:t>
+            </a:r>
+          </a:p>
+          <a:p>
+            <a:pPr>
+              <a:spcAft>
+                <a:spcPts val="300"/>
+              </a:spcAft>
+            </a:pPr>
+            <a:r>
+              <a:rPr sz="900" b="1">
+                <a:solidFill>
+                  <a:srgbClr val="0B2545"/>
+                </a:solidFill>
+                <a:latin typeface="Arial"/>
+              </a:rPr>
+              <a:t>3. I4C (Ministry of Home Affairs):
+</a:t>
+            </a:r>
+            <a:r>
+              <a:rPr sz="850">
+                <a:solidFill>
+                  <a:srgbClr val="1E293B"/>
+                </a:solidFill>
+                <a:latin typeface="Calibri"/>
+              </a:rPr>
+              <a:t>National cyber fraud statistics and Citizen Financial Cyber Fraud Reporting System.</a:t>
+            </a:r>
+          </a:p>
+          <a:p>
+            <a:pPr>
+              <a:spcAft>
+                <a:spcPts val="300"/>
+              </a:spcAft>
+            </a:pPr>
+            <a:r>
+              <a:rPr sz="900" b="1">
+                <a:solidFill>
+                  <a:srgbClr val="0B2545"/>
+                </a:solidFill>
+                <a:latin typeface="Arial"/>
+              </a:rPr>
+              <a:t>4. AbuseIPDB &amp; URLhaus:
+</a:t>
+            </a:r>
+            <a:r>
+              <a:rPr sz="850">
+                <a:solidFill>
+                  <a:srgbClr val="1E293B"/>
+                </a:solidFill>
+                <a:latin typeface="Calibri"/>
+              </a:rPr>
+              <a:t>Active blacklists and known malicious MTA exit node intelligence feeds.</a:t>
+            </a:r>
+          </a:p>
+        </p:txBody>
+      </p:sp>
+      <p:sp>
+        <p:nvSpPr>
+          <p:cNvPr id="17413" name="Rounded Rectangle 17412"/>
+          <p:cNvSpPr/>
+          <p:nvPr/>
+        </p:nvSpPr>
+        <p:spPr>
+          <a:xfrm>
+            <a:off x="8046720" y="1188720"/>
+            <a:ext cx="3749039" cy="4983480"/>
+          </a:xfrm>
+          <a:prstGeom prst="roundRect">
+            <a:avLst/>
+          </a:prstGeom>
+          <a:solidFill>
+            <a:srgbClr val="F8FAFC"/>
+          </a:solidFill>
+          <a:ln w="15240">
+            <a:solidFill>
+              <a:srgbClr val="CBD5E1"/>
+            </a:solidFill>
+          </a:ln>
+        </p:spPr>
+        <p:style>
+          <a:lnRef idx="1">
+            <a:schemeClr val="accent1"/>
+          </a:lnRef>
+          <a:fillRef idx="3">
+            <a:schemeClr val="accent1"/>
+          </a:fillRef>
+          <a:effectRef idx="2">
+            <a:schemeClr val="accent1"/>
+          </a:effectRef>
+          <a:fontRef idx="minor">
+            <a:schemeClr val="lt1"/>
+          </a:fontRef>
+        </p:style>
+        <p:txBody>
+          <a:bodyPr rtlCol="0" anchor="ctr" wrap="square" lIns="182880" rIns="182880" tIns="164592" bIns="164592"/>
+          <a:lstStyle/>
+          <a:p>
+            <a:pPr algn="ctr">
+              <a:spcAft>
+                <a:spcPts val="600"/>
+              </a:spcAft>
+            </a:pPr>
+            <a:r>
+              <a:rPr sz="1100" b="1">
+                <a:solidFill>
+                  <a:srgbClr val="EA580C"/>
+                </a:solidFill>
+                <a:latin typeface="Arial"/>
+              </a:rPr>
+              <a:t>TEAM PERSONA &amp; RESEARCH ETHOS</a:t>
+            </a:r>
+          </a:p>
+          <a:p>
+            <a:pPr>
+              <a:spcAft>
+                <a:spcPts val="300"/>
+              </a:spcAft>
+            </a:pPr>
+            <a:r>
+              <a:rPr sz="950" b="1">
+                <a:solidFill>
+                  <a:srgbClr val="EA580C"/>
+                </a:solidFill>
+                <a:latin typeface="Arial"/>
+              </a:rPr>
+              <a:t>ENGINEERED BY TEAM CYBERCORE
+</a:t>
+            </a:r>
+            <a:r>
+              <a:rPr sz="900" b="1">
+                <a:solidFill>
+                  <a:srgbClr val="0B2545"/>
+                </a:solidFill>
+                <a:latin typeface="Arial"/>
+              </a:rPr>
+              <a:t>Department of CSE (Cyber Security)
+CVR College of Engineering
+</a:t>
+            </a:r>
+            <a:r>
+              <a:rPr sz="850">
+                <a:solidFill>
+                  <a:srgbClr val="1E293B"/>
+                </a:solidFill>
+                <a:latin typeface="Calibri"/>
+              </a:rPr>
+              <a:t>Our research ethos stems from direct frontline engagement with the practical bottlenecks of SOC Tier-1 analysts and Indian law enforcement agencies.
+Rather than proposing impractical, over-engineered theoretical models, ThreatLens AI enforces strict client-side data privacy, parsimonious execution, and actionable operational defense designed to stop real-world cyber fraud.</a:t>
             </a:r>
           </a:p>
         </p:txBody>

</xml_diff>